<commit_message>
Add business-insight layer: exec summary + cedentes/sacados; Codex output brief
- scripts/build_industria_fidc_deck.py: add Executive Summary slide (market
  doubled, independents dominate management, Itau 4-5x behind BTG/QI in
  administration, credit tied to payments) and Cedentes & Sacados slide/sheet
  (named parties by materiality from reports/fidc_clean_named_parties).
- reports/insights_industria_fidc.md: committee-ready market read (who grew/fell,
  Oliveira Trust/QI Tech/BTG stories, cedentes/sacados, Itau competitive gap).
- docs/brief_codex_output.md: brief to reorient Codex from empty infrastructure
  to business-insight output (lead with findings, materialize data not scaffolding,
  fill the thin cedente/sacado layer first).
</commit_message>
<xml_diff>
--- a/outputs/Industria_FIDC_2026-05.pptx
+++ b/outputs/Industria_FIDC_2026-05.pptx
@@ -20,6 +20,8 @@
     <p:sldId id="268" r:id="rId19"/>
     <p:sldId id="269" r:id="rId20"/>
     <p:sldId id="270" r:id="rId21"/>
+    <p:sldId id="271" r:id="rId22"/>
+    <p:sldId id="272" r:id="rId23"/>
   </p:sldIdLst>
   <p:sldSz cx="12191695" cy="6858000" type="screen4x3"/>
   <p:notesSz cx="6858000" cy="9144000"/>
@@ -6017,6 +6019,375 @@
                 </a:solidFill>
                 <a:latin typeface="Calibri"/>
               </a:rPr>
+              <a:t>INDEPENDENTES X BANCOS</a:t>
+            </a:r>
+          </a:p>
+        </p:txBody>
+      </p:sp>
+      <p:sp>
+        <p:nvSpPr>
+          <p:cNvPr id="5" name="TextBox 4"/>
+          <p:cNvSpPr txBox="1"/>
+          <p:nvPr/>
+        </p:nvSpPr>
+        <p:spPr>
+          <a:xfrm>
+            <a:off x="457200" y="365760"/>
+            <a:ext cx="11338560" cy="603504"/>
+          </a:xfrm>
+          <a:prstGeom prst="rect">
+            <a:avLst/>
+          </a:prstGeom>
+          <a:noFill/>
+        </p:spPr>
+        <p:txBody>
+          <a:bodyPr wrap="square" anchor="t">
+            <a:spAutoFit/>
+          </a:bodyPr>
+          <a:lstStyle/>
+          <a:p>
+            <a:pPr algn="l"/>
+            <a:r>
+              <a:rPr sz="2200" b="1">
+                <a:solidFill>
+                  <a:srgbClr val="FFFFFF"/>
+                </a:solidFill>
+                <a:latin typeface="Calibri"/>
+              </a:rPr>
+              <a:t>PL por tipo de controle do gestor — evolução (R$ bi)</a:t>
+            </a:r>
+          </a:p>
+        </p:txBody>
+      </p:sp>
+      <p:graphicFrame>
+        <p:nvGraphicFramePr>
+          <p:cNvPr id="6" name="Chart 5"/>
+          <p:cNvGraphicFramePr>
+            <a:graphicFrameLocks noGrp="1"/>
+          </p:cNvGraphicFramePr>
+          <p:nvPr/>
+        </p:nvGraphicFramePr>
+        <p:xfrm>
+          <a:off x="457200" y="1325880"/>
+          <a:ext cx="7955279" cy="4663440"/>
+        </p:xfrm>
+        <a:graphic>
+          <a:graphicData uri="http://schemas.openxmlformats.org/drawingml/2006/chart">
+            <c:chart xmlns:c="http://schemas.openxmlformats.org/drawingml/2006/chart" r:id="rId2"/>
+          </a:graphicData>
+        </a:graphic>
+      </p:graphicFrame>
+      <p:sp>
+        <p:nvSpPr>
+          <p:cNvPr id="7" name="TextBox 6"/>
+          <p:cNvSpPr txBox="1"/>
+          <p:nvPr/>
+        </p:nvSpPr>
+        <p:spPr>
+          <a:xfrm>
+            <a:off x="8686800" y="1737360"/>
+            <a:ext cx="3291840" cy="548640"/>
+          </a:xfrm>
+          <a:prstGeom prst="rect">
+            <a:avLst/>
+          </a:prstGeom>
+          <a:noFill/>
+        </p:spPr>
+        <p:txBody>
+          <a:bodyPr wrap="square" anchor="t">
+            <a:spAutoFit/>
+          </a:bodyPr>
+          <a:lstStyle/>
+          <a:p>
+            <a:pPr algn="l"/>
+            <a:r>
+              <a:rPr sz="1300" b="1">
+                <a:solidFill>
+                  <a:srgbClr val="E8703A"/>
+                </a:solidFill>
+                <a:latin typeface="Calibri"/>
+              </a:rPr>
+              <a:t>Independente: R$ 625 bi (65%)</a:t>
+            </a:r>
+          </a:p>
+        </p:txBody>
+      </p:sp>
+      <p:sp>
+        <p:nvSpPr>
+          <p:cNvPr id="8" name="TextBox 7"/>
+          <p:cNvSpPr txBox="1"/>
+          <p:nvPr/>
+        </p:nvSpPr>
+        <p:spPr>
+          <a:xfrm>
+            <a:off x="8686800" y="2377439"/>
+            <a:ext cx="3291840" cy="548640"/>
+          </a:xfrm>
+          <a:prstGeom prst="rect">
+            <a:avLst/>
+          </a:prstGeom>
+          <a:noFill/>
+        </p:spPr>
+        <p:txBody>
+          <a:bodyPr wrap="square" anchor="t">
+            <a:spAutoFit/>
+          </a:bodyPr>
+          <a:lstStyle/>
+          <a:p>
+            <a:pPr algn="l"/>
+            <a:r>
+              <a:rPr sz="1300" b="1">
+                <a:solidFill>
+                  <a:srgbClr val="1F2A44"/>
+                </a:solidFill>
+                <a:latin typeface="Calibri"/>
+              </a:rPr>
+              <a:t>Ligada a banco: R$ 252 bi (26%)</a:t>
+            </a:r>
+          </a:p>
+        </p:txBody>
+      </p:sp>
+      <p:sp>
+        <p:nvSpPr>
+          <p:cNvPr id="9" name="TextBox 8"/>
+          <p:cNvSpPr txBox="1"/>
+          <p:nvPr/>
+        </p:nvSpPr>
+        <p:spPr>
+          <a:xfrm>
+            <a:off x="8686800" y="3017520"/>
+            <a:ext cx="3291840" cy="548640"/>
+          </a:xfrm>
+          <a:prstGeom prst="rect">
+            <a:avLst/>
+          </a:prstGeom>
+          <a:noFill/>
+        </p:spPr>
+        <p:txBody>
+          <a:bodyPr wrap="square" anchor="t">
+            <a:spAutoFit/>
+          </a:bodyPr>
+          <a:lstStyle/>
+          <a:p>
+            <a:pPr algn="l"/>
+            <a:r>
+              <a:rPr sz="1300" b="1">
+                <a:solidFill>
+                  <a:srgbClr val="8A94A6"/>
+                </a:solidFill>
+                <a:latin typeface="Calibri"/>
+              </a:rPr>
+              <a:t>Independente Grande: R$ 81 bi (8%)</a:t>
+            </a:r>
+          </a:p>
+        </p:txBody>
+      </p:sp>
+      <p:sp>
+        <p:nvSpPr>
+          <p:cNvPr id="10" name="TextBox 9"/>
+          <p:cNvSpPr txBox="1"/>
+          <p:nvPr/>
+        </p:nvSpPr>
+        <p:spPr>
+          <a:xfrm>
+            <a:off x="8686800" y="3749039"/>
+            <a:ext cx="3383280" cy="1828800"/>
+          </a:xfrm>
+          <a:prstGeom prst="rect">
+            <a:avLst/>
+          </a:prstGeom>
+          <a:noFill/>
+        </p:spPr>
+        <p:txBody>
+          <a:bodyPr wrap="square" anchor="t">
+            <a:spAutoFit/>
+          </a:bodyPr>
+          <a:lstStyle/>
+          <a:p>
+            <a:pPr algn="l"/>
+            <a:r>
+              <a:rPr sz="1000" b="0">
+                <a:solidFill>
+                  <a:srgbClr val="8A94A6"/>
+                </a:solidFill>
+                <a:latin typeface="Calibri"/>
+              </a:rPr>
+              <a:t>Definição de controle conforme rodapé do deck Itaú BBA. 'Independente Grande' = Oliveira Trust, BRL Trust, BR Trust.</a:t>
+            </a:r>
+          </a:p>
+        </p:txBody>
+      </p:sp>
+      <p:sp>
+        <p:nvSpPr>
+          <p:cNvPr id="11" name="TextBox 10"/>
+          <p:cNvSpPr txBox="1"/>
+          <p:nvPr/>
+        </p:nvSpPr>
+        <p:spPr>
+          <a:xfrm>
+            <a:off x="457200" y="6400800"/>
+            <a:ext cx="11338560" cy="411480"/>
+          </a:xfrm>
+          <a:prstGeom prst="rect">
+            <a:avLst/>
+          </a:prstGeom>
+          <a:noFill/>
+        </p:spPr>
+        <p:txBody>
+          <a:bodyPr wrap="square" anchor="t">
+            <a:spAutoFit/>
+          </a:bodyPr>
+          <a:lstStyle/>
+          <a:p>
+            <a:pPr algn="l"/>
+            <a:r>
+              <a:rPr sz="800" b="0">
+                <a:solidFill>
+                  <a:srgbClr val="8A94A6"/>
+                </a:solidFill>
+                <a:latin typeface="Calibri"/>
+              </a:rPr>
+              <a:t>Fonte: Toma Conta FIDCs — dimensão 'gestor' + taxonomia de controle (Ligada a banco / Independente Grande / Independente; definição do rodapé do deck Itaú BBA).</a:t>
+            </a:r>
+          </a:p>
+        </p:txBody>
+      </p:sp>
+    </p:spTree>
+  </p:cSld>
+  <p:clrMapOvr>
+    <a:masterClrMapping/>
+  </p:clrMapOvr>
+</p:sld>
+</file>
+
+<file path=ppt/slides/slide11.xml><?xml version="1.0" encoding="utf-8"?>
+<p:sld xmlns:a="http://schemas.openxmlformats.org/drawingml/2006/main" xmlns:p="http://schemas.openxmlformats.org/presentationml/2006/main" xmlns:r="http://schemas.openxmlformats.org/officeDocument/2006/relationships">
+  <p:cSld>
+    <p:spTree>
+      <p:nvGrpSpPr>
+        <p:cNvPr id="1" name=""/>
+        <p:cNvGrpSpPr/>
+        <p:nvPr/>
+      </p:nvGrpSpPr>
+      <p:grpSpPr/>
+      <p:sp>
+        <p:nvSpPr>
+          <p:cNvPr id="2" name="Rectangle 1"/>
+          <p:cNvSpPr/>
+          <p:nvPr/>
+        </p:nvSpPr>
+        <p:spPr>
+          <a:xfrm>
+            <a:off x="0" y="0"/>
+            <a:ext cx="12191695" cy="1024128"/>
+          </a:xfrm>
+          <a:prstGeom prst="rect">
+            <a:avLst/>
+          </a:prstGeom>
+          <a:solidFill>
+            <a:srgbClr val="1F2A44"/>
+          </a:solidFill>
+          <a:ln>
+            <a:noFill/>
+          </a:ln>
+          <a:effectLst/>
+        </p:spPr>
+        <p:style>
+          <a:lnRef idx="1">
+            <a:schemeClr val="accent1"/>
+          </a:lnRef>
+          <a:fillRef idx="3">
+            <a:schemeClr val="accent1"/>
+          </a:fillRef>
+          <a:effectRef idx="2">
+            <a:schemeClr val="accent1"/>
+          </a:effectRef>
+          <a:fontRef idx="minor">
+            <a:schemeClr val="lt1"/>
+          </a:fontRef>
+        </p:style>
+        <p:txBody>
+          <a:bodyPr rtlCol="0" anchor="ctr"/>
+          <a:lstStyle/>
+          <a:p>
+            <a:pPr algn="ctr"/>
+          </a:p>
+        </p:txBody>
+      </p:sp>
+      <p:sp>
+        <p:nvSpPr>
+          <p:cNvPr id="3" name="Rectangle 2"/>
+          <p:cNvSpPr/>
+          <p:nvPr/>
+        </p:nvSpPr>
+        <p:spPr>
+          <a:xfrm>
+            <a:off x="0" y="1024128"/>
+            <a:ext cx="12191695" cy="45720"/>
+          </a:xfrm>
+          <a:prstGeom prst="rect">
+            <a:avLst/>
+          </a:prstGeom>
+          <a:solidFill>
+            <a:srgbClr val="E8703A"/>
+          </a:solidFill>
+          <a:ln>
+            <a:noFill/>
+          </a:ln>
+          <a:effectLst/>
+        </p:spPr>
+        <p:style>
+          <a:lnRef idx="1">
+            <a:schemeClr val="accent1"/>
+          </a:lnRef>
+          <a:fillRef idx="3">
+            <a:schemeClr val="accent1"/>
+          </a:fillRef>
+          <a:effectRef idx="2">
+            <a:schemeClr val="accent1"/>
+          </a:effectRef>
+          <a:fontRef idx="minor">
+            <a:schemeClr val="lt1"/>
+          </a:fontRef>
+        </p:style>
+        <p:txBody>
+          <a:bodyPr rtlCol="0" anchor="ctr"/>
+          <a:lstStyle/>
+          <a:p>
+            <a:pPr algn="ctr"/>
+          </a:p>
+        </p:txBody>
+      </p:sp>
+      <p:sp>
+        <p:nvSpPr>
+          <p:cNvPr id="4" name="TextBox 3"/>
+          <p:cNvSpPr txBox="1"/>
+          <p:nvPr/>
+        </p:nvSpPr>
+        <p:spPr>
+          <a:xfrm>
+            <a:off x="457200" y="118872"/>
+            <a:ext cx="10972800" cy="274320"/>
+          </a:xfrm>
+          <a:prstGeom prst="rect">
+            <a:avLst/>
+          </a:prstGeom>
+          <a:noFill/>
+        </p:spPr>
+        <p:txBody>
+          <a:bodyPr wrap="square" anchor="t">
+            <a:spAutoFit/>
+          </a:bodyPr>
+          <a:lstStyle/>
+          <a:p>
+            <a:pPr algn="l"/>
+            <a:r>
+              <a:rPr sz="1100" b="1">
+                <a:solidFill>
+                  <a:srgbClr val="F4A97F"/>
+                </a:solidFill>
+                <a:latin typeface="Calibri"/>
+              </a:rPr>
               <a:t>METODOLOGIA</a:t>
             </a:r>
           </a:p>
@@ -8196,7 +8567,7 @@
 </p:sld>
 </file>
 
-<file path=ppt/slides/slide11.xml><?xml version="1.0" encoding="utf-8"?>
+<file path=ppt/slides/slide12.xml><?xml version="1.0" encoding="utf-8"?>
 <p:sld xmlns:a="http://schemas.openxmlformats.org/drawingml/2006/main" xmlns:p="http://schemas.openxmlformats.org/presentationml/2006/main" xmlns:r="http://schemas.openxmlformats.org/officeDocument/2006/relationships">
   <p:cSld>
     <p:spTree>
@@ -12247,7 +12618,2447 @@
 </p:sld>
 </file>
 
-<file path=ppt/slides/slide12.xml><?xml version="1.0" encoding="utf-8"?>
+<file path=ppt/slides/slide13.xml><?xml version="1.0" encoding="utf-8"?>
+<p:sld xmlns:a="http://schemas.openxmlformats.org/drawingml/2006/main" xmlns:p="http://schemas.openxmlformats.org/presentationml/2006/main" xmlns:r="http://schemas.openxmlformats.org/officeDocument/2006/relationships">
+  <p:cSld>
+    <p:spTree>
+      <p:nvGrpSpPr>
+        <p:cNvPr id="1" name=""/>
+        <p:cNvGrpSpPr/>
+        <p:nvPr/>
+      </p:nvGrpSpPr>
+      <p:grpSpPr/>
+      <p:sp>
+        <p:nvSpPr>
+          <p:cNvPr id="2" name="Rectangle 1"/>
+          <p:cNvSpPr/>
+          <p:nvPr/>
+        </p:nvSpPr>
+        <p:spPr>
+          <a:xfrm>
+            <a:off x="0" y="0"/>
+            <a:ext cx="12191695" cy="1024128"/>
+          </a:xfrm>
+          <a:prstGeom prst="rect">
+            <a:avLst/>
+          </a:prstGeom>
+          <a:solidFill>
+            <a:srgbClr val="1F2A44"/>
+          </a:solidFill>
+          <a:ln>
+            <a:noFill/>
+          </a:ln>
+          <a:effectLst/>
+        </p:spPr>
+        <p:style>
+          <a:lnRef idx="1">
+            <a:schemeClr val="accent1"/>
+          </a:lnRef>
+          <a:fillRef idx="3">
+            <a:schemeClr val="accent1"/>
+          </a:fillRef>
+          <a:effectRef idx="2">
+            <a:schemeClr val="accent1"/>
+          </a:effectRef>
+          <a:fontRef idx="minor">
+            <a:schemeClr val="lt1"/>
+          </a:fontRef>
+        </p:style>
+        <p:txBody>
+          <a:bodyPr rtlCol="0" anchor="ctr"/>
+          <a:lstStyle/>
+          <a:p>
+            <a:pPr algn="ctr"/>
+          </a:p>
+        </p:txBody>
+      </p:sp>
+      <p:sp>
+        <p:nvSpPr>
+          <p:cNvPr id="3" name="Rectangle 2"/>
+          <p:cNvSpPr/>
+          <p:nvPr/>
+        </p:nvSpPr>
+        <p:spPr>
+          <a:xfrm>
+            <a:off x="0" y="1024128"/>
+            <a:ext cx="12191695" cy="45720"/>
+          </a:xfrm>
+          <a:prstGeom prst="rect">
+            <a:avLst/>
+          </a:prstGeom>
+          <a:solidFill>
+            <a:srgbClr val="E8703A"/>
+          </a:solidFill>
+          <a:ln>
+            <a:noFill/>
+          </a:ln>
+          <a:effectLst/>
+        </p:spPr>
+        <p:style>
+          <a:lnRef idx="1">
+            <a:schemeClr val="accent1"/>
+          </a:lnRef>
+          <a:fillRef idx="3">
+            <a:schemeClr val="accent1"/>
+          </a:fillRef>
+          <a:effectRef idx="2">
+            <a:schemeClr val="accent1"/>
+          </a:effectRef>
+          <a:fontRef idx="minor">
+            <a:schemeClr val="lt1"/>
+          </a:fontRef>
+        </p:style>
+        <p:txBody>
+          <a:bodyPr rtlCol="0" anchor="ctr"/>
+          <a:lstStyle/>
+          <a:p>
+            <a:pPr algn="ctr"/>
+          </a:p>
+        </p:txBody>
+      </p:sp>
+      <p:sp>
+        <p:nvSpPr>
+          <p:cNvPr id="4" name="TextBox 3"/>
+          <p:cNvSpPr txBox="1"/>
+          <p:nvPr/>
+        </p:nvSpPr>
+        <p:spPr>
+          <a:xfrm>
+            <a:off x="457200" y="118872"/>
+            <a:ext cx="10972800" cy="274320"/>
+          </a:xfrm>
+          <a:prstGeom prst="rect">
+            <a:avLst/>
+          </a:prstGeom>
+          <a:noFill/>
+        </p:spPr>
+        <p:txBody>
+          <a:bodyPr wrap="square" anchor="t">
+            <a:spAutoFit/>
+          </a:bodyPr>
+          <a:lstStyle/>
+          <a:p>
+            <a:pPr algn="l"/>
+            <a:r>
+              <a:rPr sz="1100" b="1">
+                <a:solidFill>
+                  <a:srgbClr val="F4A97F"/>
+                </a:solidFill>
+                <a:latin typeface="Calibri"/>
+              </a:rPr>
+              <a:t>ORIGINAÇÃO E RISCO</a:t>
+            </a:r>
+          </a:p>
+        </p:txBody>
+      </p:sp>
+      <p:sp>
+        <p:nvSpPr>
+          <p:cNvPr id="5" name="TextBox 4"/>
+          <p:cNvSpPr txBox="1"/>
+          <p:nvPr/>
+        </p:nvSpPr>
+        <p:spPr>
+          <a:xfrm>
+            <a:off x="457200" y="365760"/>
+            <a:ext cx="11338560" cy="603504"/>
+          </a:xfrm>
+          <a:prstGeom prst="rect">
+            <a:avLst/>
+          </a:prstGeom>
+          <a:noFill/>
+        </p:spPr>
+        <p:txBody>
+          <a:bodyPr wrap="square" anchor="t">
+            <a:spAutoFit/>
+          </a:bodyPr>
+          <a:lstStyle/>
+          <a:p>
+            <a:pPr algn="l"/>
+            <a:r>
+              <a:rPr sz="2200" b="1">
+                <a:solidFill>
+                  <a:srgbClr val="FFFFFF"/>
+                </a:solidFill>
+                <a:latin typeface="Calibri"/>
+              </a:rPr>
+              <a:t>Cedentes e sacados relevantes (leitura de regulamentos)</a:t>
+            </a:r>
+          </a:p>
+        </p:txBody>
+      </p:sp>
+      <p:sp>
+        <p:nvSpPr>
+          <p:cNvPr id="6" name="TextBox 5"/>
+          <p:cNvSpPr txBox="1"/>
+          <p:nvPr/>
+        </p:nvSpPr>
+        <p:spPr>
+          <a:xfrm>
+            <a:off x="457200" y="1143000"/>
+            <a:ext cx="5486400" cy="274320"/>
+          </a:xfrm>
+          <a:prstGeom prst="rect">
+            <a:avLst/>
+          </a:prstGeom>
+          <a:noFill/>
+        </p:spPr>
+        <p:txBody>
+          <a:bodyPr wrap="square" anchor="t">
+            <a:spAutoFit/>
+          </a:bodyPr>
+          <a:lstStyle/>
+          <a:p>
+            <a:pPr algn="l"/>
+            <a:r>
+              <a:rPr sz="1300" b="1">
+                <a:solidFill>
+                  <a:srgbClr val="1F2A44"/>
+                </a:solidFill>
+                <a:latin typeface="Calibri"/>
+              </a:rPr>
+              <a:t>Maiores CEDENTES (originadores)</a:t>
+            </a:r>
+          </a:p>
+        </p:txBody>
+      </p:sp>
+      <p:sp>
+        <p:nvSpPr>
+          <p:cNvPr id="7" name="TextBox 6"/>
+          <p:cNvSpPr txBox="1"/>
+          <p:nvPr/>
+        </p:nvSpPr>
+        <p:spPr>
+          <a:xfrm>
+            <a:off x="6309360" y="1143000"/>
+            <a:ext cx="5486400" cy="274320"/>
+          </a:xfrm>
+          <a:prstGeom prst="rect">
+            <a:avLst/>
+          </a:prstGeom>
+          <a:noFill/>
+        </p:spPr>
+        <p:txBody>
+          <a:bodyPr wrap="square" anchor="t">
+            <a:spAutoFit/>
+          </a:bodyPr>
+          <a:lstStyle/>
+          <a:p>
+            <a:pPr algn="l"/>
+            <a:r>
+              <a:rPr sz="1300" b="1">
+                <a:solidFill>
+                  <a:srgbClr val="1F2A44"/>
+                </a:solidFill>
+                <a:latin typeface="Calibri"/>
+              </a:rPr>
+              <a:t>Maiores SACADOS (devedores)</a:t>
+            </a:r>
+          </a:p>
+        </p:txBody>
+      </p:sp>
+      <p:graphicFrame>
+        <p:nvGraphicFramePr>
+          <p:cNvPr id="8" name="Table 7"/>
+          <p:cNvGraphicFramePr>
+            <a:graphicFrameLocks noGrp="1"/>
+          </p:cNvGraphicFramePr>
+          <p:nvPr/>
+        </p:nvGraphicFramePr>
+        <p:xfrm>
+          <a:off x="365760" y="1463040"/>
+          <a:ext cx="5760719" cy="4206240"/>
+        </p:xfrm>
+        <a:graphic>
+          <a:graphicData uri="http://schemas.openxmlformats.org/drawingml/2006/table">
+            <a:tbl>
+              <a:tblPr firstRow="1" bandRow="1">
+                <a:tableStyleId>{5C22544A-7EE6-4342-B048-85BDC9FD1C3A}</a:tableStyleId>
+              </a:tblPr>
+              <a:tblGrid>
+                <a:gridCol w="2633472"/>
+                <a:gridCol w="1563624"/>
+                <a:gridCol w="576071"/>
+                <a:gridCol w="987552"/>
+              </a:tblGrid>
+              <a:tr h="382385">
+                <a:tc>
+                  <a:txBody>
+                    <a:bodyPr/>
+                    <a:lstStyle/>
+                    <a:p>
+                      <a:pPr algn="ctr"/>
+                      <a:r>
+                        <a:rPr sz="850" b="1">
+                          <a:solidFill>
+                            <a:srgbClr val="FFFFFF"/>
+                          </a:solidFill>
+                          <a:latin typeface="Calibri"/>
+                        </a:rPr>
+                        <a:t>Parte</a:t>
+                      </a:r>
+                    </a:p>
+                  </a:txBody>
+                  <a:tcPr anchor="ctr" marT="9144" marB="9144">
+                    <a:solidFill>
+                      <a:srgbClr val="1F2A44"/>
+                    </a:solidFill>
+                  </a:tcPr>
+                </a:tc>
+                <a:tc>
+                  <a:txBody>
+                    <a:bodyPr/>
+                    <a:lstStyle/>
+                    <a:p>
+                      <a:pPr algn="ctr"/>
+                      <a:r>
+                        <a:rPr sz="850" b="1">
+                          <a:solidFill>
+                            <a:srgbClr val="FFFFFF"/>
+                          </a:solidFill>
+                          <a:latin typeface="Calibri"/>
+                        </a:rPr>
+                        <a:t>Setor</a:t>
+                      </a:r>
+                    </a:p>
+                  </a:txBody>
+                  <a:tcPr anchor="ctr" marT="9144" marB="9144">
+                    <a:solidFill>
+                      <a:srgbClr val="1F2A44"/>
+                    </a:solidFill>
+                  </a:tcPr>
+                </a:tc>
+                <a:tc>
+                  <a:txBody>
+                    <a:bodyPr/>
+                    <a:lstStyle/>
+                    <a:p>
+                      <a:pPr algn="ctr"/>
+                      <a:r>
+                        <a:rPr sz="850" b="1">
+                          <a:solidFill>
+                            <a:srgbClr val="FFFFFF"/>
+                          </a:solidFill>
+                          <a:latin typeface="Calibri"/>
+                        </a:rPr>
+                        <a:t># Fundos</a:t>
+                      </a:r>
+                    </a:p>
+                  </a:txBody>
+                  <a:tcPr anchor="ctr" marT="9144" marB="9144">
+                    <a:solidFill>
+                      <a:srgbClr val="1F2A44"/>
+                    </a:solidFill>
+                  </a:tcPr>
+                </a:tc>
+                <a:tc>
+                  <a:txBody>
+                    <a:bodyPr/>
+                    <a:lstStyle/>
+                    <a:p>
+                      <a:pPr algn="ctr"/>
+                      <a:r>
+                        <a:rPr sz="850" b="1">
+                          <a:solidFill>
+                            <a:srgbClr val="FFFFFF"/>
+                          </a:solidFill>
+                          <a:latin typeface="Calibri"/>
+                        </a:rPr>
+                        <a:t>Materialidade (R$ bi)</a:t>
+                      </a:r>
+                    </a:p>
+                  </a:txBody>
+                  <a:tcPr anchor="ctr" marT="9144" marB="9144">
+                    <a:solidFill>
+                      <a:srgbClr val="1F2A44"/>
+                    </a:solidFill>
+                  </a:tcPr>
+                </a:tc>
+              </a:tr>
+              <a:tr h="382385">
+                <a:tc>
+                  <a:txBody>
+                    <a:bodyPr/>
+                    <a:lstStyle/>
+                    <a:p>
+                      <a:pPr algn="l"/>
+                      <a:r>
+                        <a:rPr sz="850">
+                          <a:solidFill>
+                            <a:srgbClr val="1A1A1A"/>
+                          </a:solidFill>
+                          <a:latin typeface="Calibri"/>
+                        </a:rPr>
+                        <a:t>Banco BTG Pactual S.A</a:t>
+                      </a:r>
+                    </a:p>
+                  </a:txBody>
+                  <a:tcPr anchor="ctr" marT="4572" marB="4572">
+                    <a:solidFill>
+                      <a:srgbClr val="F3F5F8"/>
+                    </a:solidFill>
+                  </a:tcPr>
+                </a:tc>
+                <a:tc>
+                  <a:txBody>
+                    <a:bodyPr/>
+                    <a:lstStyle/>
+                    <a:p>
+                      <a:pPr algn="l"/>
+                      <a:r>
+                        <a:rPr sz="850">
+                          <a:solidFill>
+                            <a:srgbClr val="1A1A1A"/>
+                          </a:solidFill>
+                          <a:latin typeface="Calibri"/>
+                        </a:rPr>
+                        <a:t>Meios de Pagamento</a:t>
+                      </a:r>
+                    </a:p>
+                  </a:txBody>
+                  <a:tcPr anchor="ctr" marT="4572" marB="4572">
+                    <a:solidFill>
+                      <a:srgbClr val="F3F5F8"/>
+                    </a:solidFill>
+                  </a:tcPr>
+                </a:tc>
+                <a:tc>
+                  <a:txBody>
+                    <a:bodyPr/>
+                    <a:lstStyle/>
+                    <a:p>
+                      <a:pPr algn="ctr"/>
+                      <a:r>
+                        <a:rPr sz="850">
+                          <a:solidFill>
+                            <a:srgbClr val="1A1A1A"/>
+                          </a:solidFill>
+                          <a:latin typeface="Calibri"/>
+                        </a:rPr>
+                        <a:t>3</a:t>
+                      </a:r>
+                    </a:p>
+                  </a:txBody>
+                  <a:tcPr anchor="ctr" marT="4572" marB="4572">
+                    <a:solidFill>
+                      <a:srgbClr val="F3F5F8"/>
+                    </a:solidFill>
+                  </a:tcPr>
+                </a:tc>
+                <a:tc>
+                  <a:txBody>
+                    <a:bodyPr/>
+                    <a:lstStyle/>
+                    <a:p>
+                      <a:pPr algn="ctr"/>
+                      <a:r>
+                        <a:rPr sz="850">
+                          <a:solidFill>
+                            <a:srgbClr val="1A1A1A"/>
+                          </a:solidFill>
+                          <a:latin typeface="Calibri"/>
+                        </a:rPr>
+                        <a:t>15.92</a:t>
+                      </a:r>
+                    </a:p>
+                  </a:txBody>
+                  <a:tcPr anchor="ctr" marT="4572" marB="4572">
+                    <a:solidFill>
+                      <a:srgbClr val="F3F5F8"/>
+                    </a:solidFill>
+                  </a:tcPr>
+                </a:tc>
+              </a:tr>
+              <a:tr h="382385">
+                <a:tc>
+                  <a:txBody>
+                    <a:bodyPr/>
+                    <a:lstStyle/>
+                    <a:p>
+                      <a:pPr algn="l"/>
+                      <a:r>
+                        <a:rPr sz="850">
+                          <a:solidFill>
+                            <a:srgbClr val="1A1A1A"/>
+                          </a:solidFill>
+                          <a:latin typeface="Calibri"/>
+                        </a:rPr>
+                        <a:t>MULTIPLIKE CONSULTORIA E COBRA</a:t>
+                      </a:r>
+                    </a:p>
+                  </a:txBody>
+                  <a:tcPr anchor="ctr" marT="4572" marB="4572">
+                    <a:solidFill>
+                      <a:srgbClr val="FFFFFF"/>
+                    </a:solidFill>
+                  </a:tcPr>
+                </a:tc>
+                <a:tc>
+                  <a:txBody>
+                    <a:bodyPr/>
+                    <a:lstStyle/>
+                    <a:p>
+                      <a:pPr algn="l"/>
+                      <a:r>
+                        <a:rPr sz="850">
+                          <a:solidFill>
+                            <a:srgbClr val="1A1A1A"/>
+                          </a:solidFill>
+                          <a:latin typeface="Calibri"/>
+                        </a:rPr>
+                        <a:t>Crédito PJ</a:t>
+                      </a:r>
+                    </a:p>
+                  </a:txBody>
+                  <a:tcPr anchor="ctr" marT="4572" marB="4572">
+                    <a:solidFill>
+                      <a:srgbClr val="FFFFFF"/>
+                    </a:solidFill>
+                  </a:tcPr>
+                </a:tc>
+                <a:tc>
+                  <a:txBody>
+                    <a:bodyPr/>
+                    <a:lstStyle/>
+                    <a:p>
+                      <a:pPr algn="ctr"/>
+                      <a:r>
+                        <a:rPr sz="850">
+                          <a:solidFill>
+                            <a:srgbClr val="1A1A1A"/>
+                          </a:solidFill>
+                          <a:latin typeface="Calibri"/>
+                        </a:rPr>
+                        <a:t>1</a:t>
+                      </a:r>
+                    </a:p>
+                  </a:txBody>
+                  <a:tcPr anchor="ctr" marT="4572" marB="4572">
+                    <a:solidFill>
+                      <a:srgbClr val="FFFFFF"/>
+                    </a:solidFill>
+                  </a:tcPr>
+                </a:tc>
+                <a:tc>
+                  <a:txBody>
+                    <a:bodyPr/>
+                    <a:lstStyle/>
+                    <a:p>
+                      <a:pPr algn="ctr"/>
+                      <a:r>
+                        <a:rPr sz="850">
+                          <a:solidFill>
+                            <a:srgbClr val="1A1A1A"/>
+                          </a:solidFill>
+                          <a:latin typeface="Calibri"/>
+                        </a:rPr>
+                        <a:t>2.20</a:t>
+                      </a:r>
+                    </a:p>
+                  </a:txBody>
+                  <a:tcPr anchor="ctr" marT="4572" marB="4572">
+                    <a:solidFill>
+                      <a:srgbClr val="FFFFFF"/>
+                    </a:solidFill>
+                  </a:tcPr>
+                </a:tc>
+              </a:tr>
+              <a:tr h="382385">
+                <a:tc>
+                  <a:txBody>
+                    <a:bodyPr/>
+                    <a:lstStyle/>
+                    <a:p>
+                      <a:pPr algn="l"/>
+                      <a:r>
+                        <a:rPr sz="850">
+                          <a:solidFill>
+                            <a:srgbClr val="1A1A1A"/>
+                          </a:solidFill>
+                          <a:latin typeface="Calibri"/>
+                        </a:rPr>
+                        <a:t>PagueVeloz Instituição de Paga</a:t>
+                      </a:r>
+                    </a:p>
+                  </a:txBody>
+                  <a:tcPr anchor="ctr" marT="4572" marB="4572">
+                    <a:solidFill>
+                      <a:srgbClr val="F3F5F8"/>
+                    </a:solidFill>
+                  </a:tcPr>
+                </a:tc>
+                <a:tc>
+                  <a:txBody>
+                    <a:bodyPr/>
+                    <a:lstStyle/>
+                    <a:p>
+                      <a:pPr algn="l"/>
+                      <a:r>
+                        <a:rPr sz="850">
+                          <a:solidFill>
+                            <a:srgbClr val="1A1A1A"/>
+                          </a:solidFill>
+                          <a:latin typeface="Calibri"/>
+                        </a:rPr>
+                        <a:t>Sem oferta CVM map</a:t>
+                      </a:r>
+                    </a:p>
+                  </a:txBody>
+                  <a:tcPr anchor="ctr" marT="4572" marB="4572">
+                    <a:solidFill>
+                      <a:srgbClr val="F3F5F8"/>
+                    </a:solidFill>
+                  </a:tcPr>
+                </a:tc>
+                <a:tc>
+                  <a:txBody>
+                    <a:bodyPr/>
+                    <a:lstStyle/>
+                    <a:p>
+                      <a:pPr algn="ctr"/>
+                      <a:r>
+                        <a:rPr sz="850">
+                          <a:solidFill>
+                            <a:srgbClr val="1A1A1A"/>
+                          </a:solidFill>
+                          <a:latin typeface="Calibri"/>
+                        </a:rPr>
+                        <a:t>1</a:t>
+                      </a:r>
+                    </a:p>
+                  </a:txBody>
+                  <a:tcPr anchor="ctr" marT="4572" marB="4572">
+                    <a:solidFill>
+                      <a:srgbClr val="F3F5F8"/>
+                    </a:solidFill>
+                  </a:tcPr>
+                </a:tc>
+                <a:tc>
+                  <a:txBody>
+                    <a:bodyPr/>
+                    <a:lstStyle/>
+                    <a:p>
+                      <a:pPr algn="ctr"/>
+                      <a:r>
+                        <a:rPr sz="850">
+                          <a:solidFill>
+                            <a:srgbClr val="1A1A1A"/>
+                          </a:solidFill>
+                          <a:latin typeface="Calibri"/>
+                        </a:rPr>
+                        <a:t>2.01</a:t>
+                      </a:r>
+                    </a:p>
+                  </a:txBody>
+                  <a:tcPr anchor="ctr" marT="4572" marB="4572">
+                    <a:solidFill>
+                      <a:srgbClr val="F3F5F8"/>
+                    </a:solidFill>
+                  </a:tcPr>
+                </a:tc>
+              </a:tr>
+              <a:tr h="382385">
+                <a:tc>
+                  <a:txBody>
+                    <a:bodyPr/>
+                    <a:lstStyle/>
+                    <a:p>
+                      <a:pPr algn="l"/>
+                      <a:r>
+                        <a:rPr sz="850">
+                          <a:solidFill>
+                            <a:srgbClr val="1A1A1A"/>
+                          </a:solidFill>
+                          <a:latin typeface="Calibri"/>
+                        </a:rPr>
+                        <a:t>Banco Bradesco S.A</a:t>
+                      </a:r>
+                    </a:p>
+                  </a:txBody>
+                  <a:tcPr anchor="ctr" marT="4572" marB="4572">
+                    <a:solidFill>
+                      <a:srgbClr val="FFFFFF"/>
+                    </a:solidFill>
+                  </a:tcPr>
+                </a:tc>
+                <a:tc>
+                  <a:txBody>
+                    <a:bodyPr/>
+                    <a:lstStyle/>
+                    <a:p>
+                      <a:pPr algn="l"/>
+                      <a:r>
+                        <a:rPr sz="850">
+                          <a:solidFill>
+                            <a:srgbClr val="1A1A1A"/>
+                          </a:solidFill>
+                          <a:latin typeface="Calibri"/>
+                        </a:rPr>
+                        <a:t>Meios de Pagamento</a:t>
+                      </a:r>
+                    </a:p>
+                  </a:txBody>
+                  <a:tcPr anchor="ctr" marT="4572" marB="4572">
+                    <a:solidFill>
+                      <a:srgbClr val="FFFFFF"/>
+                    </a:solidFill>
+                  </a:tcPr>
+                </a:tc>
+                <a:tc>
+                  <a:txBody>
+                    <a:bodyPr/>
+                    <a:lstStyle/>
+                    <a:p>
+                      <a:pPr algn="ctr"/>
+                      <a:r>
+                        <a:rPr sz="850">
+                          <a:solidFill>
+                            <a:srgbClr val="1A1A1A"/>
+                          </a:solidFill>
+                          <a:latin typeface="Calibri"/>
+                        </a:rPr>
+                        <a:t>4</a:t>
+                      </a:r>
+                    </a:p>
+                  </a:txBody>
+                  <a:tcPr anchor="ctr" marT="4572" marB="4572">
+                    <a:solidFill>
+                      <a:srgbClr val="FFFFFF"/>
+                    </a:solidFill>
+                  </a:tcPr>
+                </a:tc>
+                <a:tc>
+                  <a:txBody>
+                    <a:bodyPr/>
+                    <a:lstStyle/>
+                    <a:p>
+                      <a:pPr algn="ctr"/>
+                      <a:r>
+                        <a:rPr sz="850">
+                          <a:solidFill>
+                            <a:srgbClr val="1A1A1A"/>
+                          </a:solidFill>
+                          <a:latin typeface="Calibri"/>
+                        </a:rPr>
+                        <a:t>1.67</a:t>
+                      </a:r>
+                    </a:p>
+                  </a:txBody>
+                  <a:tcPr anchor="ctr" marT="4572" marB="4572">
+                    <a:solidFill>
+                      <a:srgbClr val="FFFFFF"/>
+                    </a:solidFill>
+                  </a:tcPr>
+                </a:tc>
+              </a:tr>
+              <a:tr h="382385">
+                <a:tc>
+                  <a:txBody>
+                    <a:bodyPr/>
+                    <a:lstStyle/>
+                    <a:p>
+                      <a:pPr algn="l"/>
+                      <a:r>
+                        <a:rPr sz="850">
+                          <a:solidFill>
+                            <a:srgbClr val="1A1A1A"/>
+                          </a:solidFill>
+                          <a:latin typeface="Calibri"/>
+                        </a:rPr>
+                        <a:t>Banco BMG S.A</a:t>
+                      </a:r>
+                    </a:p>
+                  </a:txBody>
+                  <a:tcPr anchor="ctr" marT="4572" marB="4572">
+                    <a:solidFill>
+                      <a:srgbClr val="F3F5F8"/>
+                    </a:solidFill>
+                  </a:tcPr>
+                </a:tc>
+                <a:tc>
+                  <a:txBody>
+                    <a:bodyPr/>
+                    <a:lstStyle/>
+                    <a:p>
+                      <a:pPr algn="l"/>
+                      <a:r>
+                        <a:rPr sz="850">
+                          <a:solidFill>
+                            <a:srgbClr val="1A1A1A"/>
+                          </a:solidFill>
+                          <a:latin typeface="Calibri"/>
+                        </a:rPr>
+                        <a:t>Crédito PF</a:t>
+                      </a:r>
+                    </a:p>
+                  </a:txBody>
+                  <a:tcPr anchor="ctr" marT="4572" marB="4572">
+                    <a:solidFill>
+                      <a:srgbClr val="F3F5F8"/>
+                    </a:solidFill>
+                  </a:tcPr>
+                </a:tc>
+                <a:tc>
+                  <a:txBody>
+                    <a:bodyPr/>
+                    <a:lstStyle/>
+                    <a:p>
+                      <a:pPr algn="ctr"/>
+                      <a:r>
+                        <a:rPr sz="850">
+                          <a:solidFill>
+                            <a:srgbClr val="1A1A1A"/>
+                          </a:solidFill>
+                          <a:latin typeface="Calibri"/>
+                        </a:rPr>
+                        <a:t>1</a:t>
+                      </a:r>
+                    </a:p>
+                  </a:txBody>
+                  <a:tcPr anchor="ctr" marT="4572" marB="4572">
+                    <a:solidFill>
+                      <a:srgbClr val="F3F5F8"/>
+                    </a:solidFill>
+                  </a:tcPr>
+                </a:tc>
+                <a:tc>
+                  <a:txBody>
+                    <a:bodyPr/>
+                    <a:lstStyle/>
+                    <a:p>
+                      <a:pPr algn="ctr"/>
+                      <a:r>
+                        <a:rPr sz="850">
+                          <a:solidFill>
+                            <a:srgbClr val="1A1A1A"/>
+                          </a:solidFill>
+                          <a:latin typeface="Calibri"/>
+                        </a:rPr>
+                        <a:t>1.52</a:t>
+                      </a:r>
+                    </a:p>
+                  </a:txBody>
+                  <a:tcPr anchor="ctr" marT="4572" marB="4572">
+                    <a:solidFill>
+                      <a:srgbClr val="F3F5F8"/>
+                    </a:solidFill>
+                  </a:tcPr>
+                </a:tc>
+              </a:tr>
+              <a:tr h="382385">
+                <a:tc>
+                  <a:txBody>
+                    <a:bodyPr/>
+                    <a:lstStyle/>
+                    <a:p>
+                      <a:pPr algn="l"/>
+                      <a:r>
+                        <a:rPr sz="850">
+                          <a:solidFill>
+                            <a:srgbClr val="1A1A1A"/>
+                          </a:solidFill>
+                          <a:latin typeface="Calibri"/>
+                        </a:rPr>
+                        <a:t>BRB - BANCO DE BRASÍLIA S.A</a:t>
+                      </a:r>
+                    </a:p>
+                  </a:txBody>
+                  <a:tcPr anchor="ctr" marT="4572" marB="4572">
+                    <a:solidFill>
+                      <a:srgbClr val="FFFFFF"/>
+                    </a:solidFill>
+                  </a:tcPr>
+                </a:tc>
+                <a:tc>
+                  <a:txBody>
+                    <a:bodyPr/>
+                    <a:lstStyle/>
+                    <a:p>
+                      <a:pPr algn="l"/>
+                      <a:r>
+                        <a:rPr sz="850">
+                          <a:solidFill>
+                            <a:srgbClr val="1A1A1A"/>
+                          </a:solidFill>
+                          <a:latin typeface="Calibri"/>
+                        </a:rPr>
+                        <a:t>Crédito PF</a:t>
+                      </a:r>
+                    </a:p>
+                  </a:txBody>
+                  <a:tcPr anchor="ctr" marT="4572" marB="4572">
+                    <a:solidFill>
+                      <a:srgbClr val="FFFFFF"/>
+                    </a:solidFill>
+                  </a:tcPr>
+                </a:tc>
+                <a:tc>
+                  <a:txBody>
+                    <a:bodyPr/>
+                    <a:lstStyle/>
+                    <a:p>
+                      <a:pPr algn="ctr"/>
+                      <a:r>
+                        <a:rPr sz="850">
+                          <a:solidFill>
+                            <a:srgbClr val="1A1A1A"/>
+                          </a:solidFill>
+                          <a:latin typeface="Calibri"/>
+                        </a:rPr>
+                        <a:t>1</a:t>
+                      </a:r>
+                    </a:p>
+                  </a:txBody>
+                  <a:tcPr anchor="ctr" marT="4572" marB="4572">
+                    <a:solidFill>
+                      <a:srgbClr val="FFFFFF"/>
+                    </a:solidFill>
+                  </a:tcPr>
+                </a:tc>
+                <a:tc>
+                  <a:txBody>
+                    <a:bodyPr/>
+                    <a:lstStyle/>
+                    <a:p>
+                      <a:pPr algn="ctr"/>
+                      <a:r>
+                        <a:rPr sz="850">
+                          <a:solidFill>
+                            <a:srgbClr val="1A1A1A"/>
+                          </a:solidFill>
+                          <a:latin typeface="Calibri"/>
+                        </a:rPr>
+                        <a:t>1.42</a:t>
+                      </a:r>
+                    </a:p>
+                  </a:txBody>
+                  <a:tcPr anchor="ctr" marT="4572" marB="4572">
+                    <a:solidFill>
+                      <a:srgbClr val="FFFFFF"/>
+                    </a:solidFill>
+                  </a:tcPr>
+                </a:tc>
+              </a:tr>
+              <a:tr h="382385">
+                <a:tc>
+                  <a:txBody>
+                    <a:bodyPr/>
+                    <a:lstStyle/>
+                    <a:p>
+                      <a:pPr algn="l"/>
+                      <a:r>
+                        <a:rPr sz="850">
+                          <a:solidFill>
+                            <a:srgbClr val="1A1A1A"/>
+                          </a:solidFill>
+                          <a:latin typeface="Calibri"/>
+                        </a:rPr>
+                        <a:t>UPL DO BRASIL INDÚSTRIA E COMÉ</a:t>
+                      </a:r>
+                    </a:p>
+                  </a:txBody>
+                  <a:tcPr anchor="ctr" marT="4572" marB="4572">
+                    <a:solidFill>
+                      <a:srgbClr val="F3F5F8"/>
+                    </a:solidFill>
+                  </a:tcPr>
+                </a:tc>
+                <a:tc>
+                  <a:txBody>
+                    <a:bodyPr/>
+                    <a:lstStyle/>
+                    <a:p>
+                      <a:pPr algn="l"/>
+                      <a:r>
+                        <a:rPr sz="850">
+                          <a:solidFill>
+                            <a:srgbClr val="1A1A1A"/>
+                          </a:solidFill>
+                          <a:latin typeface="Calibri"/>
+                        </a:rPr>
+                        <a:t>Agro</a:t>
+                      </a:r>
+                    </a:p>
+                  </a:txBody>
+                  <a:tcPr anchor="ctr" marT="4572" marB="4572">
+                    <a:solidFill>
+                      <a:srgbClr val="F3F5F8"/>
+                    </a:solidFill>
+                  </a:tcPr>
+                </a:tc>
+                <a:tc>
+                  <a:txBody>
+                    <a:bodyPr/>
+                    <a:lstStyle/>
+                    <a:p>
+                      <a:pPr algn="ctr"/>
+                      <a:r>
+                        <a:rPr sz="850">
+                          <a:solidFill>
+                            <a:srgbClr val="1A1A1A"/>
+                          </a:solidFill>
+                          <a:latin typeface="Calibri"/>
+                        </a:rPr>
+                        <a:t>1</a:t>
+                      </a:r>
+                    </a:p>
+                  </a:txBody>
+                  <a:tcPr anchor="ctr" marT="4572" marB="4572">
+                    <a:solidFill>
+                      <a:srgbClr val="F3F5F8"/>
+                    </a:solidFill>
+                  </a:tcPr>
+                </a:tc>
+                <a:tc>
+                  <a:txBody>
+                    <a:bodyPr/>
+                    <a:lstStyle/>
+                    <a:p>
+                      <a:pPr algn="ctr"/>
+                      <a:r>
+                        <a:rPr sz="850">
+                          <a:solidFill>
+                            <a:srgbClr val="1A1A1A"/>
+                          </a:solidFill>
+                          <a:latin typeface="Calibri"/>
+                        </a:rPr>
+                        <a:t>0.94</a:t>
+                      </a:r>
+                    </a:p>
+                  </a:txBody>
+                  <a:tcPr anchor="ctr" marT="4572" marB="4572">
+                    <a:solidFill>
+                      <a:srgbClr val="F3F5F8"/>
+                    </a:solidFill>
+                  </a:tcPr>
+                </a:tc>
+              </a:tr>
+              <a:tr h="382385">
+                <a:tc>
+                  <a:txBody>
+                    <a:bodyPr/>
+                    <a:lstStyle/>
+                    <a:p>
+                      <a:pPr algn="l"/>
+                      <a:r>
+                        <a:rPr sz="850">
+                          <a:solidFill>
+                            <a:srgbClr val="1A1A1A"/>
+                          </a:solidFill>
+                          <a:latin typeface="Calibri"/>
+                        </a:rPr>
+                        <a:t>Banco Votorantim S.A</a:t>
+                      </a:r>
+                    </a:p>
+                  </a:txBody>
+                  <a:tcPr anchor="ctr" marT="4572" marB="4572">
+                    <a:solidFill>
+                      <a:srgbClr val="FFFFFF"/>
+                    </a:solidFill>
+                  </a:tcPr>
+                </a:tc>
+                <a:tc>
+                  <a:txBody>
+                    <a:bodyPr/>
+                    <a:lstStyle/>
+                    <a:p>
+                      <a:pPr algn="l"/>
+                      <a:r>
+                        <a:rPr sz="850">
+                          <a:solidFill>
+                            <a:srgbClr val="1A1A1A"/>
+                          </a:solidFill>
+                          <a:latin typeface="Calibri"/>
+                        </a:rPr>
+                        <a:t>Sem oferta CVM map</a:t>
+                      </a:r>
+                    </a:p>
+                  </a:txBody>
+                  <a:tcPr anchor="ctr" marT="4572" marB="4572">
+                    <a:solidFill>
+                      <a:srgbClr val="FFFFFF"/>
+                    </a:solidFill>
+                  </a:tcPr>
+                </a:tc>
+                <a:tc>
+                  <a:txBody>
+                    <a:bodyPr/>
+                    <a:lstStyle/>
+                    <a:p>
+                      <a:pPr algn="ctr"/>
+                      <a:r>
+                        <a:rPr sz="850">
+                          <a:solidFill>
+                            <a:srgbClr val="1A1A1A"/>
+                          </a:solidFill>
+                          <a:latin typeface="Calibri"/>
+                        </a:rPr>
+                        <a:t>1</a:t>
+                      </a:r>
+                    </a:p>
+                  </a:txBody>
+                  <a:tcPr anchor="ctr" marT="4572" marB="4572">
+                    <a:solidFill>
+                      <a:srgbClr val="FFFFFF"/>
+                    </a:solidFill>
+                  </a:tcPr>
+                </a:tc>
+                <a:tc>
+                  <a:txBody>
+                    <a:bodyPr/>
+                    <a:lstStyle/>
+                    <a:p>
+                      <a:pPr algn="ctr"/>
+                      <a:r>
+                        <a:rPr sz="850">
+                          <a:solidFill>
+                            <a:srgbClr val="1A1A1A"/>
+                          </a:solidFill>
+                          <a:latin typeface="Calibri"/>
+                        </a:rPr>
+                        <a:t>0.91</a:t>
+                      </a:r>
+                    </a:p>
+                  </a:txBody>
+                  <a:tcPr anchor="ctr" marT="4572" marB="4572">
+                    <a:solidFill>
+                      <a:srgbClr val="FFFFFF"/>
+                    </a:solidFill>
+                  </a:tcPr>
+                </a:tc>
+              </a:tr>
+              <a:tr h="382385">
+                <a:tc>
+                  <a:txBody>
+                    <a:bodyPr/>
+                    <a:lstStyle/>
+                    <a:p>
+                      <a:pPr algn="l"/>
+                      <a:r>
+                        <a:rPr sz="850">
+                          <a:solidFill>
+                            <a:srgbClr val="1A1A1A"/>
+                          </a:solidFill>
+                          <a:latin typeface="Calibri"/>
+                        </a:rPr>
+                        <a:t>Serviços Técnicos de Seguro Lt</a:t>
+                      </a:r>
+                    </a:p>
+                  </a:txBody>
+                  <a:tcPr anchor="ctr" marT="4572" marB="4572">
+                    <a:solidFill>
+                      <a:srgbClr val="F3F5F8"/>
+                    </a:solidFill>
+                  </a:tcPr>
+                </a:tc>
+                <a:tc>
+                  <a:txBody>
+                    <a:bodyPr/>
+                    <a:lstStyle/>
+                    <a:p>
+                      <a:pPr algn="l"/>
+                      <a:r>
+                        <a:rPr sz="850">
+                          <a:solidFill>
+                            <a:srgbClr val="1A1A1A"/>
+                          </a:solidFill>
+                          <a:latin typeface="Calibri"/>
+                        </a:rPr>
+                        <a:t>Sem oferta CVM map</a:t>
+                      </a:r>
+                    </a:p>
+                  </a:txBody>
+                  <a:tcPr anchor="ctr" marT="4572" marB="4572">
+                    <a:solidFill>
+                      <a:srgbClr val="F3F5F8"/>
+                    </a:solidFill>
+                  </a:tcPr>
+                </a:tc>
+                <a:tc>
+                  <a:txBody>
+                    <a:bodyPr/>
+                    <a:lstStyle/>
+                    <a:p>
+                      <a:pPr algn="ctr"/>
+                      <a:r>
+                        <a:rPr sz="850">
+                          <a:solidFill>
+                            <a:srgbClr val="1A1A1A"/>
+                          </a:solidFill>
+                          <a:latin typeface="Calibri"/>
+                        </a:rPr>
+                        <a:t>1</a:t>
+                      </a:r>
+                    </a:p>
+                  </a:txBody>
+                  <a:tcPr anchor="ctr" marT="4572" marB="4572">
+                    <a:solidFill>
+                      <a:srgbClr val="F3F5F8"/>
+                    </a:solidFill>
+                  </a:tcPr>
+                </a:tc>
+                <a:tc>
+                  <a:txBody>
+                    <a:bodyPr/>
+                    <a:lstStyle/>
+                    <a:p>
+                      <a:pPr algn="ctr"/>
+                      <a:r>
+                        <a:rPr sz="850">
+                          <a:solidFill>
+                            <a:srgbClr val="1A1A1A"/>
+                          </a:solidFill>
+                          <a:latin typeface="Calibri"/>
+                        </a:rPr>
+                        <a:t>0.91</a:t>
+                      </a:r>
+                    </a:p>
+                  </a:txBody>
+                  <a:tcPr anchor="ctr" marT="4572" marB="4572">
+                    <a:solidFill>
+                      <a:srgbClr val="F3F5F8"/>
+                    </a:solidFill>
+                  </a:tcPr>
+                </a:tc>
+              </a:tr>
+              <a:tr h="382390">
+                <a:tc>
+                  <a:txBody>
+                    <a:bodyPr/>
+                    <a:lstStyle/>
+                    <a:p>
+                      <a:pPr algn="l"/>
+                      <a:r>
+                        <a:rPr sz="850">
+                          <a:solidFill>
+                            <a:srgbClr val="1A1A1A"/>
+                          </a:solidFill>
+                          <a:latin typeface="Calibri"/>
+                        </a:rPr>
+                        <a:t>IBM BRASIL - INDÚSTRIA, MÁQUIN</a:t>
+                      </a:r>
+                    </a:p>
+                  </a:txBody>
+                  <a:tcPr anchor="ctr" marT="4572" marB="4572">
+                    <a:solidFill>
+                      <a:srgbClr val="FFFFFF"/>
+                    </a:solidFill>
+                  </a:tcPr>
+                </a:tc>
+                <a:tc>
+                  <a:txBody>
+                    <a:bodyPr/>
+                    <a:lstStyle/>
+                    <a:p>
+                      <a:pPr algn="l"/>
+                      <a:r>
+                        <a:rPr sz="850">
+                          <a:solidFill>
+                            <a:srgbClr val="1A1A1A"/>
+                          </a:solidFill>
+                          <a:latin typeface="Calibri"/>
+                        </a:rPr>
+                        <a:t>Crédito PF</a:t>
+                      </a:r>
+                    </a:p>
+                  </a:txBody>
+                  <a:tcPr anchor="ctr" marT="4572" marB="4572">
+                    <a:solidFill>
+                      <a:srgbClr val="FFFFFF"/>
+                    </a:solidFill>
+                  </a:tcPr>
+                </a:tc>
+                <a:tc>
+                  <a:txBody>
+                    <a:bodyPr/>
+                    <a:lstStyle/>
+                    <a:p>
+                      <a:pPr algn="ctr"/>
+                      <a:r>
+                        <a:rPr sz="850">
+                          <a:solidFill>
+                            <a:srgbClr val="1A1A1A"/>
+                          </a:solidFill>
+                          <a:latin typeface="Calibri"/>
+                        </a:rPr>
+                        <a:t>1</a:t>
+                      </a:r>
+                    </a:p>
+                  </a:txBody>
+                  <a:tcPr anchor="ctr" marT="4572" marB="4572">
+                    <a:solidFill>
+                      <a:srgbClr val="FFFFFF"/>
+                    </a:solidFill>
+                  </a:tcPr>
+                </a:tc>
+                <a:tc>
+                  <a:txBody>
+                    <a:bodyPr/>
+                    <a:lstStyle/>
+                    <a:p>
+                      <a:pPr algn="ctr"/>
+                      <a:r>
+                        <a:rPr sz="850">
+                          <a:solidFill>
+                            <a:srgbClr val="1A1A1A"/>
+                          </a:solidFill>
+                          <a:latin typeface="Calibri"/>
+                        </a:rPr>
+                        <a:t>0.85</a:t>
+                      </a:r>
+                    </a:p>
+                  </a:txBody>
+                  <a:tcPr anchor="ctr" marT="4572" marB="4572">
+                    <a:solidFill>
+                      <a:srgbClr val="FFFFFF"/>
+                    </a:solidFill>
+                  </a:tcPr>
+                </a:tc>
+              </a:tr>
+            </a:tbl>
+          </a:graphicData>
+        </a:graphic>
+      </p:graphicFrame>
+      <p:graphicFrame>
+        <p:nvGraphicFramePr>
+          <p:cNvPr id="9" name="Table 8"/>
+          <p:cNvGraphicFramePr>
+            <a:graphicFrameLocks noGrp="1"/>
+          </p:cNvGraphicFramePr>
+          <p:nvPr/>
+        </p:nvGraphicFramePr>
+        <p:xfrm>
+          <a:off x="6263640" y="1463040"/>
+          <a:ext cx="5760719" cy="4206240"/>
+        </p:xfrm>
+        <a:graphic>
+          <a:graphicData uri="http://schemas.openxmlformats.org/drawingml/2006/table">
+            <a:tbl>
+              <a:tblPr firstRow="1" bandRow="1">
+                <a:tableStyleId>{5C22544A-7EE6-4342-B048-85BDC9FD1C3A}</a:tableStyleId>
+              </a:tblPr>
+              <a:tblGrid>
+                <a:gridCol w="2633472"/>
+                <a:gridCol w="1563624"/>
+                <a:gridCol w="576071"/>
+                <a:gridCol w="987552"/>
+              </a:tblGrid>
+              <a:tr h="382385">
+                <a:tc>
+                  <a:txBody>
+                    <a:bodyPr/>
+                    <a:lstStyle/>
+                    <a:p>
+                      <a:pPr algn="ctr"/>
+                      <a:r>
+                        <a:rPr sz="850" b="1">
+                          <a:solidFill>
+                            <a:srgbClr val="FFFFFF"/>
+                          </a:solidFill>
+                          <a:latin typeface="Calibri"/>
+                        </a:rPr>
+                        <a:t>Parte</a:t>
+                      </a:r>
+                    </a:p>
+                  </a:txBody>
+                  <a:tcPr anchor="ctr" marT="9144" marB="9144">
+                    <a:solidFill>
+                      <a:srgbClr val="1F2A44"/>
+                    </a:solidFill>
+                  </a:tcPr>
+                </a:tc>
+                <a:tc>
+                  <a:txBody>
+                    <a:bodyPr/>
+                    <a:lstStyle/>
+                    <a:p>
+                      <a:pPr algn="ctr"/>
+                      <a:r>
+                        <a:rPr sz="850" b="1">
+                          <a:solidFill>
+                            <a:srgbClr val="FFFFFF"/>
+                          </a:solidFill>
+                          <a:latin typeface="Calibri"/>
+                        </a:rPr>
+                        <a:t>Setor</a:t>
+                      </a:r>
+                    </a:p>
+                  </a:txBody>
+                  <a:tcPr anchor="ctr" marT="9144" marB="9144">
+                    <a:solidFill>
+                      <a:srgbClr val="1F2A44"/>
+                    </a:solidFill>
+                  </a:tcPr>
+                </a:tc>
+                <a:tc>
+                  <a:txBody>
+                    <a:bodyPr/>
+                    <a:lstStyle/>
+                    <a:p>
+                      <a:pPr algn="ctr"/>
+                      <a:r>
+                        <a:rPr sz="850" b="1">
+                          <a:solidFill>
+                            <a:srgbClr val="FFFFFF"/>
+                          </a:solidFill>
+                          <a:latin typeface="Calibri"/>
+                        </a:rPr>
+                        <a:t># Fundos</a:t>
+                      </a:r>
+                    </a:p>
+                  </a:txBody>
+                  <a:tcPr anchor="ctr" marT="9144" marB="9144">
+                    <a:solidFill>
+                      <a:srgbClr val="1F2A44"/>
+                    </a:solidFill>
+                  </a:tcPr>
+                </a:tc>
+                <a:tc>
+                  <a:txBody>
+                    <a:bodyPr/>
+                    <a:lstStyle/>
+                    <a:p>
+                      <a:pPr algn="ctr"/>
+                      <a:r>
+                        <a:rPr sz="850" b="1">
+                          <a:solidFill>
+                            <a:srgbClr val="FFFFFF"/>
+                          </a:solidFill>
+                          <a:latin typeface="Calibri"/>
+                        </a:rPr>
+                        <a:t>Materialidade (R$ bi)</a:t>
+                      </a:r>
+                    </a:p>
+                  </a:txBody>
+                  <a:tcPr anchor="ctr" marT="9144" marB="9144">
+                    <a:solidFill>
+                      <a:srgbClr val="1F2A44"/>
+                    </a:solidFill>
+                  </a:tcPr>
+                </a:tc>
+              </a:tr>
+              <a:tr h="382385">
+                <a:tc>
+                  <a:txBody>
+                    <a:bodyPr/>
+                    <a:lstStyle/>
+                    <a:p>
+                      <a:pPr algn="l"/>
+                      <a:r>
+                        <a:rPr sz="850">
+                          <a:solidFill>
+                            <a:srgbClr val="1A1A1A"/>
+                          </a:solidFill>
+                          <a:latin typeface="Calibri"/>
+                        </a:rPr>
+                        <a:t>MERCADO PAGO INSTITUIÇÃO DE PA</a:t>
+                      </a:r>
+                    </a:p>
+                  </a:txBody>
+                  <a:tcPr anchor="ctr" marT="4572" marB="4572">
+                    <a:solidFill>
+                      <a:srgbClr val="F3F5F8"/>
+                    </a:solidFill>
+                  </a:tcPr>
+                </a:tc>
+                <a:tc>
+                  <a:txBody>
+                    <a:bodyPr/>
+                    <a:lstStyle/>
+                    <a:p>
+                      <a:pPr algn="l"/>
+                      <a:r>
+                        <a:rPr sz="850">
+                          <a:solidFill>
+                            <a:srgbClr val="1A1A1A"/>
+                          </a:solidFill>
+                          <a:latin typeface="Calibri"/>
+                        </a:rPr>
+                        <a:t>Meios de Pagamento</a:t>
+                      </a:r>
+                    </a:p>
+                  </a:txBody>
+                  <a:tcPr anchor="ctr" marT="4572" marB="4572">
+                    <a:solidFill>
+                      <a:srgbClr val="F3F5F8"/>
+                    </a:solidFill>
+                  </a:tcPr>
+                </a:tc>
+                <a:tc>
+                  <a:txBody>
+                    <a:bodyPr/>
+                    <a:lstStyle/>
+                    <a:p>
+                      <a:pPr algn="ctr"/>
+                      <a:r>
+                        <a:rPr sz="850">
+                          <a:solidFill>
+                            <a:srgbClr val="1A1A1A"/>
+                          </a:solidFill>
+                          <a:latin typeface="Calibri"/>
+                        </a:rPr>
+                        <a:t>2</a:t>
+                      </a:r>
+                    </a:p>
+                  </a:txBody>
+                  <a:tcPr anchor="ctr" marT="4572" marB="4572">
+                    <a:solidFill>
+                      <a:srgbClr val="F3F5F8"/>
+                    </a:solidFill>
+                  </a:tcPr>
+                </a:tc>
+                <a:tc>
+                  <a:txBody>
+                    <a:bodyPr/>
+                    <a:lstStyle/>
+                    <a:p>
+                      <a:pPr algn="ctr"/>
+                      <a:r>
+                        <a:rPr sz="850">
+                          <a:solidFill>
+                            <a:srgbClr val="1A1A1A"/>
+                          </a:solidFill>
+                          <a:latin typeface="Calibri"/>
+                        </a:rPr>
+                        <a:t>5.75</a:t>
+                      </a:r>
+                    </a:p>
+                  </a:txBody>
+                  <a:tcPr anchor="ctr" marT="4572" marB="4572">
+                    <a:solidFill>
+                      <a:srgbClr val="F3F5F8"/>
+                    </a:solidFill>
+                  </a:tcPr>
+                </a:tc>
+              </a:tr>
+              <a:tr h="382385">
+                <a:tc>
+                  <a:txBody>
+                    <a:bodyPr/>
+                    <a:lstStyle/>
+                    <a:p>
+                      <a:pPr algn="l"/>
+                      <a:r>
+                        <a:rPr sz="850">
+                          <a:solidFill>
+                            <a:srgbClr val="1A1A1A"/>
+                          </a:solidFill>
+                          <a:latin typeface="Calibri"/>
+                        </a:rPr>
+                        <a:t>Boletos Banco Votorantim S.A</a:t>
+                      </a:r>
+                    </a:p>
+                  </a:txBody>
+                  <a:tcPr anchor="ctr" marT="4572" marB="4572">
+                    <a:solidFill>
+                      <a:srgbClr val="FFFFFF"/>
+                    </a:solidFill>
+                  </a:tcPr>
+                </a:tc>
+                <a:tc>
+                  <a:txBody>
+                    <a:bodyPr/>
+                    <a:lstStyle/>
+                    <a:p>
+                      <a:pPr algn="l"/>
+                      <a:r>
+                        <a:rPr sz="850">
+                          <a:solidFill>
+                            <a:srgbClr val="1A1A1A"/>
+                          </a:solidFill>
+                          <a:latin typeface="Calibri"/>
+                        </a:rPr>
+                        <a:t>Sem oferta CVM map</a:t>
+                      </a:r>
+                    </a:p>
+                  </a:txBody>
+                  <a:tcPr anchor="ctr" marT="4572" marB="4572">
+                    <a:solidFill>
+                      <a:srgbClr val="FFFFFF"/>
+                    </a:solidFill>
+                  </a:tcPr>
+                </a:tc>
+                <a:tc>
+                  <a:txBody>
+                    <a:bodyPr/>
+                    <a:lstStyle/>
+                    <a:p>
+                      <a:pPr algn="ctr"/>
+                      <a:r>
+                        <a:rPr sz="850">
+                          <a:solidFill>
+                            <a:srgbClr val="1A1A1A"/>
+                          </a:solidFill>
+                          <a:latin typeface="Calibri"/>
+                        </a:rPr>
+                        <a:t>1</a:t>
+                      </a:r>
+                    </a:p>
+                  </a:txBody>
+                  <a:tcPr anchor="ctr" marT="4572" marB="4572">
+                    <a:solidFill>
+                      <a:srgbClr val="FFFFFF"/>
+                    </a:solidFill>
+                  </a:tcPr>
+                </a:tc>
+                <a:tc>
+                  <a:txBody>
+                    <a:bodyPr/>
+                    <a:lstStyle/>
+                    <a:p>
+                      <a:pPr algn="ctr"/>
+                      <a:r>
+                        <a:rPr sz="850">
+                          <a:solidFill>
+                            <a:srgbClr val="1A1A1A"/>
+                          </a:solidFill>
+                          <a:latin typeface="Calibri"/>
+                        </a:rPr>
+                        <a:t>0.91</a:t>
+                      </a:r>
+                    </a:p>
+                  </a:txBody>
+                  <a:tcPr anchor="ctr" marT="4572" marB="4572">
+                    <a:solidFill>
+                      <a:srgbClr val="FFFFFF"/>
+                    </a:solidFill>
+                  </a:tcPr>
+                </a:tc>
+              </a:tr>
+              <a:tr h="382385">
+                <a:tc>
+                  <a:txBody>
+                    <a:bodyPr/>
+                    <a:lstStyle/>
+                    <a:p>
+                      <a:pPr algn="l"/>
+                      <a:r>
+                        <a:rPr sz="850">
+                          <a:solidFill>
+                            <a:srgbClr val="1A1A1A"/>
+                          </a:solidFill>
+                          <a:latin typeface="Calibri"/>
+                        </a:rPr>
+                        <a:t>GRUPO CASAS BAHIA S.A</a:t>
+                      </a:r>
+                    </a:p>
+                  </a:txBody>
+                  <a:tcPr anchor="ctr" marT="4572" marB="4572">
+                    <a:solidFill>
+                      <a:srgbClr val="F3F5F8"/>
+                    </a:solidFill>
+                  </a:tcPr>
+                </a:tc>
+                <a:tc>
+                  <a:txBody>
+                    <a:bodyPr/>
+                    <a:lstStyle/>
+                    <a:p>
+                      <a:pPr algn="l"/>
+                      <a:r>
+                        <a:rPr sz="850">
+                          <a:solidFill>
+                            <a:srgbClr val="1A1A1A"/>
+                          </a:solidFill>
+                          <a:latin typeface="Calibri"/>
+                        </a:rPr>
+                        <a:t>Crédito PJ</a:t>
+                      </a:r>
+                    </a:p>
+                  </a:txBody>
+                  <a:tcPr anchor="ctr" marT="4572" marB="4572">
+                    <a:solidFill>
+                      <a:srgbClr val="F3F5F8"/>
+                    </a:solidFill>
+                  </a:tcPr>
+                </a:tc>
+                <a:tc>
+                  <a:txBody>
+                    <a:bodyPr/>
+                    <a:lstStyle/>
+                    <a:p>
+                      <a:pPr algn="ctr"/>
+                      <a:r>
+                        <a:rPr sz="850">
+                          <a:solidFill>
+                            <a:srgbClr val="1A1A1A"/>
+                          </a:solidFill>
+                          <a:latin typeface="Calibri"/>
+                        </a:rPr>
+                        <a:t>1</a:t>
+                      </a:r>
+                    </a:p>
+                  </a:txBody>
+                  <a:tcPr anchor="ctr" marT="4572" marB="4572">
+                    <a:solidFill>
+                      <a:srgbClr val="F3F5F8"/>
+                    </a:solidFill>
+                  </a:tcPr>
+                </a:tc>
+                <a:tc>
+                  <a:txBody>
+                    <a:bodyPr/>
+                    <a:lstStyle/>
+                    <a:p>
+                      <a:pPr algn="ctr"/>
+                      <a:r>
+                        <a:rPr sz="850">
+                          <a:solidFill>
+                            <a:srgbClr val="1A1A1A"/>
+                          </a:solidFill>
+                          <a:latin typeface="Calibri"/>
+                        </a:rPr>
+                        <a:t>0.78</a:t>
+                      </a:r>
+                    </a:p>
+                  </a:txBody>
+                  <a:tcPr anchor="ctr" marT="4572" marB="4572">
+                    <a:solidFill>
+                      <a:srgbClr val="F3F5F8"/>
+                    </a:solidFill>
+                  </a:tcPr>
+                </a:tc>
+              </a:tr>
+              <a:tr h="382385">
+                <a:tc>
+                  <a:txBody>
+                    <a:bodyPr/>
+                    <a:lstStyle/>
+                    <a:p>
+                      <a:pPr algn="l"/>
+                      <a:r>
+                        <a:rPr sz="850">
+                          <a:solidFill>
+                            <a:srgbClr val="1A1A1A"/>
+                          </a:solidFill>
+                          <a:latin typeface="Calibri"/>
+                        </a:rPr>
+                        <a:t>Oliveira Trust Distribuidora d</a:t>
+                      </a:r>
+                    </a:p>
+                  </a:txBody>
+                  <a:tcPr anchor="ctr" marT="4572" marB="4572">
+                    <a:solidFill>
+                      <a:srgbClr val="FFFFFF"/>
+                    </a:solidFill>
+                  </a:tcPr>
+                </a:tc>
+                <a:tc>
+                  <a:txBody>
+                    <a:bodyPr/>
+                    <a:lstStyle/>
+                    <a:p>
+                      <a:pPr algn="l"/>
+                      <a:r>
+                        <a:rPr sz="850">
+                          <a:solidFill>
+                            <a:srgbClr val="1A1A1A"/>
+                          </a:solidFill>
+                          <a:latin typeface="Calibri"/>
+                        </a:rPr>
+                        <a:t>Crédito PJ</a:t>
+                      </a:r>
+                    </a:p>
+                  </a:txBody>
+                  <a:tcPr anchor="ctr" marT="4572" marB="4572">
+                    <a:solidFill>
+                      <a:srgbClr val="FFFFFF"/>
+                    </a:solidFill>
+                  </a:tcPr>
+                </a:tc>
+                <a:tc>
+                  <a:txBody>
+                    <a:bodyPr/>
+                    <a:lstStyle/>
+                    <a:p>
+                      <a:pPr algn="ctr"/>
+                      <a:r>
+                        <a:rPr sz="850">
+                          <a:solidFill>
+                            <a:srgbClr val="1A1A1A"/>
+                          </a:solidFill>
+                          <a:latin typeface="Calibri"/>
+                        </a:rPr>
+                        <a:t>1</a:t>
+                      </a:r>
+                    </a:p>
+                  </a:txBody>
+                  <a:tcPr anchor="ctr" marT="4572" marB="4572">
+                    <a:solidFill>
+                      <a:srgbClr val="FFFFFF"/>
+                    </a:solidFill>
+                  </a:tcPr>
+                </a:tc>
+                <a:tc>
+                  <a:txBody>
+                    <a:bodyPr/>
+                    <a:lstStyle/>
+                    <a:p>
+                      <a:pPr algn="ctr"/>
+                      <a:r>
+                        <a:rPr sz="850">
+                          <a:solidFill>
+                            <a:srgbClr val="1A1A1A"/>
+                          </a:solidFill>
+                          <a:latin typeface="Calibri"/>
+                        </a:rPr>
+                        <a:t>0.78</a:t>
+                      </a:r>
+                    </a:p>
+                  </a:txBody>
+                  <a:tcPr anchor="ctr" marT="4572" marB="4572">
+                    <a:solidFill>
+                      <a:srgbClr val="FFFFFF"/>
+                    </a:solidFill>
+                  </a:tcPr>
+                </a:tc>
+              </a:tr>
+              <a:tr h="382385">
+                <a:tc>
+                  <a:txBody>
+                    <a:bodyPr/>
+                    <a:lstStyle/>
+                    <a:p>
+                      <a:pPr algn="l"/>
+                      <a:r>
+                        <a:rPr sz="850">
+                          <a:solidFill>
+                            <a:srgbClr val="1A1A1A"/>
+                          </a:solidFill>
+                          <a:latin typeface="Calibri"/>
+                        </a:rPr>
+                        <a:t>SafraPay Instituição de Pagame</a:t>
+                      </a:r>
+                    </a:p>
+                  </a:txBody>
+                  <a:tcPr anchor="ctr" marT="4572" marB="4572">
+                    <a:solidFill>
+                      <a:srgbClr val="F3F5F8"/>
+                    </a:solidFill>
+                  </a:tcPr>
+                </a:tc>
+                <a:tc>
+                  <a:txBody>
+                    <a:bodyPr/>
+                    <a:lstStyle/>
+                    <a:p>
+                      <a:pPr algn="l"/>
+                      <a:r>
+                        <a:rPr sz="850">
+                          <a:solidFill>
+                            <a:srgbClr val="1A1A1A"/>
+                          </a:solidFill>
+                          <a:latin typeface="Calibri"/>
+                        </a:rPr>
+                        <a:t>Crédito PJ</a:t>
+                      </a:r>
+                    </a:p>
+                  </a:txBody>
+                  <a:tcPr anchor="ctr" marT="4572" marB="4572">
+                    <a:solidFill>
+                      <a:srgbClr val="F3F5F8"/>
+                    </a:solidFill>
+                  </a:tcPr>
+                </a:tc>
+                <a:tc>
+                  <a:txBody>
+                    <a:bodyPr/>
+                    <a:lstStyle/>
+                    <a:p>
+                      <a:pPr algn="ctr"/>
+                      <a:r>
+                        <a:rPr sz="850">
+                          <a:solidFill>
+                            <a:srgbClr val="1A1A1A"/>
+                          </a:solidFill>
+                          <a:latin typeface="Calibri"/>
+                        </a:rPr>
+                        <a:t>1</a:t>
+                      </a:r>
+                    </a:p>
+                  </a:txBody>
+                  <a:tcPr anchor="ctr" marT="4572" marB="4572">
+                    <a:solidFill>
+                      <a:srgbClr val="F3F5F8"/>
+                    </a:solidFill>
+                  </a:tcPr>
+                </a:tc>
+                <a:tc>
+                  <a:txBody>
+                    <a:bodyPr/>
+                    <a:lstStyle/>
+                    <a:p>
+                      <a:pPr algn="ctr"/>
+                      <a:r>
+                        <a:rPr sz="850">
+                          <a:solidFill>
+                            <a:srgbClr val="1A1A1A"/>
+                          </a:solidFill>
+                          <a:latin typeface="Calibri"/>
+                        </a:rPr>
+                        <a:t>0.78</a:t>
+                      </a:r>
+                    </a:p>
+                  </a:txBody>
+                  <a:tcPr anchor="ctr" marT="4572" marB="4572">
+                    <a:solidFill>
+                      <a:srgbClr val="F3F5F8"/>
+                    </a:solidFill>
+                  </a:tcPr>
+                </a:tc>
+              </a:tr>
+              <a:tr h="382385">
+                <a:tc>
+                  <a:txBody>
+                    <a:bodyPr/>
+                    <a:lstStyle/>
+                    <a:p>
+                      <a:pPr algn="l"/>
+                      <a:r>
+                        <a:rPr sz="850">
+                          <a:solidFill>
+                            <a:srgbClr val="1A1A1A"/>
+                          </a:solidFill>
+                          <a:latin typeface="Calibri"/>
+                        </a:rPr>
+                        <a:t>LAVORO AGRO HOLDING S.A</a:t>
+                      </a:r>
+                    </a:p>
+                  </a:txBody>
+                  <a:tcPr anchor="ctr" marT="4572" marB="4572">
+                    <a:solidFill>
+                      <a:srgbClr val="FFFFFF"/>
+                    </a:solidFill>
+                  </a:tcPr>
+                </a:tc>
+                <a:tc>
+                  <a:txBody>
+                    <a:bodyPr/>
+                    <a:lstStyle/>
+                    <a:p>
+                      <a:pPr algn="l"/>
+                      <a:r>
+                        <a:rPr sz="850">
+                          <a:solidFill>
+                            <a:srgbClr val="1A1A1A"/>
+                          </a:solidFill>
+                          <a:latin typeface="Calibri"/>
+                        </a:rPr>
+                        <a:t>Agro</a:t>
+                      </a:r>
+                    </a:p>
+                  </a:txBody>
+                  <a:tcPr anchor="ctr" marT="4572" marB="4572">
+                    <a:solidFill>
+                      <a:srgbClr val="FFFFFF"/>
+                    </a:solidFill>
+                  </a:tcPr>
+                </a:tc>
+                <a:tc>
+                  <a:txBody>
+                    <a:bodyPr/>
+                    <a:lstStyle/>
+                    <a:p>
+                      <a:pPr algn="ctr"/>
+                      <a:r>
+                        <a:rPr sz="850">
+                          <a:solidFill>
+                            <a:srgbClr val="1A1A1A"/>
+                          </a:solidFill>
+                          <a:latin typeface="Calibri"/>
+                        </a:rPr>
+                        <a:t>1</a:t>
+                      </a:r>
+                    </a:p>
+                  </a:txBody>
+                  <a:tcPr anchor="ctr" marT="4572" marB="4572">
+                    <a:solidFill>
+                      <a:srgbClr val="FFFFFF"/>
+                    </a:solidFill>
+                  </a:tcPr>
+                </a:tc>
+                <a:tc>
+                  <a:txBody>
+                    <a:bodyPr/>
+                    <a:lstStyle/>
+                    <a:p>
+                      <a:pPr algn="ctr"/>
+                      <a:r>
+                        <a:rPr sz="850">
+                          <a:solidFill>
+                            <a:srgbClr val="1A1A1A"/>
+                          </a:solidFill>
+                          <a:latin typeface="Calibri"/>
+                        </a:rPr>
+                        <a:t>0.73</a:t>
+                      </a:r>
+                    </a:p>
+                  </a:txBody>
+                  <a:tcPr anchor="ctr" marT="4572" marB="4572">
+                    <a:solidFill>
+                      <a:srgbClr val="FFFFFF"/>
+                    </a:solidFill>
+                  </a:tcPr>
+                </a:tc>
+              </a:tr>
+              <a:tr h="382385">
+                <a:tc>
+                  <a:txBody>
+                    <a:bodyPr/>
+                    <a:lstStyle/>
+                    <a:p>
+                      <a:pPr algn="l"/>
+                      <a:r>
+                        <a:rPr sz="850">
+                          <a:solidFill>
+                            <a:srgbClr val="1A1A1A"/>
+                          </a:solidFill>
+                          <a:latin typeface="Calibri"/>
+                        </a:rPr>
+                        <a:t>Latasa Industria e Comercio Lt</a:t>
+                      </a:r>
+                    </a:p>
+                  </a:txBody>
+                  <a:tcPr anchor="ctr" marT="4572" marB="4572">
+                    <a:solidFill>
+                      <a:srgbClr val="F3F5F8"/>
+                    </a:solidFill>
+                  </a:tcPr>
+                </a:tc>
+                <a:tc>
+                  <a:txBody>
+                    <a:bodyPr/>
+                    <a:lstStyle/>
+                    <a:p>
+                      <a:pPr algn="l"/>
+                      <a:r>
+                        <a:rPr sz="850">
+                          <a:solidFill>
+                            <a:srgbClr val="1A1A1A"/>
+                          </a:solidFill>
+                          <a:latin typeface="Calibri"/>
+                        </a:rPr>
+                        <a:t>Crédito PF</a:t>
+                      </a:r>
+                    </a:p>
+                  </a:txBody>
+                  <a:tcPr anchor="ctr" marT="4572" marB="4572">
+                    <a:solidFill>
+                      <a:srgbClr val="F3F5F8"/>
+                    </a:solidFill>
+                  </a:tcPr>
+                </a:tc>
+                <a:tc>
+                  <a:txBody>
+                    <a:bodyPr/>
+                    <a:lstStyle/>
+                    <a:p>
+                      <a:pPr algn="ctr"/>
+                      <a:r>
+                        <a:rPr sz="850">
+                          <a:solidFill>
+                            <a:srgbClr val="1A1A1A"/>
+                          </a:solidFill>
+                          <a:latin typeface="Calibri"/>
+                        </a:rPr>
+                        <a:t>1</a:t>
+                      </a:r>
+                    </a:p>
+                  </a:txBody>
+                  <a:tcPr anchor="ctr" marT="4572" marB="4572">
+                    <a:solidFill>
+                      <a:srgbClr val="F3F5F8"/>
+                    </a:solidFill>
+                  </a:tcPr>
+                </a:tc>
+                <a:tc>
+                  <a:txBody>
+                    <a:bodyPr/>
+                    <a:lstStyle/>
+                    <a:p>
+                      <a:pPr algn="ctr"/>
+                      <a:r>
+                        <a:rPr sz="850">
+                          <a:solidFill>
+                            <a:srgbClr val="1A1A1A"/>
+                          </a:solidFill>
+                          <a:latin typeface="Calibri"/>
+                        </a:rPr>
+                        <a:t>0.63</a:t>
+                      </a:r>
+                    </a:p>
+                  </a:txBody>
+                  <a:tcPr anchor="ctr" marT="4572" marB="4572">
+                    <a:solidFill>
+                      <a:srgbClr val="F3F5F8"/>
+                    </a:solidFill>
+                  </a:tcPr>
+                </a:tc>
+              </a:tr>
+              <a:tr h="382385">
+                <a:tc>
+                  <a:txBody>
+                    <a:bodyPr/>
+                    <a:lstStyle/>
+                    <a:p>
+                      <a:pPr algn="l"/>
+                      <a:r>
+                        <a:rPr sz="850">
+                          <a:solidFill>
+                            <a:srgbClr val="1A1A1A"/>
+                          </a:solidFill>
+                          <a:latin typeface="Calibri"/>
+                        </a:rPr>
+                        <a:t>io de Metais Ltda</a:t>
+                      </a:r>
+                    </a:p>
+                  </a:txBody>
+                  <a:tcPr anchor="ctr" marT="4572" marB="4572">
+                    <a:solidFill>
+                      <a:srgbClr val="FFFFFF"/>
+                    </a:solidFill>
+                  </a:tcPr>
+                </a:tc>
+                <a:tc>
+                  <a:txBody>
+                    <a:bodyPr/>
+                    <a:lstStyle/>
+                    <a:p>
+                      <a:pPr algn="l"/>
+                      <a:r>
+                        <a:rPr sz="850">
+                          <a:solidFill>
+                            <a:srgbClr val="1A1A1A"/>
+                          </a:solidFill>
+                          <a:latin typeface="Calibri"/>
+                        </a:rPr>
+                        <a:t>Crédito PF</a:t>
+                      </a:r>
+                    </a:p>
+                  </a:txBody>
+                  <a:tcPr anchor="ctr" marT="4572" marB="4572">
+                    <a:solidFill>
+                      <a:srgbClr val="FFFFFF"/>
+                    </a:solidFill>
+                  </a:tcPr>
+                </a:tc>
+                <a:tc>
+                  <a:txBody>
+                    <a:bodyPr/>
+                    <a:lstStyle/>
+                    <a:p>
+                      <a:pPr algn="ctr"/>
+                      <a:r>
+                        <a:rPr sz="850">
+                          <a:solidFill>
+                            <a:srgbClr val="1A1A1A"/>
+                          </a:solidFill>
+                          <a:latin typeface="Calibri"/>
+                        </a:rPr>
+                        <a:t>1</a:t>
+                      </a:r>
+                    </a:p>
+                  </a:txBody>
+                  <a:tcPr anchor="ctr" marT="4572" marB="4572">
+                    <a:solidFill>
+                      <a:srgbClr val="FFFFFF"/>
+                    </a:solidFill>
+                  </a:tcPr>
+                </a:tc>
+                <a:tc>
+                  <a:txBody>
+                    <a:bodyPr/>
+                    <a:lstStyle/>
+                    <a:p>
+                      <a:pPr algn="ctr"/>
+                      <a:r>
+                        <a:rPr sz="850">
+                          <a:solidFill>
+                            <a:srgbClr val="1A1A1A"/>
+                          </a:solidFill>
+                          <a:latin typeface="Calibri"/>
+                        </a:rPr>
+                        <a:t>0.63</a:t>
+                      </a:r>
+                    </a:p>
+                  </a:txBody>
+                  <a:tcPr anchor="ctr" marT="4572" marB="4572">
+                    <a:solidFill>
+                      <a:srgbClr val="FFFFFF"/>
+                    </a:solidFill>
+                  </a:tcPr>
+                </a:tc>
+              </a:tr>
+              <a:tr h="382385">
+                <a:tc>
+                  <a:txBody>
+                    <a:bodyPr/>
+                    <a:lstStyle/>
+                    <a:p>
+                      <a:pPr algn="l"/>
+                      <a:r>
+                        <a:rPr sz="850">
+                          <a:solidFill>
+                            <a:srgbClr val="1A1A1A"/>
+                          </a:solidFill>
+                          <a:latin typeface="Calibri"/>
+                        </a:rPr>
+                        <a:t>MEUCASHCARD SERVIÇOS TECNOLÓGI</a:t>
+                      </a:r>
+                    </a:p>
+                  </a:txBody>
+                  <a:tcPr anchor="ctr" marT="4572" marB="4572">
+                    <a:solidFill>
+                      <a:srgbClr val="F3F5F8"/>
+                    </a:solidFill>
+                  </a:tcPr>
+                </a:tc>
+                <a:tc>
+                  <a:txBody>
+                    <a:bodyPr/>
+                    <a:lstStyle/>
+                    <a:p>
+                      <a:pPr algn="l"/>
+                      <a:r>
+                        <a:rPr sz="850">
+                          <a:solidFill>
+                            <a:srgbClr val="1A1A1A"/>
+                          </a:solidFill>
+                          <a:latin typeface="Calibri"/>
+                        </a:rPr>
+                        <a:t>Imobiliário</a:t>
+                      </a:r>
+                    </a:p>
+                  </a:txBody>
+                  <a:tcPr anchor="ctr" marT="4572" marB="4572">
+                    <a:solidFill>
+                      <a:srgbClr val="F3F5F8"/>
+                    </a:solidFill>
+                  </a:tcPr>
+                </a:tc>
+                <a:tc>
+                  <a:txBody>
+                    <a:bodyPr/>
+                    <a:lstStyle/>
+                    <a:p>
+                      <a:pPr algn="ctr"/>
+                      <a:r>
+                        <a:rPr sz="850">
+                          <a:solidFill>
+                            <a:srgbClr val="1A1A1A"/>
+                          </a:solidFill>
+                          <a:latin typeface="Calibri"/>
+                        </a:rPr>
+                        <a:t>1</a:t>
+                      </a:r>
+                    </a:p>
+                  </a:txBody>
+                  <a:tcPr anchor="ctr" marT="4572" marB="4572">
+                    <a:solidFill>
+                      <a:srgbClr val="F3F5F8"/>
+                    </a:solidFill>
+                  </a:tcPr>
+                </a:tc>
+                <a:tc>
+                  <a:txBody>
+                    <a:bodyPr/>
+                    <a:lstStyle/>
+                    <a:p>
+                      <a:pPr algn="ctr"/>
+                      <a:r>
+                        <a:rPr sz="850">
+                          <a:solidFill>
+                            <a:srgbClr val="1A1A1A"/>
+                          </a:solidFill>
+                          <a:latin typeface="Calibri"/>
+                        </a:rPr>
+                        <a:t>0.55</a:t>
+                      </a:r>
+                    </a:p>
+                  </a:txBody>
+                  <a:tcPr anchor="ctr" marT="4572" marB="4572">
+                    <a:solidFill>
+                      <a:srgbClr val="F3F5F8"/>
+                    </a:solidFill>
+                  </a:tcPr>
+                </a:tc>
+              </a:tr>
+              <a:tr h="382390">
+                <a:tc>
+                  <a:txBody>
+                    <a:bodyPr/>
+                    <a:lstStyle/>
+                    <a:p>
+                      <a:pPr algn="l"/>
+                      <a:r>
+                        <a:rPr sz="850">
+                          <a:solidFill>
+                            <a:srgbClr val="1A1A1A"/>
+                          </a:solidFill>
+                          <a:latin typeface="Calibri"/>
+                        </a:rPr>
+                        <a:t>Rotam do Brasil Agroquímica e </a:t>
+                      </a:r>
+                    </a:p>
+                  </a:txBody>
+                  <a:tcPr anchor="ctr" marT="4572" marB="4572">
+                    <a:solidFill>
+                      <a:srgbClr val="FFFFFF"/>
+                    </a:solidFill>
+                  </a:tcPr>
+                </a:tc>
+                <a:tc>
+                  <a:txBody>
+                    <a:bodyPr/>
+                    <a:lstStyle/>
+                    <a:p>
+                      <a:pPr algn="l"/>
+                      <a:r>
+                        <a:rPr sz="850">
+                          <a:solidFill>
+                            <a:srgbClr val="1A1A1A"/>
+                          </a:solidFill>
+                          <a:latin typeface="Calibri"/>
+                        </a:rPr>
+                        <a:t>Agro</a:t>
+                      </a:r>
+                    </a:p>
+                  </a:txBody>
+                  <a:tcPr anchor="ctr" marT="4572" marB="4572">
+                    <a:solidFill>
+                      <a:srgbClr val="FFFFFF"/>
+                    </a:solidFill>
+                  </a:tcPr>
+                </a:tc>
+                <a:tc>
+                  <a:txBody>
+                    <a:bodyPr/>
+                    <a:lstStyle/>
+                    <a:p>
+                      <a:pPr algn="ctr"/>
+                      <a:r>
+                        <a:rPr sz="850">
+                          <a:solidFill>
+                            <a:srgbClr val="1A1A1A"/>
+                          </a:solidFill>
+                          <a:latin typeface="Calibri"/>
+                        </a:rPr>
+                        <a:t>1</a:t>
+                      </a:r>
+                    </a:p>
+                  </a:txBody>
+                  <a:tcPr anchor="ctr" marT="4572" marB="4572">
+                    <a:solidFill>
+                      <a:srgbClr val="FFFFFF"/>
+                    </a:solidFill>
+                  </a:tcPr>
+                </a:tc>
+                <a:tc>
+                  <a:txBody>
+                    <a:bodyPr/>
+                    <a:lstStyle/>
+                    <a:p>
+                      <a:pPr algn="ctr"/>
+                      <a:r>
+                        <a:rPr sz="850">
+                          <a:solidFill>
+                            <a:srgbClr val="1A1A1A"/>
+                          </a:solidFill>
+                          <a:latin typeface="Calibri"/>
+                        </a:rPr>
+                        <a:t>0.51</a:t>
+                      </a:r>
+                    </a:p>
+                  </a:txBody>
+                  <a:tcPr anchor="ctr" marT="4572" marB="4572">
+                    <a:solidFill>
+                      <a:srgbClr val="FFFFFF"/>
+                    </a:solidFill>
+                  </a:tcPr>
+                </a:tc>
+              </a:tr>
+            </a:tbl>
+          </a:graphicData>
+        </a:graphic>
+      </p:graphicFrame>
+      <p:sp>
+        <p:nvSpPr>
+          <p:cNvPr id="10" name="TextBox 9"/>
+          <p:cNvSpPr txBox="1"/>
+          <p:nvPr/>
+        </p:nvSpPr>
+        <p:spPr>
+          <a:xfrm>
+            <a:off x="457200" y="5806440"/>
+            <a:ext cx="11338560" cy="365760"/>
+          </a:xfrm>
+          <a:prstGeom prst="rect">
+            <a:avLst/>
+          </a:prstGeom>
+          <a:noFill/>
+        </p:spPr>
+        <p:txBody>
+          <a:bodyPr wrap="square" anchor="t">
+            <a:spAutoFit/>
+          </a:bodyPr>
+          <a:lstStyle/>
+          <a:p>
+            <a:pPr algn="l"/>
+            <a:r>
+              <a:rPr sz="1100" b="1">
+                <a:solidFill>
+                  <a:srgbClr val="E8703A"/>
+                </a:solidFill>
+                <a:latin typeface="Calibri"/>
+              </a:rPr>
+              <a:t>Sacados são majoritariamente plataformas de pagamento/varejo — o crédito está colado a meios de pagamento.</a:t>
+            </a:r>
+          </a:p>
+        </p:txBody>
+      </p:sp>
+      <p:sp>
+        <p:nvSpPr>
+          <p:cNvPr id="11" name="TextBox 10"/>
+          <p:cNvSpPr txBox="1"/>
+          <p:nvPr/>
+        </p:nvSpPr>
+        <p:spPr>
+          <a:xfrm>
+            <a:off x="457200" y="6400800"/>
+            <a:ext cx="11338560" cy="411480"/>
+          </a:xfrm>
+          <a:prstGeom prst="rect">
+            <a:avLst/>
+          </a:prstGeom>
+          <a:noFill/>
+        </p:spPr>
+        <p:txBody>
+          <a:bodyPr wrap="square" anchor="t">
+            <a:spAutoFit/>
+          </a:bodyPr>
+          <a:lstStyle/>
+          <a:p>
+            <a:pPr algn="l"/>
+            <a:r>
+              <a:rPr sz="800" b="0">
+                <a:solidFill>
+                  <a:srgbClr val="8A94A6"/>
+                </a:solidFill>
+                <a:latin typeface="Calibri"/>
+              </a:rPr>
+              <a:t>Fonte: Toma Conta FIDCs — leitura de regulamentos (cedentes/sacados nomeados, materialidade por PL de fundo). Base: reports/fidc_clean_named_parties.</a:t>
+            </a:r>
+          </a:p>
+        </p:txBody>
+      </p:sp>
+    </p:spTree>
+  </p:cSld>
+  <p:clrMapOvr>
+    <a:masterClrMapping/>
+  </p:clrMapOvr>
+</p:sld>
+</file>
+
+<file path=ppt/slides/slide14.xml><?xml version="1.0" encoding="utf-8"?>
 <p:sld xmlns:a="http://schemas.openxmlformats.org/drawingml/2006/main" xmlns:p="http://schemas.openxmlformats.org/presentationml/2006/main" xmlns:r="http://schemas.openxmlformats.org/officeDocument/2006/relationships">
   <p:cSld>
     <p:spTree>
@@ -12893,7 +15704,7 @@
 </p:sld>
 </file>
 
-<file path=ppt/slides/slide13.xml><?xml version="1.0" encoding="utf-8"?>
+<file path=ppt/slides/slide15.xml><?xml version="1.0" encoding="utf-8"?>
 <p:sld xmlns:a="http://schemas.openxmlformats.org/drawingml/2006/main" xmlns:p="http://schemas.openxmlformats.org/presentationml/2006/main" xmlns:r="http://schemas.openxmlformats.org/officeDocument/2006/relationships">
   <p:cSld>
     <p:spTree>
@@ -13122,7 +15933,7 @@
 </p:sld>
 </file>
 
-<file path=ppt/slides/slide14.xml><?xml version="1.0" encoding="utf-8"?>
+<file path=ppt/slides/slide16.xml><?xml version="1.0" encoding="utf-8"?>
 <p:sld xmlns:a="http://schemas.openxmlformats.org/drawingml/2006/main" xmlns:p="http://schemas.openxmlformats.org/presentationml/2006/main" xmlns:r="http://schemas.openxmlformats.org/officeDocument/2006/relationships">
   <p:cSld>
     <p:spTree>
@@ -13458,7 +16269,7 @@
 </p:sld>
 </file>
 
-<file path=ppt/slides/slide15.xml><?xml version="1.0" encoding="utf-8"?>
+<file path=ppt/slides/slide17.xml><?xml version="1.0" encoding="utf-8"?>
 <p:sld xmlns:a="http://schemas.openxmlformats.org/drawingml/2006/main" xmlns:p="http://schemas.openxmlformats.org/presentationml/2006/main" xmlns:r="http://schemas.openxmlformats.org/officeDocument/2006/relationships">
   <p:cSld>
     <p:spTree>
@@ -13648,7 +16459,7 @@
                 <a:gridCol w="1920239"/>
                 <a:gridCol w="9601200"/>
               </a:tblGrid>
-              <a:tr h="419100">
+              <a:tr h="359228">
                 <a:tc>
                   <a:txBody>
                     <a:bodyPr/>
@@ -13696,7 +16507,7 @@
                   </a:tcPr>
                 </a:tc>
               </a:tr>
-              <a:tr h="419100">
+              <a:tr h="359228">
                 <a:tc>
                   <a:txBody>
                     <a:bodyPr/>
@@ -13744,7 +16555,7 @@
                   </a:tcPr>
                 </a:tc>
               </a:tr>
-              <a:tr h="419100">
+              <a:tr h="359228">
                 <a:tc>
                   <a:txBody>
                     <a:bodyPr/>
@@ -13792,7 +16603,7 @@
                   </a:tcPr>
                 </a:tc>
               </a:tr>
-              <a:tr h="419100">
+              <a:tr h="359228">
                 <a:tc>
                   <a:txBody>
                     <a:bodyPr/>
@@ -13840,7 +16651,7 @@
                   </a:tcPr>
                 </a:tc>
               </a:tr>
-              <a:tr h="419100">
+              <a:tr h="359228">
                 <a:tc>
                   <a:txBody>
                     <a:bodyPr/>
@@ -13888,7 +16699,7 @@
                   </a:tcPr>
                 </a:tc>
               </a:tr>
-              <a:tr h="419100">
+              <a:tr h="359228">
                 <a:tc>
                   <a:txBody>
                     <a:bodyPr/>
@@ -13936,7 +16747,7 @@
                   </a:tcPr>
                 </a:tc>
               </a:tr>
-              <a:tr h="419100">
+              <a:tr h="359228">
                 <a:tc>
                   <a:txBody>
                     <a:bodyPr/>
@@ -13984,7 +16795,7 @@
                   </a:tcPr>
                 </a:tc>
               </a:tr>
-              <a:tr h="419100">
+              <a:tr h="359228">
                 <a:tc>
                   <a:txBody>
                     <a:bodyPr/>
@@ -14032,7 +16843,7 @@
                   </a:tcPr>
                 </a:tc>
               </a:tr>
-              <a:tr h="419100">
+              <a:tr h="359228">
                 <a:tc>
                   <a:txBody>
                     <a:bodyPr/>
@@ -14080,7 +16891,7 @@
                   </a:tcPr>
                 </a:tc>
               </a:tr>
-              <a:tr h="419100">
+              <a:tr h="359228">
                 <a:tc>
                   <a:txBody>
                     <a:bodyPr/>
@@ -14128,7 +16939,7 @@
                   </a:tcPr>
                 </a:tc>
               </a:tr>
-              <a:tr h="419100">
+              <a:tr h="359228">
                 <a:tc>
                   <a:txBody>
                     <a:bodyPr/>
@@ -14176,7 +16987,7 @@
                   </a:tcPr>
                 </a:tc>
               </a:tr>
-              <a:tr h="419100">
+              <a:tr h="359228">
                 <a:tc>
                   <a:txBody>
                     <a:bodyPr/>
@@ -14214,6 +17025,102 @@
                           <a:latin typeface="Calibri"/>
                         </a:rPr>
                         <a:t>Toma Conta FIDCs — variação anual de PL (ex-FIC) e captação líquida (dimensão mensal). Métrica preferida: variação de PL. Validação de magnitude: ANBIMA (imprensa, 2024). NÃO é o campo 'emissões encerradas'.</a:t>
+                      </a:r>
+                    </a:p>
+                  </a:txBody>
+                  <a:tcPr anchor="ctr" marT="4572" marB="4572">
+                    <a:solidFill>
+                      <a:srgbClr val="F3F5F8"/>
+                    </a:solidFill>
+                  </a:tcPr>
+                </a:tc>
+              </a:tr>
+              <a:tr h="359228">
+                <a:tc>
+                  <a:txBody>
+                    <a:bodyPr/>
+                    <a:lstStyle/>
+                    <a:p>
+                      <a:pPr algn="l"/>
+                      <a:r>
+                        <a:rPr sz="800">
+                          <a:solidFill>
+                            <a:srgbClr val="1A1A1A"/>
+                          </a:solidFill>
+                          <a:latin typeface="Calibri"/>
+                        </a:rPr>
+                        <a:t>PARTES</a:t>
+                      </a:r>
+                    </a:p>
+                  </a:txBody>
+                  <a:tcPr anchor="ctr" marT="4572" marB="4572">
+                    <a:solidFill>
+                      <a:srgbClr val="FFFFFF"/>
+                    </a:solidFill>
+                  </a:tcPr>
+                </a:tc>
+                <a:tc>
+                  <a:txBody>
+                    <a:bodyPr/>
+                    <a:lstStyle/>
+                    <a:p>
+                      <a:pPr algn="l"/>
+                      <a:r>
+                        <a:rPr sz="800">
+                          <a:solidFill>
+                            <a:srgbClr val="1A1A1A"/>
+                          </a:solidFill>
+                          <a:latin typeface="Calibri"/>
+                        </a:rPr>
+                        <a:t>Toma Conta FIDCs — leitura de regulamentos (cedentes/sacados nomeados, materialidade por PL de fundo). Base: reports/fidc_clean_named_parties.</a:t>
+                      </a:r>
+                    </a:p>
+                  </a:txBody>
+                  <a:tcPr anchor="ctr" marT="4572" marB="4572">
+                    <a:solidFill>
+                      <a:srgbClr val="FFFFFF"/>
+                    </a:solidFill>
+                  </a:tcPr>
+                </a:tc>
+              </a:tr>
+              <a:tr h="359236">
+                <a:tc>
+                  <a:txBody>
+                    <a:bodyPr/>
+                    <a:lstStyle/>
+                    <a:p>
+                      <a:pPr algn="l"/>
+                      <a:r>
+                        <a:rPr sz="800">
+                          <a:solidFill>
+                            <a:srgbClr val="1A1A1A"/>
+                          </a:solidFill>
+                          <a:latin typeface="Calibri"/>
+                        </a:rPr>
+                        <a:t>SUMARIO</a:t>
+                      </a:r>
+                    </a:p>
+                  </a:txBody>
+                  <a:tcPr anchor="ctr" marT="4572" marB="4572">
+                    <a:solidFill>
+                      <a:srgbClr val="F3F5F8"/>
+                    </a:solidFill>
+                  </a:tcPr>
+                </a:tc>
+                <a:tc>
+                  <a:txBody>
+                    <a:bodyPr/>
+                    <a:lstStyle/>
+                    <a:p>
+                      <a:pPr algn="l"/>
+                      <a:r>
+                        <a:rPr sz="800">
+                          <a:solidFill>
+                            <a:srgbClr val="1A1A1A"/>
+                          </a:solidFill>
+                          <a:latin typeface="Calibri"/>
+                        </a:rPr>
+                        <a:t>Síntese das dimensões do Toma Conta (gestor/admin/custodiante/segmento) consolidadas por conglomerado.</a:t>
                       </a:r>
                     </a:p>
                   </a:txBody>
@@ -14237,6 +17144,813 @@
 </file>
 
 <file path=ppt/slides/slide2.xml><?xml version="1.0" encoding="utf-8"?>
+<p:sld xmlns:a="http://schemas.openxmlformats.org/drawingml/2006/main" xmlns:p="http://schemas.openxmlformats.org/presentationml/2006/main" xmlns:r="http://schemas.openxmlformats.org/officeDocument/2006/relationships">
+  <p:cSld>
+    <p:spTree>
+      <p:nvGrpSpPr>
+        <p:cNvPr id="1" name=""/>
+        <p:cNvGrpSpPr/>
+        <p:nvPr/>
+      </p:nvGrpSpPr>
+      <p:grpSpPr/>
+      <p:sp>
+        <p:nvSpPr>
+          <p:cNvPr id="2" name="Rectangle 1"/>
+          <p:cNvSpPr/>
+          <p:nvPr/>
+        </p:nvSpPr>
+        <p:spPr>
+          <a:xfrm>
+            <a:off x="0" y="0"/>
+            <a:ext cx="12191695" cy="1024128"/>
+          </a:xfrm>
+          <a:prstGeom prst="rect">
+            <a:avLst/>
+          </a:prstGeom>
+          <a:solidFill>
+            <a:srgbClr val="1F2A44"/>
+          </a:solidFill>
+          <a:ln>
+            <a:noFill/>
+          </a:ln>
+          <a:effectLst/>
+        </p:spPr>
+        <p:style>
+          <a:lnRef idx="1">
+            <a:schemeClr val="accent1"/>
+          </a:lnRef>
+          <a:fillRef idx="3">
+            <a:schemeClr val="accent1"/>
+          </a:fillRef>
+          <a:effectRef idx="2">
+            <a:schemeClr val="accent1"/>
+          </a:effectRef>
+          <a:fontRef idx="minor">
+            <a:schemeClr val="lt1"/>
+          </a:fontRef>
+        </p:style>
+        <p:txBody>
+          <a:bodyPr rtlCol="0" anchor="ctr"/>
+          <a:lstStyle/>
+          <a:p>
+            <a:pPr algn="ctr"/>
+          </a:p>
+        </p:txBody>
+      </p:sp>
+      <p:sp>
+        <p:nvSpPr>
+          <p:cNvPr id="3" name="Rectangle 2"/>
+          <p:cNvSpPr/>
+          <p:nvPr/>
+        </p:nvSpPr>
+        <p:spPr>
+          <a:xfrm>
+            <a:off x="0" y="1024128"/>
+            <a:ext cx="12191695" cy="45720"/>
+          </a:xfrm>
+          <a:prstGeom prst="rect">
+            <a:avLst/>
+          </a:prstGeom>
+          <a:solidFill>
+            <a:srgbClr val="E8703A"/>
+          </a:solidFill>
+          <a:ln>
+            <a:noFill/>
+          </a:ln>
+          <a:effectLst/>
+        </p:spPr>
+        <p:style>
+          <a:lnRef idx="1">
+            <a:schemeClr val="accent1"/>
+          </a:lnRef>
+          <a:fillRef idx="3">
+            <a:schemeClr val="accent1"/>
+          </a:fillRef>
+          <a:effectRef idx="2">
+            <a:schemeClr val="accent1"/>
+          </a:effectRef>
+          <a:fontRef idx="minor">
+            <a:schemeClr val="lt1"/>
+          </a:fontRef>
+        </p:style>
+        <p:txBody>
+          <a:bodyPr rtlCol="0" anchor="ctr"/>
+          <a:lstStyle/>
+          <a:p>
+            <a:pPr algn="ctr"/>
+          </a:p>
+        </p:txBody>
+      </p:sp>
+      <p:sp>
+        <p:nvSpPr>
+          <p:cNvPr id="4" name="TextBox 3"/>
+          <p:cNvSpPr txBox="1"/>
+          <p:nvPr/>
+        </p:nvSpPr>
+        <p:spPr>
+          <a:xfrm>
+            <a:off x="457200" y="118872"/>
+            <a:ext cx="10972800" cy="274320"/>
+          </a:xfrm>
+          <a:prstGeom prst="rect">
+            <a:avLst/>
+          </a:prstGeom>
+          <a:noFill/>
+        </p:spPr>
+        <p:txBody>
+          <a:bodyPr wrap="square" anchor="t">
+            <a:spAutoFit/>
+          </a:bodyPr>
+          <a:lstStyle/>
+          <a:p>
+            <a:pPr algn="l"/>
+            <a:r>
+              <a:rPr sz="1100" b="1">
+                <a:solidFill>
+                  <a:srgbClr val="F4A97F"/>
+                </a:solidFill>
+                <a:latin typeface="Calibri"/>
+              </a:rPr>
+              <a:t>LEITURA DE MERCADO</a:t>
+            </a:r>
+          </a:p>
+        </p:txBody>
+      </p:sp>
+      <p:sp>
+        <p:nvSpPr>
+          <p:cNvPr id="5" name="TextBox 4"/>
+          <p:cNvSpPr txBox="1"/>
+          <p:nvPr/>
+        </p:nvSpPr>
+        <p:spPr>
+          <a:xfrm>
+            <a:off x="457200" y="365760"/>
+            <a:ext cx="11338560" cy="603504"/>
+          </a:xfrm>
+          <a:prstGeom prst="rect">
+            <a:avLst/>
+          </a:prstGeom>
+          <a:noFill/>
+        </p:spPr>
+        <p:txBody>
+          <a:bodyPr wrap="square" anchor="t">
+            <a:spAutoFit/>
+          </a:bodyPr>
+          <a:lstStyle/>
+          <a:p>
+            <a:pPr algn="l"/>
+            <a:r>
+              <a:rPr sz="2200" b="1">
+                <a:solidFill>
+                  <a:srgbClr val="FFFFFF"/>
+                </a:solidFill>
+                <a:latin typeface="Calibri"/>
+              </a:rPr>
+              <a:t>Sumário executivo — o que importa para o Comitê</a:t>
+            </a:r>
+          </a:p>
+        </p:txBody>
+      </p:sp>
+      <p:sp>
+        <p:nvSpPr>
+          <p:cNvPr id="6" name="Rectangle 5"/>
+          <p:cNvSpPr/>
+          <p:nvPr/>
+        </p:nvSpPr>
+        <p:spPr>
+          <a:xfrm>
+            <a:off x="457200" y="1371600"/>
+            <a:ext cx="128016" cy="1051560"/>
+          </a:xfrm>
+          <a:prstGeom prst="rect">
+            <a:avLst/>
+          </a:prstGeom>
+          <a:solidFill>
+            <a:srgbClr val="E8703A"/>
+          </a:solidFill>
+          <a:ln>
+            <a:noFill/>
+          </a:ln>
+          <a:effectLst/>
+        </p:spPr>
+        <p:style>
+          <a:lnRef idx="1">
+            <a:schemeClr val="accent1"/>
+          </a:lnRef>
+          <a:fillRef idx="3">
+            <a:schemeClr val="accent1"/>
+          </a:fillRef>
+          <a:effectRef idx="2">
+            <a:schemeClr val="accent1"/>
+          </a:effectRef>
+          <a:fontRef idx="minor">
+            <a:schemeClr val="lt1"/>
+          </a:fontRef>
+        </p:style>
+        <p:txBody>
+          <a:bodyPr rtlCol="0" anchor="ctr"/>
+          <a:lstStyle/>
+          <a:p>
+            <a:pPr algn="ctr"/>
+          </a:p>
+        </p:txBody>
+      </p:sp>
+      <p:sp>
+        <p:nvSpPr>
+          <p:cNvPr id="7" name="TextBox 6"/>
+          <p:cNvSpPr txBox="1"/>
+          <p:nvPr/>
+        </p:nvSpPr>
+        <p:spPr>
+          <a:xfrm>
+            <a:off x="731520" y="1389888"/>
+            <a:ext cx="4206240" cy="1051560"/>
+          </a:xfrm>
+          <a:prstGeom prst="rect">
+            <a:avLst/>
+          </a:prstGeom>
+          <a:noFill/>
+        </p:spPr>
+        <p:txBody>
+          <a:bodyPr wrap="square" anchor="ctr">
+            <a:spAutoFit/>
+          </a:bodyPr>
+          <a:lstStyle/>
+          <a:p>
+            <a:pPr algn="l"/>
+            <a:r>
+              <a:rPr sz="1500" b="1">
+                <a:solidFill>
+                  <a:srgbClr val="1F2A44"/>
+                </a:solidFill>
+                <a:latin typeface="Calibri"/>
+              </a:rPr>
+              <a:t>O mercado dobrou</a:t>
+            </a:r>
+          </a:p>
+        </p:txBody>
+      </p:sp>
+      <p:sp>
+        <p:nvSpPr>
+          <p:cNvPr id="8" name="TextBox 7"/>
+          <p:cNvSpPr txBox="1"/>
+          <p:nvPr/>
+        </p:nvSpPr>
+        <p:spPr>
+          <a:xfrm>
+            <a:off x="4846320" y="1389888"/>
+            <a:ext cx="2834640" cy="1051560"/>
+          </a:xfrm>
+          <a:prstGeom prst="rect">
+            <a:avLst/>
+          </a:prstGeom>
+          <a:noFill/>
+        </p:spPr>
+        <p:txBody>
+          <a:bodyPr wrap="square" anchor="ctr">
+            <a:spAutoFit/>
+          </a:bodyPr>
+          <a:lstStyle/>
+          <a:p>
+            <a:pPr algn="l"/>
+            <a:r>
+              <a:rPr sz="1500" b="1">
+                <a:solidFill>
+                  <a:srgbClr val="E8703A"/>
+                </a:solidFill>
+                <a:latin typeface="Calibri"/>
+              </a:rPr>
+              <a:t>R$ 52 → 880 bi (ex-FIC)</a:t>
+            </a:r>
+          </a:p>
+        </p:txBody>
+      </p:sp>
+      <p:sp>
+        <p:nvSpPr>
+          <p:cNvPr id="9" name="TextBox 8"/>
+          <p:cNvSpPr txBox="1"/>
+          <p:nvPr/>
+        </p:nvSpPr>
+        <p:spPr>
+          <a:xfrm>
+            <a:off x="7772400" y="1389888"/>
+            <a:ext cx="4114800" cy="1051560"/>
+          </a:xfrm>
+          <a:prstGeom prst="rect">
+            <a:avLst/>
+          </a:prstGeom>
+          <a:noFill/>
+        </p:spPr>
+        <p:txBody>
+          <a:bodyPr wrap="square" anchor="ctr">
+            <a:spAutoFit/>
+          </a:bodyPr>
+          <a:lstStyle/>
+          <a:p>
+            <a:pPr algn="l"/>
+            <a:r>
+              <a:rPr sz="1100" b="0">
+                <a:solidFill>
+                  <a:srgbClr val="1A1A1A"/>
+                </a:solidFill>
+                <a:latin typeface="Calibri"/>
+              </a:rPr>
+              <a:t>Indústria de FIDC praticamente dobrou em ~2,5 anos, puxada por crédito estruturado.</a:t>
+            </a:r>
+          </a:p>
+        </p:txBody>
+      </p:sp>
+      <p:sp>
+        <p:nvSpPr>
+          <p:cNvPr id="10" name="Rectangle 9"/>
+          <p:cNvSpPr/>
+          <p:nvPr/>
+        </p:nvSpPr>
+        <p:spPr>
+          <a:xfrm>
+            <a:off x="457200" y="2542032"/>
+            <a:ext cx="128016" cy="1051560"/>
+          </a:xfrm>
+          <a:prstGeom prst="rect">
+            <a:avLst/>
+          </a:prstGeom>
+          <a:solidFill>
+            <a:srgbClr val="E8703A"/>
+          </a:solidFill>
+          <a:ln>
+            <a:noFill/>
+          </a:ln>
+          <a:effectLst/>
+        </p:spPr>
+        <p:style>
+          <a:lnRef idx="1">
+            <a:schemeClr val="accent1"/>
+          </a:lnRef>
+          <a:fillRef idx="3">
+            <a:schemeClr val="accent1"/>
+          </a:fillRef>
+          <a:effectRef idx="2">
+            <a:schemeClr val="accent1"/>
+          </a:effectRef>
+          <a:fontRef idx="minor">
+            <a:schemeClr val="lt1"/>
+          </a:fontRef>
+        </p:style>
+        <p:txBody>
+          <a:bodyPr rtlCol="0" anchor="ctr"/>
+          <a:lstStyle/>
+          <a:p>
+            <a:pPr algn="ctr"/>
+          </a:p>
+        </p:txBody>
+      </p:sp>
+      <p:sp>
+        <p:nvSpPr>
+          <p:cNvPr id="11" name="TextBox 10"/>
+          <p:cNvSpPr txBox="1"/>
+          <p:nvPr/>
+        </p:nvSpPr>
+        <p:spPr>
+          <a:xfrm>
+            <a:off x="731520" y="2560320"/>
+            <a:ext cx="4206240" cy="1051560"/>
+          </a:xfrm>
+          <a:prstGeom prst="rect">
+            <a:avLst/>
+          </a:prstGeom>
+          <a:noFill/>
+        </p:spPr>
+        <p:txBody>
+          <a:bodyPr wrap="square" anchor="ctr">
+            <a:spAutoFit/>
+          </a:bodyPr>
+          <a:lstStyle/>
+          <a:p>
+            <a:pPr algn="l"/>
+            <a:r>
+              <a:rPr sz="1500" b="1">
+                <a:solidFill>
+                  <a:srgbClr val="1F2A44"/>
+                </a:solidFill>
+                <a:latin typeface="Calibri"/>
+              </a:rPr>
+              <a:t>Independentes dominam a gestão</a:t>
+            </a:r>
+          </a:p>
+        </p:txBody>
+      </p:sp>
+      <p:sp>
+        <p:nvSpPr>
+          <p:cNvPr id="12" name="TextBox 11"/>
+          <p:cNvSpPr txBox="1"/>
+          <p:nvPr/>
+        </p:nvSpPr>
+        <p:spPr>
+          <a:xfrm>
+            <a:off x="4846320" y="2560320"/>
+            <a:ext cx="2834640" cy="1051560"/>
+          </a:xfrm>
+          <a:prstGeom prst="rect">
+            <a:avLst/>
+          </a:prstGeom>
+          <a:noFill/>
+        </p:spPr>
+        <p:txBody>
+          <a:bodyPr wrap="square" anchor="ctr">
+            <a:spAutoFit/>
+          </a:bodyPr>
+          <a:lstStyle/>
+          <a:p>
+            <a:pPr algn="l"/>
+            <a:r>
+              <a:rPr sz="1500" b="1">
+                <a:solidFill>
+                  <a:srgbClr val="E8703A"/>
+                </a:solidFill>
+                <a:latin typeface="Calibri"/>
+              </a:rPr>
+              <a:t>65% do PL (R$ 625 bi)</a:t>
+            </a:r>
+          </a:p>
+        </p:txBody>
+      </p:sp>
+      <p:sp>
+        <p:nvSpPr>
+          <p:cNvPr id="13" name="TextBox 12"/>
+          <p:cNvSpPr txBox="1"/>
+          <p:nvPr/>
+        </p:nvSpPr>
+        <p:spPr>
+          <a:xfrm>
+            <a:off x="7772400" y="2560320"/>
+            <a:ext cx="4114800" cy="1051560"/>
+          </a:xfrm>
+          <a:prstGeom prst="rect">
+            <a:avLst/>
+          </a:prstGeom>
+          <a:noFill/>
+        </p:spPr>
+        <p:txBody>
+          <a:bodyPr wrap="square" anchor="ctr">
+            <a:spAutoFit/>
+          </a:bodyPr>
+          <a:lstStyle/>
+          <a:p>
+            <a:pPr algn="l"/>
+            <a:r>
+              <a:rPr sz="1100" b="0">
+                <a:solidFill>
+                  <a:srgbClr val="1A1A1A"/>
+                </a:solidFill>
+                <a:latin typeface="Calibri"/>
+              </a:rPr>
+              <a:t>A gestão migrou para fora dos bancos de varejo; independentes lideram.</a:t>
+            </a:r>
+          </a:p>
+        </p:txBody>
+      </p:sp>
+      <p:sp>
+        <p:nvSpPr>
+          <p:cNvPr id="14" name="Rectangle 13"/>
+          <p:cNvSpPr/>
+          <p:nvPr/>
+        </p:nvSpPr>
+        <p:spPr>
+          <a:xfrm>
+            <a:off x="457200" y="3712464"/>
+            <a:ext cx="128016" cy="1051560"/>
+          </a:xfrm>
+          <a:prstGeom prst="rect">
+            <a:avLst/>
+          </a:prstGeom>
+          <a:solidFill>
+            <a:srgbClr val="E8703A"/>
+          </a:solidFill>
+          <a:ln>
+            <a:noFill/>
+          </a:ln>
+          <a:effectLst/>
+        </p:spPr>
+        <p:style>
+          <a:lnRef idx="1">
+            <a:schemeClr val="accent1"/>
+          </a:lnRef>
+          <a:fillRef idx="3">
+            <a:schemeClr val="accent1"/>
+          </a:fillRef>
+          <a:effectRef idx="2">
+            <a:schemeClr val="accent1"/>
+          </a:effectRef>
+          <a:fontRef idx="minor">
+            <a:schemeClr val="lt1"/>
+          </a:fontRef>
+        </p:style>
+        <p:txBody>
+          <a:bodyPr rtlCol="0" anchor="ctr"/>
+          <a:lstStyle/>
+          <a:p>
+            <a:pPr algn="ctr"/>
+          </a:p>
+        </p:txBody>
+      </p:sp>
+      <p:sp>
+        <p:nvSpPr>
+          <p:cNvPr id="15" name="TextBox 14"/>
+          <p:cNvSpPr txBox="1"/>
+          <p:nvPr/>
+        </p:nvSpPr>
+        <p:spPr>
+          <a:xfrm>
+            <a:off x="731520" y="3730752"/>
+            <a:ext cx="4206240" cy="1051560"/>
+          </a:xfrm>
+          <a:prstGeom prst="rect">
+            <a:avLst/>
+          </a:prstGeom>
+          <a:noFill/>
+        </p:spPr>
+        <p:txBody>
+          <a:bodyPr wrap="square" anchor="ctr">
+            <a:spAutoFit/>
+          </a:bodyPr>
+          <a:lstStyle/>
+          <a:p>
+            <a:pPr algn="l"/>
+            <a:r>
+              <a:rPr sz="1500" b="1">
+                <a:solidFill>
+                  <a:srgbClr val="1F2A44"/>
+                </a:solidFill>
+                <a:latin typeface="Calibri"/>
+              </a:rPr>
+              <a:t>A briga é administração/custódia</a:t>
+            </a:r>
+          </a:p>
+        </p:txBody>
+      </p:sp>
+      <p:sp>
+        <p:nvSpPr>
+          <p:cNvPr id="16" name="TextBox 15"/>
+          <p:cNvSpPr txBox="1"/>
+          <p:nvPr/>
+        </p:nvSpPr>
+        <p:spPr>
+          <a:xfrm>
+            <a:off x="4846320" y="3730752"/>
+            <a:ext cx="2834640" cy="1051560"/>
+          </a:xfrm>
+          <a:prstGeom prst="rect">
+            <a:avLst/>
+          </a:prstGeom>
+          <a:noFill/>
+        </p:spPr>
+        <p:txBody>
+          <a:bodyPr wrap="square" anchor="ctr">
+            <a:spAutoFit/>
+          </a:bodyPr>
+          <a:lstStyle/>
+          <a:p>
+            <a:pPr algn="l"/>
+            <a:r>
+              <a:rPr sz="1500" b="1">
+                <a:solidFill>
+                  <a:srgbClr val="E8703A"/>
+                </a:solidFill>
+                <a:latin typeface="Calibri"/>
+              </a:rPr>
+              <a:t>BTG 146 · QI Tech 139 · Itaú 32 bi</a:t>
+            </a:r>
+          </a:p>
+        </p:txBody>
+      </p:sp>
+      <p:sp>
+        <p:nvSpPr>
+          <p:cNvPr id="17" name="TextBox 16"/>
+          <p:cNvSpPr txBox="1"/>
+          <p:nvPr/>
+        </p:nvSpPr>
+        <p:spPr>
+          <a:xfrm>
+            <a:off x="7772400" y="3730752"/>
+            <a:ext cx="4114800" cy="1051560"/>
+          </a:xfrm>
+          <a:prstGeom prst="rect">
+            <a:avLst/>
+          </a:prstGeom>
+          <a:noFill/>
+        </p:spPr>
+        <p:txBody>
+          <a:bodyPr wrap="square" anchor="ctr">
+            <a:spAutoFit/>
+          </a:bodyPr>
+          <a:lstStyle/>
+          <a:p>
+            <a:pPr algn="l"/>
+            <a:r>
+              <a:rPr sz="1100" b="0">
+                <a:solidFill>
+                  <a:srgbClr val="1A1A1A"/>
+                </a:solidFill>
+                <a:latin typeface="Calibri"/>
+              </a:rPr>
+              <a:t>Itaú administra ~4–5x menos que BTG e QI Tech — o gap a endereçar.</a:t>
+            </a:r>
+          </a:p>
+        </p:txBody>
+      </p:sp>
+      <p:sp>
+        <p:nvSpPr>
+          <p:cNvPr id="18" name="Rectangle 17"/>
+          <p:cNvSpPr/>
+          <p:nvPr/>
+        </p:nvSpPr>
+        <p:spPr>
+          <a:xfrm>
+            <a:off x="457200" y="4882896"/>
+            <a:ext cx="128016" cy="1051560"/>
+          </a:xfrm>
+          <a:prstGeom prst="rect">
+            <a:avLst/>
+          </a:prstGeom>
+          <a:solidFill>
+            <a:srgbClr val="E8703A"/>
+          </a:solidFill>
+          <a:ln>
+            <a:noFill/>
+          </a:ln>
+          <a:effectLst/>
+        </p:spPr>
+        <p:style>
+          <a:lnRef idx="1">
+            <a:schemeClr val="accent1"/>
+          </a:lnRef>
+          <a:fillRef idx="3">
+            <a:schemeClr val="accent1"/>
+          </a:fillRef>
+          <a:effectRef idx="2">
+            <a:schemeClr val="accent1"/>
+          </a:effectRef>
+          <a:fontRef idx="minor">
+            <a:schemeClr val="lt1"/>
+          </a:fontRef>
+        </p:style>
+        <p:txBody>
+          <a:bodyPr rtlCol="0" anchor="ctr"/>
+          <a:lstStyle/>
+          <a:p>
+            <a:pPr algn="ctr"/>
+          </a:p>
+        </p:txBody>
+      </p:sp>
+      <p:sp>
+        <p:nvSpPr>
+          <p:cNvPr id="19" name="TextBox 18"/>
+          <p:cNvSpPr txBox="1"/>
+          <p:nvPr/>
+        </p:nvSpPr>
+        <p:spPr>
+          <a:xfrm>
+            <a:off x="731520" y="4901184"/>
+            <a:ext cx="4206240" cy="1051560"/>
+          </a:xfrm>
+          <a:prstGeom prst="rect">
+            <a:avLst/>
+          </a:prstGeom>
+          <a:noFill/>
+        </p:spPr>
+        <p:txBody>
+          <a:bodyPr wrap="square" anchor="ctr">
+            <a:spAutoFit/>
+          </a:bodyPr>
+          <a:lstStyle/>
+          <a:p>
+            <a:pPr algn="l"/>
+            <a:r>
+              <a:rPr sz="1500" b="1">
+                <a:solidFill>
+                  <a:srgbClr val="1F2A44"/>
+                </a:solidFill>
+                <a:latin typeface="Calibri"/>
+              </a:rPr>
+              <a:t>Crédito colado a pagamentos</a:t>
+            </a:r>
+          </a:p>
+        </p:txBody>
+      </p:sp>
+      <p:sp>
+        <p:nvSpPr>
+          <p:cNvPr id="20" name="TextBox 19"/>
+          <p:cNvSpPr txBox="1"/>
+          <p:nvPr/>
+        </p:nvSpPr>
+        <p:spPr>
+          <a:xfrm>
+            <a:off x="4846320" y="4901184"/>
+            <a:ext cx="2834640" cy="1051560"/>
+          </a:xfrm>
+          <a:prstGeom prst="rect">
+            <a:avLst/>
+          </a:prstGeom>
+          <a:noFill/>
+        </p:spPr>
+        <p:txBody>
+          <a:bodyPr wrap="square" anchor="ctr">
+            <a:spAutoFit/>
+          </a:bodyPr>
+          <a:lstStyle/>
+          <a:p>
+            <a:pPr algn="l"/>
+            <a:r>
+              <a:rPr sz="1500" b="1">
+                <a:solidFill>
+                  <a:srgbClr val="E8703A"/>
+                </a:solidFill>
+                <a:latin typeface="Calibri"/>
+              </a:rPr>
+              <a:t>Maior sacado: Mercado Pago (R$ 5,7 bi)</a:t>
+            </a:r>
+          </a:p>
+        </p:txBody>
+      </p:sp>
+      <p:sp>
+        <p:nvSpPr>
+          <p:cNvPr id="21" name="TextBox 20"/>
+          <p:cNvSpPr txBox="1"/>
+          <p:nvPr/>
+        </p:nvSpPr>
+        <p:spPr>
+          <a:xfrm>
+            <a:off x="7772400" y="4901184"/>
+            <a:ext cx="4114800" cy="1051560"/>
+          </a:xfrm>
+          <a:prstGeom prst="rect">
+            <a:avLst/>
+          </a:prstGeom>
+          <a:noFill/>
+        </p:spPr>
+        <p:txBody>
+          <a:bodyPr wrap="square" anchor="ctr">
+            <a:spAutoFit/>
+          </a:bodyPr>
+          <a:lstStyle/>
+          <a:p>
+            <a:pPr algn="l"/>
+            <a:r>
+              <a:rPr sz="1100" b="0">
+                <a:solidFill>
+                  <a:srgbClr val="1A1A1A"/>
+                </a:solidFill>
+                <a:latin typeface="Calibri"/>
+              </a:rPr>
+              <a:t>Grandes sacados são plataformas de pagamento/varejo (Mercado Pago, SafraPay, Casas Bahia).</a:t>
+            </a:r>
+          </a:p>
+        </p:txBody>
+      </p:sp>
+      <p:sp>
+        <p:nvSpPr>
+          <p:cNvPr id="22" name="TextBox 21"/>
+          <p:cNvSpPr txBox="1"/>
+          <p:nvPr/>
+        </p:nvSpPr>
+        <p:spPr>
+          <a:xfrm>
+            <a:off x="457200" y="6400800"/>
+            <a:ext cx="11338560" cy="411480"/>
+          </a:xfrm>
+          <a:prstGeom prst="rect">
+            <a:avLst/>
+          </a:prstGeom>
+          <a:noFill/>
+        </p:spPr>
+        <p:txBody>
+          <a:bodyPr wrap="square" anchor="t">
+            <a:spAutoFit/>
+          </a:bodyPr>
+          <a:lstStyle/>
+          <a:p>
+            <a:pPr algn="l"/>
+            <a:r>
+              <a:rPr sz="800" b="0">
+                <a:solidFill>
+                  <a:srgbClr val="8A94A6"/>
+                </a:solidFill>
+                <a:latin typeface="Calibri"/>
+              </a:rPr>
+              <a:t>Fonte: Síntese das dimensões do Toma Conta (gestor/admin/custodiante/segmento) consolidadas por conglomerado.</a:t>
+            </a:r>
+          </a:p>
+        </p:txBody>
+      </p:sp>
+    </p:spTree>
+  </p:cSld>
+  <p:clrMapOvr>
+    <a:masterClrMapping/>
+  </p:clrMapOvr>
+</p:sld>
+</file>
+
+<file path=ppt/slides/slide3.xml><?xml version="1.0" encoding="utf-8"?>
 <p:sld xmlns:a="http://schemas.openxmlformats.org/drawingml/2006/main" xmlns:p="http://schemas.openxmlformats.org/presentationml/2006/main" xmlns:r="http://schemas.openxmlformats.org/officeDocument/2006/relationships">
   <p:cSld>
     <p:spTree>
@@ -14661,7 +18375,7 @@
 </p:sld>
 </file>
 
-<file path=ppt/slides/slide3.xml><?xml version="1.0" encoding="utf-8"?>
+<file path=ppt/slides/slide4.xml><?xml version="1.0" encoding="utf-8"?>
 <p:sld xmlns:a="http://schemas.openxmlformats.org/drawingml/2006/main" xmlns:p="http://schemas.openxmlformats.org/presentationml/2006/main" xmlns:r="http://schemas.openxmlformats.org/officeDocument/2006/relationships">
   <p:cSld>
     <p:spTree>
@@ -14890,7 +18604,7 @@
 </p:sld>
 </file>
 
-<file path=ppt/slides/slide4.xml><?xml version="1.0" encoding="utf-8"?>
+<file path=ppt/slides/slide5.xml><?xml version="1.0" encoding="utf-8"?>
 <p:sld xmlns:a="http://schemas.openxmlformats.org/drawingml/2006/main" xmlns:p="http://schemas.openxmlformats.org/presentationml/2006/main" xmlns:r="http://schemas.openxmlformats.org/officeDocument/2006/relationships">
   <p:cSld>
     <p:spTree>
@@ -15671,7 +19385,7 @@
 </p:sld>
 </file>
 
-<file path=ppt/slides/slide5.xml><?xml version="1.0" encoding="utf-8"?>
+<file path=ppt/slides/slide6.xml><?xml version="1.0" encoding="utf-8"?>
 <p:sld xmlns:a="http://schemas.openxmlformats.org/drawingml/2006/main" xmlns:p="http://schemas.openxmlformats.org/presentationml/2006/main" xmlns:r="http://schemas.openxmlformats.org/officeDocument/2006/relationships">
   <p:cSld>
     <p:spTree>
@@ -15900,7 +19614,7 @@
 </p:sld>
 </file>
 
-<file path=ppt/slides/slide6.xml><?xml version="1.0" encoding="utf-8"?>
+<file path=ppt/slides/slide7.xml><?xml version="1.0" encoding="utf-8"?>
 <p:sld xmlns:a="http://schemas.openxmlformats.org/drawingml/2006/main" xmlns:p="http://schemas.openxmlformats.org/presentationml/2006/main" xmlns:r="http://schemas.openxmlformats.org/officeDocument/2006/relationships">
   <p:cSld>
     <p:spTree>
@@ -18561,7 +22275,7 @@
 </p:sld>
 </file>
 
-<file path=ppt/slides/slide7.xml><?xml version="1.0" encoding="utf-8"?>
+<file path=ppt/slides/slide8.xml><?xml version="1.0" encoding="utf-8"?>
 <p:sld xmlns:a="http://schemas.openxmlformats.org/drawingml/2006/main" xmlns:p="http://schemas.openxmlformats.org/presentationml/2006/main" xmlns:r="http://schemas.openxmlformats.org/officeDocument/2006/relationships">
   <p:cSld>
     <p:spTree>
@@ -18790,7 +22504,7 @@
 </p:sld>
 </file>
 
-<file path=ppt/slides/slide8.xml><?xml version="1.0" encoding="utf-8"?>
+<file path=ppt/slides/slide9.xml><?xml version="1.0" encoding="utf-8"?>
 <p:sld xmlns:a="http://schemas.openxmlformats.org/drawingml/2006/main" xmlns:p="http://schemas.openxmlformats.org/presentationml/2006/main" xmlns:r="http://schemas.openxmlformats.org/officeDocument/2006/relationships">
   <p:cSld>
     <p:spTree>
@@ -21439,375 +25153,6 @@
                 <a:latin typeface="Calibri"/>
               </a:rPr>
               <a:t>Fonte: Toma Conta FIDCs — dimensão 'administrador', consolidado por conglomerado (de-para por CNPJ). Origem: Informe Mensal FIDC/CVM.</a:t>
-            </a:r>
-          </a:p>
-        </p:txBody>
-      </p:sp>
-    </p:spTree>
-  </p:cSld>
-  <p:clrMapOvr>
-    <a:masterClrMapping/>
-  </p:clrMapOvr>
-</p:sld>
-</file>
-
-<file path=ppt/slides/slide9.xml><?xml version="1.0" encoding="utf-8"?>
-<p:sld xmlns:a="http://schemas.openxmlformats.org/drawingml/2006/main" xmlns:p="http://schemas.openxmlformats.org/presentationml/2006/main" xmlns:r="http://schemas.openxmlformats.org/officeDocument/2006/relationships">
-  <p:cSld>
-    <p:spTree>
-      <p:nvGrpSpPr>
-        <p:cNvPr id="1" name=""/>
-        <p:cNvGrpSpPr/>
-        <p:nvPr/>
-      </p:nvGrpSpPr>
-      <p:grpSpPr/>
-      <p:sp>
-        <p:nvSpPr>
-          <p:cNvPr id="2" name="Rectangle 1"/>
-          <p:cNvSpPr/>
-          <p:nvPr/>
-        </p:nvSpPr>
-        <p:spPr>
-          <a:xfrm>
-            <a:off x="0" y="0"/>
-            <a:ext cx="12191695" cy="1024128"/>
-          </a:xfrm>
-          <a:prstGeom prst="rect">
-            <a:avLst/>
-          </a:prstGeom>
-          <a:solidFill>
-            <a:srgbClr val="1F2A44"/>
-          </a:solidFill>
-          <a:ln>
-            <a:noFill/>
-          </a:ln>
-          <a:effectLst/>
-        </p:spPr>
-        <p:style>
-          <a:lnRef idx="1">
-            <a:schemeClr val="accent1"/>
-          </a:lnRef>
-          <a:fillRef idx="3">
-            <a:schemeClr val="accent1"/>
-          </a:fillRef>
-          <a:effectRef idx="2">
-            <a:schemeClr val="accent1"/>
-          </a:effectRef>
-          <a:fontRef idx="minor">
-            <a:schemeClr val="lt1"/>
-          </a:fontRef>
-        </p:style>
-        <p:txBody>
-          <a:bodyPr rtlCol="0" anchor="ctr"/>
-          <a:lstStyle/>
-          <a:p>
-            <a:pPr algn="ctr"/>
-          </a:p>
-        </p:txBody>
-      </p:sp>
-      <p:sp>
-        <p:nvSpPr>
-          <p:cNvPr id="3" name="Rectangle 2"/>
-          <p:cNvSpPr/>
-          <p:nvPr/>
-        </p:nvSpPr>
-        <p:spPr>
-          <a:xfrm>
-            <a:off x="0" y="1024128"/>
-            <a:ext cx="12191695" cy="45720"/>
-          </a:xfrm>
-          <a:prstGeom prst="rect">
-            <a:avLst/>
-          </a:prstGeom>
-          <a:solidFill>
-            <a:srgbClr val="E8703A"/>
-          </a:solidFill>
-          <a:ln>
-            <a:noFill/>
-          </a:ln>
-          <a:effectLst/>
-        </p:spPr>
-        <p:style>
-          <a:lnRef idx="1">
-            <a:schemeClr val="accent1"/>
-          </a:lnRef>
-          <a:fillRef idx="3">
-            <a:schemeClr val="accent1"/>
-          </a:fillRef>
-          <a:effectRef idx="2">
-            <a:schemeClr val="accent1"/>
-          </a:effectRef>
-          <a:fontRef idx="minor">
-            <a:schemeClr val="lt1"/>
-          </a:fontRef>
-        </p:style>
-        <p:txBody>
-          <a:bodyPr rtlCol="0" anchor="ctr"/>
-          <a:lstStyle/>
-          <a:p>
-            <a:pPr algn="ctr"/>
-          </a:p>
-        </p:txBody>
-      </p:sp>
-      <p:sp>
-        <p:nvSpPr>
-          <p:cNvPr id="4" name="TextBox 3"/>
-          <p:cNvSpPr txBox="1"/>
-          <p:nvPr/>
-        </p:nvSpPr>
-        <p:spPr>
-          <a:xfrm>
-            <a:off x="457200" y="118872"/>
-            <a:ext cx="10972800" cy="274320"/>
-          </a:xfrm>
-          <a:prstGeom prst="rect">
-            <a:avLst/>
-          </a:prstGeom>
-          <a:noFill/>
-        </p:spPr>
-        <p:txBody>
-          <a:bodyPr wrap="square" anchor="t">
-            <a:spAutoFit/>
-          </a:bodyPr>
-          <a:lstStyle/>
-          <a:p>
-            <a:pPr algn="l"/>
-            <a:r>
-              <a:rPr sz="1100" b="1">
-                <a:solidFill>
-                  <a:srgbClr val="F4A97F"/>
-                </a:solidFill>
-                <a:latin typeface="Calibri"/>
-              </a:rPr>
-              <a:t>INDEPENDENTES X BANCOS</a:t>
-            </a:r>
-          </a:p>
-        </p:txBody>
-      </p:sp>
-      <p:sp>
-        <p:nvSpPr>
-          <p:cNvPr id="5" name="TextBox 4"/>
-          <p:cNvSpPr txBox="1"/>
-          <p:nvPr/>
-        </p:nvSpPr>
-        <p:spPr>
-          <a:xfrm>
-            <a:off x="457200" y="365760"/>
-            <a:ext cx="11338560" cy="603504"/>
-          </a:xfrm>
-          <a:prstGeom prst="rect">
-            <a:avLst/>
-          </a:prstGeom>
-          <a:noFill/>
-        </p:spPr>
-        <p:txBody>
-          <a:bodyPr wrap="square" anchor="t">
-            <a:spAutoFit/>
-          </a:bodyPr>
-          <a:lstStyle/>
-          <a:p>
-            <a:pPr algn="l"/>
-            <a:r>
-              <a:rPr sz="2200" b="1">
-                <a:solidFill>
-                  <a:srgbClr val="FFFFFF"/>
-                </a:solidFill>
-                <a:latin typeface="Calibri"/>
-              </a:rPr>
-              <a:t>PL por tipo de controle do gestor — evolução (R$ bi)</a:t>
-            </a:r>
-          </a:p>
-        </p:txBody>
-      </p:sp>
-      <p:graphicFrame>
-        <p:nvGraphicFramePr>
-          <p:cNvPr id="6" name="Chart 5"/>
-          <p:cNvGraphicFramePr>
-            <a:graphicFrameLocks noGrp="1"/>
-          </p:cNvGraphicFramePr>
-          <p:nvPr/>
-        </p:nvGraphicFramePr>
-        <p:xfrm>
-          <a:off x="457200" y="1325880"/>
-          <a:ext cx="7955279" cy="4663440"/>
-        </p:xfrm>
-        <a:graphic>
-          <a:graphicData uri="http://schemas.openxmlformats.org/drawingml/2006/chart">
-            <c:chart xmlns:c="http://schemas.openxmlformats.org/drawingml/2006/chart" r:id="rId2"/>
-          </a:graphicData>
-        </a:graphic>
-      </p:graphicFrame>
-      <p:sp>
-        <p:nvSpPr>
-          <p:cNvPr id="7" name="TextBox 6"/>
-          <p:cNvSpPr txBox="1"/>
-          <p:nvPr/>
-        </p:nvSpPr>
-        <p:spPr>
-          <a:xfrm>
-            <a:off x="8686800" y="1737360"/>
-            <a:ext cx="3291840" cy="548640"/>
-          </a:xfrm>
-          <a:prstGeom prst="rect">
-            <a:avLst/>
-          </a:prstGeom>
-          <a:noFill/>
-        </p:spPr>
-        <p:txBody>
-          <a:bodyPr wrap="square" anchor="t">
-            <a:spAutoFit/>
-          </a:bodyPr>
-          <a:lstStyle/>
-          <a:p>
-            <a:pPr algn="l"/>
-            <a:r>
-              <a:rPr sz="1300" b="1">
-                <a:solidFill>
-                  <a:srgbClr val="E8703A"/>
-                </a:solidFill>
-                <a:latin typeface="Calibri"/>
-              </a:rPr>
-              <a:t>Independente: R$ 625 bi (65%)</a:t>
-            </a:r>
-          </a:p>
-        </p:txBody>
-      </p:sp>
-      <p:sp>
-        <p:nvSpPr>
-          <p:cNvPr id="8" name="TextBox 7"/>
-          <p:cNvSpPr txBox="1"/>
-          <p:nvPr/>
-        </p:nvSpPr>
-        <p:spPr>
-          <a:xfrm>
-            <a:off x="8686800" y="2377439"/>
-            <a:ext cx="3291840" cy="548640"/>
-          </a:xfrm>
-          <a:prstGeom prst="rect">
-            <a:avLst/>
-          </a:prstGeom>
-          <a:noFill/>
-        </p:spPr>
-        <p:txBody>
-          <a:bodyPr wrap="square" anchor="t">
-            <a:spAutoFit/>
-          </a:bodyPr>
-          <a:lstStyle/>
-          <a:p>
-            <a:pPr algn="l"/>
-            <a:r>
-              <a:rPr sz="1300" b="1">
-                <a:solidFill>
-                  <a:srgbClr val="1F2A44"/>
-                </a:solidFill>
-                <a:latin typeface="Calibri"/>
-              </a:rPr>
-              <a:t>Ligada a banco: R$ 252 bi (26%)</a:t>
-            </a:r>
-          </a:p>
-        </p:txBody>
-      </p:sp>
-      <p:sp>
-        <p:nvSpPr>
-          <p:cNvPr id="9" name="TextBox 8"/>
-          <p:cNvSpPr txBox="1"/>
-          <p:nvPr/>
-        </p:nvSpPr>
-        <p:spPr>
-          <a:xfrm>
-            <a:off x="8686800" y="3017520"/>
-            <a:ext cx="3291840" cy="548640"/>
-          </a:xfrm>
-          <a:prstGeom prst="rect">
-            <a:avLst/>
-          </a:prstGeom>
-          <a:noFill/>
-        </p:spPr>
-        <p:txBody>
-          <a:bodyPr wrap="square" anchor="t">
-            <a:spAutoFit/>
-          </a:bodyPr>
-          <a:lstStyle/>
-          <a:p>
-            <a:pPr algn="l"/>
-            <a:r>
-              <a:rPr sz="1300" b="1">
-                <a:solidFill>
-                  <a:srgbClr val="8A94A6"/>
-                </a:solidFill>
-                <a:latin typeface="Calibri"/>
-              </a:rPr>
-              <a:t>Independente Grande: R$ 81 bi (8%)</a:t>
-            </a:r>
-          </a:p>
-        </p:txBody>
-      </p:sp>
-      <p:sp>
-        <p:nvSpPr>
-          <p:cNvPr id="10" name="TextBox 9"/>
-          <p:cNvSpPr txBox="1"/>
-          <p:nvPr/>
-        </p:nvSpPr>
-        <p:spPr>
-          <a:xfrm>
-            <a:off x="8686800" y="3749039"/>
-            <a:ext cx="3383280" cy="1828800"/>
-          </a:xfrm>
-          <a:prstGeom prst="rect">
-            <a:avLst/>
-          </a:prstGeom>
-          <a:noFill/>
-        </p:spPr>
-        <p:txBody>
-          <a:bodyPr wrap="square" anchor="t">
-            <a:spAutoFit/>
-          </a:bodyPr>
-          <a:lstStyle/>
-          <a:p>
-            <a:pPr algn="l"/>
-            <a:r>
-              <a:rPr sz="1000" b="0">
-                <a:solidFill>
-                  <a:srgbClr val="8A94A6"/>
-                </a:solidFill>
-                <a:latin typeface="Calibri"/>
-              </a:rPr>
-              <a:t>Definição de controle conforme rodapé do deck Itaú BBA. 'Independente Grande' = Oliveira Trust, BRL Trust, BR Trust.</a:t>
-            </a:r>
-          </a:p>
-        </p:txBody>
-      </p:sp>
-      <p:sp>
-        <p:nvSpPr>
-          <p:cNvPr id="11" name="TextBox 10"/>
-          <p:cNvSpPr txBox="1"/>
-          <p:nvPr/>
-        </p:nvSpPr>
-        <p:spPr>
-          <a:xfrm>
-            <a:off x="457200" y="6400800"/>
-            <a:ext cx="11338560" cy="411480"/>
-          </a:xfrm>
-          <a:prstGeom prst="rect">
-            <a:avLst/>
-          </a:prstGeom>
-          <a:noFill/>
-        </p:spPr>
-        <p:txBody>
-          <a:bodyPr wrap="square" anchor="t">
-            <a:spAutoFit/>
-          </a:bodyPr>
-          <a:lstStyle/>
-          <a:p>
-            <a:pPr algn="l"/>
-            <a:r>
-              <a:rPr sz="800" b="0">
-                <a:solidFill>
-                  <a:srgbClr val="8A94A6"/>
-                </a:solidFill>
-                <a:latin typeface="Calibri"/>
-              </a:rPr>
-              <a:t>Fonte: Toma Conta FIDCs — dimensão 'gestor' + taxonomia de controle (Ligada a banco / Independente Grande / Independente; definição do rodapé do deck Itaú BBA).</a:t>
             </a:r>
           </a:p>
         </p:txBody>

</xml_diff>

<commit_message>
Fix exec-summary baseline to 2023 for the 'doubled in ~2.5y' message
</commit_message>
<xml_diff>
--- a/outputs/Industria_FIDC_2026-05.pptx
+++ b/outputs/Industria_FIDC_2026-05.pptx
@@ -17420,7 +17420,7 @@
                 </a:solidFill>
                 <a:latin typeface="Calibri"/>
               </a:rPr>
-              <a:t>R$ 52 → 880 bi (ex-FIC)</a:t>
+              <a:t>R$ 386 (2023) → 880 bi</a:t>
             </a:r>
           </a:p>
         </p:txBody>
@@ -17455,7 +17455,7 @@
                 </a:solidFill>
                 <a:latin typeface="Calibri"/>
               </a:rPr>
-              <a:t>Indústria de FIDC praticamente dobrou em ~2,5 anos, puxada por crédito estruturado.</a:t>
+              <a:t>Indústria de FIDC dobrou em ~2,5 anos (ex-FIC), puxada por crédito estruturado.</a:t>
             </a:r>
           </a:p>
         </p:txBody>

</xml_diff>

<commit_message>
Add methodology/audit doc + deepen market share, investors, methodology slide
- docs/METODOLOGIA_E_AUDITORIA.md: adversarial audit of every metric (source,
  formula, universe, filters, double-counting, sampling bias, reproducibility,
  verdict); source divergences (CVM gross 959 / ex-FIC 880 / ANBIMA net); cedente
  universe made explicit (569 parsed regulamentos, 2024-26 biased sample, 141
  named); sacado limits; investor identification by category (CVM Tab X_1_1,
  nominal barred by sigilo) + distribution stats; secondary-market verdict (no
  free granular data; paid ANBIMA Feed/B3; no invented liquidity metric).
- Deck: market-share delta highlight now includes delta # funds; cotista
  distribution percentiles on cotistas slide; methodology slide.
- reports/crosscheck_itau.md and reports/insights_industria_fidc.md remain the
  narrative layer.
</commit_message>
<xml_diff>
--- a/outputs/Industria_FIDC_2026-05.pptx
+++ b/outputs/Industria_FIDC_2026-05.pptx
@@ -24,6 +24,7 @@
     <p:sldId id="272" r:id="rId23"/>
     <p:sldId id="273" r:id="rId24"/>
     <p:sldId id="274" r:id="rId25"/>
+    <p:sldId id="275" r:id="rId26"/>
   </p:sldIdLst>
   <p:sldSz cx="12191695" cy="6858000" type="screen4x3"/>
   <p:notesSz cx="6858000" cy="9144000"/>
@@ -16005,8 +16006,8 @@
           <p:nvPr/>
         </p:nvGraphicFramePr>
         <p:xfrm>
-          <a:off x="8046720" y="2194560"/>
-          <a:ext cx="3749038" cy="2286000"/>
+          <a:off x="8046720" y="1920240"/>
+          <a:ext cx="3749038" cy="2011680"/>
         </p:xfrm>
         <a:graphic>
           <a:graphicData uri="http://schemas.openxmlformats.org/drawingml/2006/table">
@@ -16019,7 +16020,7 @@
                 <a:gridCol w="986589"/>
                 <a:gridCol w="1183907"/>
               </a:tblGrid>
-              <a:tr h="457200">
+              <a:tr h="402336">
                 <a:tc>
                   <a:txBody>
                     <a:bodyPr/>
@@ -16090,7 +16091,7 @@
                   </a:tcPr>
                 </a:tc>
               </a:tr>
-              <a:tr h="457200">
+              <a:tr h="402336">
                 <a:tc>
                   <a:txBody>
                     <a:bodyPr/>
@@ -16161,7 +16162,7 @@
                   </a:tcPr>
                 </a:tc>
               </a:tr>
-              <a:tr h="457200">
+              <a:tr h="402336">
                 <a:tc>
                   <a:txBody>
                     <a:bodyPr/>
@@ -16232,7 +16233,7 @@
                   </a:tcPr>
                 </a:tc>
               </a:tr>
-              <a:tr h="457200">
+              <a:tr h="402336">
                 <a:tc>
                   <a:txBody>
                     <a:bodyPr/>
@@ -16303,7 +16304,7 @@
                   </a:tcPr>
                 </a:tc>
               </a:tr>
-              <a:tr h="457200">
+              <a:tr h="402336">
                 <a:tc>
                   <a:txBody>
                     <a:bodyPr/>
@@ -16381,6 +16382,77 @@
       <p:sp>
         <p:nvSpPr>
           <p:cNvPr id="9" name="TextBox 8"/>
+          <p:cNvSpPr txBox="1"/>
+          <p:nvPr/>
+        </p:nvSpPr>
+        <p:spPr>
+          <a:xfrm>
+            <a:off x="8046720" y="4206240"/>
+            <a:ext cx="3931920" cy="1737360"/>
+          </a:xfrm>
+          <a:prstGeom prst="rect">
+            <a:avLst/>
+          </a:prstGeom>
+          <a:noFill/>
+        </p:spPr>
+        <p:txBody>
+          <a:bodyPr wrap="square" anchor="t">
+            <a:spAutoFit/>
+          </a:bodyPr>
+          <a:lstStyle/>
+          <a:p>
+            <a:pPr algn="l"/>
+            <a:r>
+              <a:rPr sz="1100" b="0">
+                <a:solidFill>
+                  <a:srgbClr val="1A1A1A"/>
+                </a:solidFill>
+                <a:latin typeface="Calibri"/>
+              </a:rPr>
+              <a:t>Distribuição (todos os fundos):</a:t>
+            </a:r>
+          </a:p>
+          <a:p>
+            <a:pPr algn="l"/>
+            <a:r>
+              <a:rPr sz="1100" b="0">
+                <a:solidFill>
+                  <a:srgbClr val="1A1A1A"/>
+                </a:solidFill>
+                <a:latin typeface="Calibri"/>
+              </a:rPr>
+              <a:t>mediana 4 · média 106 cotistas</a:t>
+            </a:r>
+          </a:p>
+          <a:p>
+            <a:pPr algn="l"/>
+            <a:r>
+              <a:rPr sz="1100" b="0">
+                <a:solidFill>
+                  <a:srgbClr val="1A1A1A"/>
+                </a:solidFill>
+                <a:latin typeface="Calibri"/>
+              </a:rPr>
+              <a:t>p90 64 · p95 158 · p99 3,064</a:t>
+            </a:r>
+          </a:p>
+          <a:p>
+            <a:pPr algn="l"/>
+            <a:r>
+              <a:rPr sz="1100" b="0">
+                <a:solidFill>
+                  <a:srgbClr val="1A1A1A"/>
+                </a:solidFill>
+                <a:latin typeface="Calibri"/>
+              </a:rPr>
+              <a:t>40% dos fundos têm ≤ 2 cotistas</a:t>
+            </a:r>
+          </a:p>
+        </p:txBody>
+      </p:sp>
+      <p:sp>
+        <p:nvSpPr>
+          <p:cNvPr id="10" name="TextBox 9"/>
           <p:cNvSpPr txBox="1"/>
           <p:nvPr/>
         </p:nvSpPr>
@@ -17426,7 +17498,7 @@
                 </a:solidFill>
                 <a:latin typeface="Calibri"/>
               </a:rPr>
-              <a:t>TRANSPARÊNCIA</a:t>
+              <a:t>DEFENSABILIDADE</a:t>
             </a:r>
           </a:p>
         </p:txBody>
@@ -17461,901 +17533,844 @@
                 </a:solidFill>
                 <a:latin typeface="Calibri"/>
               </a:rPr>
-              <a:t>Fonte exata por gráfico</a:t>
+              <a:t>Metodologia — como cada número foi obtido</a:t>
             </a:r>
           </a:p>
         </p:txBody>
       </p:sp>
-      <p:graphicFrame>
-        <p:nvGraphicFramePr>
-          <p:cNvPr id="6" name="Table 5"/>
-          <p:cNvGraphicFramePr>
-            <a:graphicFrameLocks noGrp="1"/>
-          </p:cNvGraphicFramePr>
+      <p:sp>
+        <p:nvSpPr>
+          <p:cNvPr id="6" name="Rectangle 5"/>
+          <p:cNvSpPr/>
           <p:nvPr/>
-        </p:nvGraphicFramePr>
-        <p:xfrm>
-          <a:off x="365760" y="1280160"/>
-          <a:ext cx="11521439" cy="5029200"/>
-        </p:xfrm>
-        <a:graphic>
-          <a:graphicData uri="http://schemas.openxmlformats.org/drawingml/2006/table">
-            <a:tbl>
-              <a:tblPr firstRow="1" bandRow="1">
-                <a:tableStyleId>{5C22544A-7EE6-4342-B048-85BDC9FD1C3A}</a:tableStyleId>
-              </a:tblPr>
-              <a:tblGrid>
-                <a:gridCol w="1920239"/>
-                <a:gridCol w="9601200"/>
-              </a:tblGrid>
-              <a:tr h="279400">
-                <a:tc>
-                  <a:txBody>
-                    <a:bodyPr/>
-                    <a:lstStyle/>
-                    <a:p>
-                      <a:pPr algn="ctr"/>
-                      <a:r>
-                        <a:rPr sz="800" b="1">
-                          <a:solidFill>
-                            <a:srgbClr val="FFFFFF"/>
-                          </a:solidFill>
-                          <a:latin typeface="Calibri"/>
-                        </a:rPr>
-                        <a:t>Gráfico</a:t>
-                      </a:r>
-                    </a:p>
-                  </a:txBody>
-                  <a:tcPr anchor="ctr" marT="9144" marB="9144">
-                    <a:solidFill>
-                      <a:srgbClr val="1F2A44"/>
-                    </a:solidFill>
-                  </a:tcPr>
-                </a:tc>
-                <a:tc>
-                  <a:txBody>
-                    <a:bodyPr/>
-                    <a:lstStyle/>
-                    <a:p>
-                      <a:pPr algn="ctr"/>
-                      <a:r>
-                        <a:rPr sz="800" b="1">
-                          <a:solidFill>
-                            <a:srgbClr val="FFFFFF"/>
-                          </a:solidFill>
-                          <a:latin typeface="Calibri"/>
-                        </a:rPr>
-                        <a:t>Fonte</a:t>
-                      </a:r>
-                    </a:p>
-                  </a:txBody>
-                  <a:tcPr anchor="ctr" marT="9144" marB="9144">
-                    <a:solidFill>
-                      <a:srgbClr val="1F2A44"/>
-                    </a:solidFill>
-                  </a:tcPr>
-                </a:tc>
-              </a:tr>
-              <a:tr h="279400">
-                <a:tc>
-                  <a:txBody>
-                    <a:bodyPr/>
-                    <a:lstStyle/>
-                    <a:p>
-                      <a:pPr algn="l"/>
-                      <a:r>
-                        <a:rPr sz="800">
-                          <a:solidFill>
-                            <a:srgbClr val="1A1A1A"/>
-                          </a:solidFill>
-                          <a:latin typeface="Calibri"/>
-                        </a:rPr>
-                        <a:t>PL</a:t>
-                      </a:r>
-                    </a:p>
-                  </a:txBody>
-                  <a:tcPr anchor="ctr" marT="4572" marB="4572">
-                    <a:solidFill>
-                      <a:srgbClr val="F3F5F8"/>
-                    </a:solidFill>
-                  </a:tcPr>
-                </a:tc>
-                <a:tc>
-                  <a:txBody>
-                    <a:bodyPr/>
-                    <a:lstStyle/>
-                    <a:p>
-                      <a:pPr algn="l"/>
-                      <a:r>
-                        <a:rPr sz="800">
-                          <a:solidFill>
-                            <a:srgbClr val="1A1A1A"/>
-                          </a:solidFill>
-                          <a:latin typeface="Calibri"/>
-                        </a:rPr>
-                        <a:t>Toma Conta FIDCs — aba Indústria (série mensal, base ex-FIC-FIDC). Origem: Informe Mensal FIDC/CVM. NÃO usa o Power BI/dashboard ANBIMA (dados presos no visual).</a:t>
-                      </a:r>
-                    </a:p>
-                  </a:txBody>
-                  <a:tcPr anchor="ctr" marT="4572" marB="4572">
-                    <a:solidFill>
-                      <a:srgbClr val="F3F5F8"/>
-                    </a:solidFill>
-                  </a:tcPr>
-                </a:tc>
-              </a:tr>
-              <a:tr h="279400">
-                <a:tc>
-                  <a:txBody>
-                    <a:bodyPr/>
-                    <a:lstStyle/>
-                    <a:p>
-                      <a:pPr algn="l"/>
-                      <a:r>
-                        <a:rPr sz="800">
-                          <a:solidFill>
-                            <a:srgbClr val="1A1A1A"/>
-                          </a:solidFill>
-                          <a:latin typeface="Calibri"/>
-                        </a:rPr>
-                        <a:t>COMPOSICAO</a:t>
-                      </a:r>
-                    </a:p>
-                  </a:txBody>
-                  <a:tcPr anchor="ctr" marT="4572" marB="4572">
-                    <a:solidFill>
-                      <a:srgbClr val="FFFFFF"/>
-                    </a:solidFill>
-                  </a:tcPr>
-                </a:tc>
-                <a:tc>
-                  <a:txBody>
-                    <a:bodyPr/>
-                    <a:lstStyle/>
-                    <a:p>
-                      <a:pPr algn="l"/>
-                      <a:r>
-                        <a:rPr sz="800">
-                          <a:solidFill>
-                            <a:srgbClr val="1A1A1A"/>
-                          </a:solidFill>
-                          <a:latin typeface="Calibri"/>
-                        </a:rPr>
-                        <a:t>Toma Conta FIDCs — dimensão 'segmento' (série mensal). Taxonomia interna alinhada às classes ANBIMA. Origem: Informe Mensal FIDC/CVM.</a:t>
-                      </a:r>
-                    </a:p>
-                  </a:txBody>
-                  <a:tcPr anchor="ctr" marT="4572" marB="4572">
-                    <a:solidFill>
-                      <a:srgbClr val="FFFFFF"/>
-                    </a:solidFill>
-                  </a:tcPr>
-                </a:tc>
-              </a:tr>
-              <a:tr h="279400">
-                <a:tc>
-                  <a:txBody>
-                    <a:bodyPr/>
-                    <a:lstStyle/>
-                    <a:p>
-                      <a:pPr algn="l"/>
-                      <a:r>
-                        <a:rPr sz="800">
-                          <a:solidFill>
-                            <a:srgbClr val="1A1A1A"/>
-                          </a:solidFill>
-                          <a:latin typeface="Calibri"/>
-                        </a:rPr>
-                        <a:t>DEFINICOES</a:t>
-                      </a:r>
-                    </a:p>
-                  </a:txBody>
-                  <a:tcPr anchor="ctr" marT="4572" marB="4572">
-                    <a:solidFill>
-                      <a:srgbClr val="F3F5F8"/>
-                    </a:solidFill>
-                  </a:tcPr>
-                </a:tc>
-                <a:tc>
-                  <a:txBody>
-                    <a:bodyPr/>
-                    <a:lstStyle/>
-                    <a:p>
-                      <a:pPr algn="l"/>
-                      <a:r>
-                        <a:rPr sz="800">
-                          <a:solidFill>
-                            <a:srgbClr val="1A1A1A"/>
-                          </a:solidFill>
-                          <a:latin typeface="Calibri"/>
-                        </a:rPr>
-                        <a:t>ANBIMA — Deliberação nº 72 (Diretriz de Classificação de FIDC).</a:t>
-                      </a:r>
-                    </a:p>
-                  </a:txBody>
-                  <a:tcPr anchor="ctr" marT="4572" marB="4572">
-                    <a:solidFill>
-                      <a:srgbClr val="F3F5F8"/>
-                    </a:solidFill>
-                  </a:tcPr>
-                </a:tc>
-              </a:tr>
-              <a:tr h="279400">
-                <a:tc>
-                  <a:txBody>
-                    <a:bodyPr/>
-                    <a:lstStyle/>
-                    <a:p>
-                      <a:pPr algn="l"/>
-                      <a:r>
-                        <a:rPr sz="800">
-                          <a:solidFill>
-                            <a:srgbClr val="1A1A1A"/>
-                          </a:solidFill>
-                          <a:latin typeface="Calibri"/>
-                        </a:rPr>
-                        <a:t>GESTOR</a:t>
-                      </a:r>
-                    </a:p>
-                  </a:txBody>
-                  <a:tcPr anchor="ctr" marT="4572" marB="4572">
-                    <a:solidFill>
-                      <a:srgbClr val="FFFFFF"/>
-                    </a:solidFill>
-                  </a:tcPr>
-                </a:tc>
-                <a:tc>
-                  <a:txBody>
-                    <a:bodyPr/>
-                    <a:lstStyle/>
-                    <a:p>
-                      <a:pPr algn="l"/>
-                      <a:r>
-                        <a:rPr sz="800">
-                          <a:solidFill>
-                            <a:srgbClr val="1A1A1A"/>
-                          </a:solidFill>
-                          <a:latin typeface="Calibri"/>
-                        </a:rPr>
-                        <a:t>Toma Conta FIDCs — dimensão 'gestor', consolidado por conglomerado (de-para por CNPJ). Origem: Cadastro CVM (gestor) + Informe Mensal (PL).</a:t>
-                      </a:r>
-                    </a:p>
-                  </a:txBody>
-                  <a:tcPr anchor="ctr" marT="4572" marB="4572">
-                    <a:solidFill>
-                      <a:srgbClr val="FFFFFF"/>
-                    </a:solidFill>
-                  </a:tcPr>
-                </a:tc>
-              </a:tr>
-              <a:tr h="279400">
-                <a:tc>
-                  <a:txBody>
-                    <a:bodyPr/>
-                    <a:lstStyle/>
-                    <a:p>
-                      <a:pPr algn="l"/>
-                      <a:r>
-                        <a:rPr sz="800">
-                          <a:solidFill>
-                            <a:srgbClr val="1A1A1A"/>
-                          </a:solidFill>
-                          <a:latin typeface="Calibri"/>
-                        </a:rPr>
-                        <a:t>ADMIN</a:t>
-                      </a:r>
-                    </a:p>
-                  </a:txBody>
-                  <a:tcPr anchor="ctr" marT="4572" marB="4572">
-                    <a:solidFill>
-                      <a:srgbClr val="F3F5F8"/>
-                    </a:solidFill>
-                  </a:tcPr>
-                </a:tc>
-                <a:tc>
-                  <a:txBody>
-                    <a:bodyPr/>
-                    <a:lstStyle/>
-                    <a:p>
-                      <a:pPr algn="l"/>
-                      <a:r>
-                        <a:rPr sz="800">
-                          <a:solidFill>
-                            <a:srgbClr val="1A1A1A"/>
-                          </a:solidFill>
-                          <a:latin typeface="Calibri"/>
-                        </a:rPr>
-                        <a:t>Toma Conta FIDCs — dimensão 'administrador', consolidado por conglomerado (de-para por CNPJ). Origem: Informe Mensal FIDC/CVM.</a:t>
-                      </a:r>
-                    </a:p>
-                  </a:txBody>
-                  <a:tcPr anchor="ctr" marT="4572" marB="4572">
-                    <a:solidFill>
-                      <a:srgbClr val="F3F5F8"/>
-                    </a:solidFill>
-                  </a:tcPr>
-                </a:tc>
-              </a:tr>
-              <a:tr h="279400">
-                <a:tc>
-                  <a:txBody>
-                    <a:bodyPr/>
-                    <a:lstStyle/>
-                    <a:p>
-                      <a:pPr algn="l"/>
-                      <a:r>
-                        <a:rPr sz="800">
-                          <a:solidFill>
-                            <a:srgbClr val="1A1A1A"/>
-                          </a:solidFill>
-                          <a:latin typeface="Calibri"/>
-                        </a:rPr>
-                        <a:t>CONTROLE</a:t>
-                      </a:r>
-                    </a:p>
-                  </a:txBody>
-                  <a:tcPr anchor="ctr" marT="4572" marB="4572">
-                    <a:solidFill>
-                      <a:srgbClr val="FFFFFF"/>
-                    </a:solidFill>
-                  </a:tcPr>
-                </a:tc>
-                <a:tc>
-                  <a:txBody>
-                    <a:bodyPr/>
-                    <a:lstStyle/>
-                    <a:p>
-                      <a:pPr algn="l"/>
-                      <a:r>
-                        <a:rPr sz="800">
-                          <a:solidFill>
-                            <a:srgbClr val="1A1A1A"/>
-                          </a:solidFill>
-                          <a:latin typeface="Calibri"/>
-                        </a:rPr>
-                        <a:t>Toma Conta FIDCs — dimensão 'gestor' + taxonomia de controle (Ligada a banco / Independente Grande / Independente; definição do rodapé do deck Itaú BBA).</a:t>
-                      </a:r>
-                    </a:p>
-                  </a:txBody>
-                  <a:tcPr anchor="ctr" marT="4572" marB="4572">
-                    <a:solidFill>
-                      <a:srgbClr val="FFFFFF"/>
-                    </a:solidFill>
-                  </a:tcPr>
-                </a:tc>
-              </a:tr>
-              <a:tr h="279400">
-                <a:tc>
-                  <a:txBody>
-                    <a:bodyPr/>
-                    <a:lstStyle/>
-                    <a:p>
-                      <a:pPr algn="l"/>
-                      <a:r>
-                        <a:rPr sz="800">
-                          <a:solidFill>
-                            <a:srgbClr val="1A1A1A"/>
-                          </a:solidFill>
-                          <a:latin typeface="Calibri"/>
-                        </a:rPr>
-                        <a:t>DEPARA</a:t>
-                      </a:r>
-                    </a:p>
-                  </a:txBody>
-                  <a:tcPr anchor="ctr" marT="4572" marB="4572">
-                    <a:solidFill>
-                      <a:srgbClr val="F3F5F8"/>
-                    </a:solidFill>
-                  </a:tcPr>
-                </a:tc>
-                <a:tc>
-                  <a:txBody>
-                    <a:bodyPr/>
-                    <a:lstStyle/>
-                    <a:p>
-                      <a:pPr algn="l"/>
-                      <a:r>
-                        <a:rPr sz="800">
-                          <a:solidFill>
-                            <a:srgbClr val="1A1A1A"/>
-                          </a:solidFill>
-                          <a:latin typeface="Calibri"/>
-                        </a:rPr>
-                        <a:t>De-para próprio, verificado por CNPJ contra industry_fund_snapshot (mai/2026). Config: config/conglomerados_fidc.json.</a:t>
-                      </a:r>
-                    </a:p>
-                  </a:txBody>
-                  <a:tcPr anchor="ctr" marT="4572" marB="4572">
-                    <a:solidFill>
-                      <a:srgbClr val="F3F5F8"/>
-                    </a:solidFill>
-                  </a:tcPr>
-                </a:tc>
-              </a:tr>
-              <a:tr h="279400">
-                <a:tc>
-                  <a:txBody>
-                    <a:bodyPr/>
-                    <a:lstStyle/>
-                    <a:p>
-                      <a:pPr algn="l"/>
-                      <a:r>
-                        <a:rPr sz="800">
-                          <a:solidFill>
-                            <a:srgbClr val="1A1A1A"/>
-                          </a:solidFill>
-                          <a:latin typeface="Calibri"/>
-                        </a:rPr>
-                        <a:t>TOP25</a:t>
-                      </a:r>
-                    </a:p>
-                  </a:txBody>
-                  <a:tcPr anchor="ctr" marT="4572" marB="4572">
-                    <a:solidFill>
-                      <a:srgbClr val="FFFFFF"/>
-                    </a:solidFill>
-                  </a:tcPr>
-                </a:tc>
-                <a:tc>
-                  <a:txBody>
-                    <a:bodyPr/>
-                    <a:lstStyle/>
-                    <a:p>
-                      <a:pPr algn="l"/>
-                      <a:r>
-                        <a:rPr sz="800">
-                          <a:solidFill>
-                            <a:srgbClr val="1A1A1A"/>
-                          </a:solidFill>
-                          <a:latin typeface="Calibri"/>
-                        </a:rPr>
-                        <a:t>Toma Conta FIDCs — snapshot por fundo (PL, gestor consolidado, leituras de segmento/oferta/subordinação quando há regulamento parseado). Origem: Informe Mensal FIDC/CVM + leituras regulatórias do Toma Conta.</a:t>
-                      </a:r>
-                    </a:p>
-                  </a:txBody>
-                  <a:tcPr anchor="ctr" marT="4572" marB="4572">
-                    <a:solidFill>
-                      <a:srgbClr val="FFFFFF"/>
-                    </a:solidFill>
-                  </a:tcPr>
-                </a:tc>
-              </a:tr>
-              <a:tr h="279400">
-                <a:tc>
-                  <a:txBody>
-                    <a:bodyPr/>
-                    <a:lstStyle/>
-                    <a:p>
-                      <a:pPr algn="l"/>
-                      <a:r>
-                        <a:rPr sz="800">
-                          <a:solidFill>
-                            <a:srgbClr val="1A1A1A"/>
-                          </a:solidFill>
-                          <a:latin typeface="Calibri"/>
-                        </a:rPr>
-                        <a:t>COTISTAS</a:t>
-                      </a:r>
-                    </a:p>
-                  </a:txBody>
-                  <a:tcPr anchor="ctr" marT="4572" marB="4572">
-                    <a:solidFill>
-                      <a:srgbClr val="F3F5F8"/>
-                    </a:solidFill>
-                  </a:tcPr>
-                </a:tc>
-                <a:tc>
-                  <a:txBody>
-                    <a:bodyPr/>
-                    <a:lstStyle/>
-                    <a:p>
-                      <a:pPr algn="l"/>
-                      <a:r>
-                        <a:rPr sz="800">
-                          <a:solidFill>
-                            <a:srgbClr val="1A1A1A"/>
-                          </a:solidFill>
-                          <a:latin typeface="Calibri"/>
-                        </a:rPr>
-                        <a:t>Informe Mensal FIDC/CVM — Tabela X (nº de cotistas) via Toma Conta. Filtro PL &gt; R$ 200 mi.</a:t>
-                      </a:r>
-                    </a:p>
-                  </a:txBody>
-                  <a:tcPr anchor="ctr" marT="4572" marB="4572">
-                    <a:solidFill>
-                      <a:srgbClr val="F3F5F8"/>
-                    </a:solidFill>
-                  </a:tcPr>
-                </a:tc>
-              </a:tr>
-              <a:tr h="279400">
-                <a:tc>
-                  <a:txBody>
-                    <a:bodyPr/>
-                    <a:lstStyle/>
-                    <a:p>
-                      <a:pPr algn="l"/>
-                      <a:r>
-                        <a:rPr sz="800">
-                          <a:solidFill>
-                            <a:srgbClr val="1A1A1A"/>
-                          </a:solidFill>
-                          <a:latin typeface="Calibri"/>
-                        </a:rPr>
-                        <a:t>INVESTIDOR</a:t>
-                      </a:r>
-                    </a:p>
-                  </a:txBody>
-                  <a:tcPr anchor="ctr" marT="4572" marB="4572">
-                    <a:solidFill>
-                      <a:srgbClr val="FFFFFF"/>
-                    </a:solidFill>
-                  </a:tcPr>
-                </a:tc>
-                <a:tc>
-                  <a:txBody>
-                    <a:bodyPr/>
-                    <a:lstStyle/>
-                    <a:p>
-                      <a:pPr algn="l"/>
-                      <a:r>
-                        <a:rPr sz="800">
-                          <a:solidFill>
-                            <a:srgbClr val="1A1A1A"/>
-                          </a:solidFill>
-                          <a:latin typeface="Calibri"/>
-                        </a:rPr>
-                        <a:t>Informe Mensal FIDC/CVM — nº de cotistas por segmento de investidor, via Toma Conta.</a:t>
-                      </a:r>
-                    </a:p>
-                  </a:txBody>
-                  <a:tcPr anchor="ctr" marT="4572" marB="4572">
-                    <a:solidFill>
-                      <a:srgbClr val="FFFFFF"/>
-                    </a:solidFill>
-                  </a:tcPr>
-                </a:tc>
-              </a:tr>
-              <a:tr h="279400">
-                <a:tc>
-                  <a:txBody>
-                    <a:bodyPr/>
-                    <a:lstStyle/>
-                    <a:p>
-                      <a:pPr algn="l"/>
-                      <a:r>
-                        <a:rPr sz="800">
-                          <a:solidFill>
-                            <a:srgbClr val="1A1A1A"/>
-                          </a:solidFill>
-                          <a:latin typeface="Calibri"/>
-                        </a:rPr>
-                        <a:t>EMISSOES</a:t>
-                      </a:r>
-                    </a:p>
-                  </a:txBody>
-                  <a:tcPr anchor="ctr" marT="4572" marB="4572">
-                    <a:solidFill>
-                      <a:srgbClr val="F3F5F8"/>
-                    </a:solidFill>
-                  </a:tcPr>
-                </a:tc>
-                <a:tc>
-                  <a:txBody>
-                    <a:bodyPr/>
-                    <a:lstStyle/>
-                    <a:p>
-                      <a:pPr algn="l"/>
-                      <a:r>
-                        <a:rPr sz="800">
-                          <a:solidFill>
-                            <a:srgbClr val="1A1A1A"/>
-                          </a:solidFill>
-                          <a:latin typeface="Calibri"/>
-                        </a:rPr>
-                        <a:t>Toma Conta FIDCs — variação anual de PL (ex-FIC) e captação líquida (dimensão mensal). Métrica preferida: variação de PL. Validação de magnitude: ANBIMA (imprensa, 2024). NÃO é o campo 'emissões encerradas'.</a:t>
-                      </a:r>
-                    </a:p>
-                  </a:txBody>
-                  <a:tcPr anchor="ctr" marT="4572" marB="4572">
-                    <a:solidFill>
-                      <a:srgbClr val="F3F5F8"/>
-                    </a:solidFill>
-                  </a:tcPr>
-                </a:tc>
-              </a:tr>
-              <a:tr h="279400">
-                <a:tc>
-                  <a:txBody>
-                    <a:bodyPr/>
-                    <a:lstStyle/>
-                    <a:p>
-                      <a:pPr algn="l"/>
-                      <a:r>
-                        <a:rPr sz="800">
-                          <a:solidFill>
-                            <a:srgbClr val="1A1A1A"/>
-                          </a:solidFill>
-                          <a:latin typeface="Calibri"/>
-                        </a:rPr>
-                        <a:t>PARTES</a:t>
-                      </a:r>
-                    </a:p>
-                  </a:txBody>
-                  <a:tcPr anchor="ctr" marT="4572" marB="4572">
-                    <a:solidFill>
-                      <a:srgbClr val="FFFFFF"/>
-                    </a:solidFill>
-                  </a:tcPr>
-                </a:tc>
-                <a:tc>
-                  <a:txBody>
-                    <a:bodyPr/>
-                    <a:lstStyle/>
-                    <a:p>
-                      <a:pPr algn="l"/>
-                      <a:r>
-                        <a:rPr sz="800">
-                          <a:solidFill>
-                            <a:srgbClr val="1A1A1A"/>
-                          </a:solidFill>
-                          <a:latin typeface="Calibri"/>
-                        </a:rPr>
-                        <a:t>Toma Conta FIDCs — leitura de regulamentos (cedentes/sacados nomeados, materialidade por PL de fundo). Base: reports/fidc_clean_named_parties.</a:t>
-                      </a:r>
-                    </a:p>
-                  </a:txBody>
-                  <a:tcPr anchor="ctr" marT="4572" marB="4572">
-                    <a:solidFill>
-                      <a:srgbClr val="FFFFFF"/>
-                    </a:solidFill>
-                  </a:tcPr>
-                </a:tc>
-              </a:tr>
-              <a:tr h="279400">
-                <a:tc>
-                  <a:txBody>
-                    <a:bodyPr/>
-                    <a:lstStyle/>
-                    <a:p>
-                      <a:pPr algn="l"/>
-                      <a:r>
-                        <a:rPr sz="800">
-                          <a:solidFill>
-                            <a:srgbClr val="1A1A1A"/>
-                          </a:solidFill>
-                          <a:latin typeface="Calibri"/>
-                        </a:rPr>
-                        <a:t>SUMARIO</a:t>
-                      </a:r>
-                    </a:p>
-                  </a:txBody>
-                  <a:tcPr anchor="ctr" marT="4572" marB="4572">
-                    <a:solidFill>
-                      <a:srgbClr val="F3F5F8"/>
-                    </a:solidFill>
-                  </a:tcPr>
-                </a:tc>
-                <a:tc>
-                  <a:txBody>
-                    <a:bodyPr/>
-                    <a:lstStyle/>
-                    <a:p>
-                      <a:pPr algn="l"/>
-                      <a:r>
-                        <a:rPr sz="800">
-                          <a:solidFill>
-                            <a:srgbClr val="1A1A1A"/>
-                          </a:solidFill>
-                          <a:latin typeface="Calibri"/>
-                        </a:rPr>
-                        <a:t>Síntese das dimensões do Toma Conta (gestor/admin/custodiante/segmento) consolidadas por conglomerado.</a:t>
-                      </a:r>
-                    </a:p>
-                  </a:txBody>
-                  <a:tcPr anchor="ctr" marT="4572" marB="4572">
-                    <a:solidFill>
-                      <a:srgbClr val="F3F5F8"/>
-                    </a:solidFill>
-                  </a:tcPr>
-                </a:tc>
-              </a:tr>
-              <a:tr h="279400">
-                <a:tc>
-                  <a:txBody>
-                    <a:bodyPr/>
-                    <a:lstStyle/>
-                    <a:p>
-                      <a:pPr algn="l"/>
-                      <a:r>
-                        <a:rPr sz="800">
-                          <a:solidFill>
-                            <a:srgbClr val="1A1A1A"/>
-                          </a:solidFill>
-                          <a:latin typeface="Calibri"/>
-                        </a:rPr>
-                        <a:t>DELTA_PAPEL</a:t>
-                      </a:r>
-                    </a:p>
-                  </a:txBody>
-                  <a:tcPr anchor="ctr" marT="4572" marB="4572">
-                    <a:solidFill>
-                      <a:srgbClr val="FFFFFF"/>
-                    </a:solidFill>
-                  </a:tcPr>
-                </a:tc>
-                <a:tc>
-                  <a:txBody>
-                    <a:bodyPr/>
-                    <a:lstStyle/>
-                    <a:p>
-                      <a:pPr algn="l"/>
-                      <a:r>
-                        <a:rPr sz="800">
-                          <a:solidFill>
-                            <a:srgbClr val="1A1A1A"/>
-                          </a:solidFill>
-                          <a:latin typeface="Calibri"/>
-                        </a:rPr>
-                        <a:t>Toma Conta FIDCs — dimensão mensal por papel, consolidada por CNPJ. Share = PL do grupo / PL total do papel na competência. Δrank = posição em dez/2023 menos posição em mai/2026. PL de estoque (inclui troca de mandato).</a:t>
-                      </a:r>
-                    </a:p>
-                  </a:txBody>
-                  <a:tcPr anchor="ctr" marT="4572" marB="4572">
-                    <a:solidFill>
-                      <a:srgbClr val="FFFFFF"/>
-                    </a:solidFill>
-                  </a:tcPr>
-                </a:tc>
-              </a:tr>
-              <a:tr h="279400">
-                <a:tc>
-                  <a:txBody>
-                    <a:bodyPr/>
-                    <a:lstStyle/>
-                    <a:p>
-                      <a:pPr algn="l"/>
-                      <a:r>
-                        <a:rPr sz="800">
-                          <a:solidFill>
-                            <a:srgbClr val="1A1A1A"/>
-                          </a:solidFill>
-                          <a:latin typeface="Calibri"/>
-                        </a:rPr>
-                        <a:t>ORIGINACAO</a:t>
-                      </a:r>
-                    </a:p>
-                  </a:txBody>
-                  <a:tcPr anchor="ctr" marT="4572" marB="4572">
-                    <a:solidFill>
-                      <a:srgbClr val="F3F5F8"/>
-                    </a:solidFill>
-                  </a:tcPr>
-                </a:tc>
-                <a:tc>
-                  <a:txBody>
-                    <a:bodyPr/>
-                    <a:lstStyle/>
-                    <a:p>
-                      <a:pPr algn="l"/>
-                      <a:r>
-                        <a:rPr sz="800">
-                          <a:solidFill>
-                            <a:srgbClr val="1A1A1A"/>
-                          </a:solidFill>
-                          <a:latin typeface="Calibri"/>
-                        </a:rPr>
-                        <a:t>Toma Conta FIDCs — fundos por ANO DE 1ª OFERTA (snapshot: first_offer_year). Mede ORIGINAÇÃO (fundo novo), expurgando troca de gestor/adm de fundos já existentes. Cobertura de 1ª oferta: 1.407 de 4.219 fundos.</a:t>
-                      </a:r>
-                    </a:p>
-                  </a:txBody>
-                  <a:tcPr anchor="ctr" marT="4572" marB="4572">
-                    <a:solidFill>
-                      <a:srgbClr val="F3F5F8"/>
-                    </a:solidFill>
-                  </a:tcPr>
-                </a:tc>
-              </a:tr>
-              <a:tr h="279400">
-                <a:tc>
-                  <a:txBody>
-                    <a:bodyPr/>
-                    <a:lstStyle/>
-                    <a:p>
-                      <a:pPr algn="l"/>
-                      <a:r>
-                        <a:rPr sz="800">
-                          <a:solidFill>
-                            <a:srgbClr val="1A1A1A"/>
-                          </a:solidFill>
-                          <a:latin typeface="Calibri"/>
-                        </a:rPr>
-                        <a:t>CAPTACAO</a:t>
-                      </a:r>
-                    </a:p>
-                  </a:txBody>
-                  <a:tcPr anchor="ctr" marT="4572" marB="4572">
-                    <a:solidFill>
-                      <a:srgbClr val="FFFFFF"/>
-                    </a:solidFill>
-                  </a:tcPr>
-                </a:tc>
-                <a:tc>
-                  <a:txBody>
-                    <a:bodyPr/>
-                    <a:lstStyle/>
-                    <a:p>
-                      <a:pPr algn="l"/>
-                      <a:r>
-                        <a:rPr sz="800">
-                          <a:solidFill>
-                            <a:srgbClr val="1A1A1A"/>
-                          </a:solidFill>
-                          <a:latin typeface="Calibri"/>
-                        </a:rPr>
-                        <a:t>Toma Conta FIDCs — captação líquida = captações − resgates no mês (Informe Mensal FIDC/CVM), somada por ano. Complementa a variação de PL.</a:t>
-                      </a:r>
-                    </a:p>
-                  </a:txBody>
-                  <a:tcPr anchor="ctr" marT="4572" marB="4572">
-                    <a:solidFill>
-                      <a:srgbClr val="FFFFFF"/>
-                    </a:solidFill>
-                  </a:tcPr>
-                </a:tc>
-              </a:tr>
-              <a:tr h="279400">
-                <a:tc>
-                  <a:txBody>
-                    <a:bodyPr/>
-                    <a:lstStyle/>
-                    <a:p>
-                      <a:pPr algn="l"/>
-                      <a:r>
-                        <a:rPr sz="800">
-                          <a:solidFill>
-                            <a:srgbClr val="1A1A1A"/>
-                          </a:solidFill>
-                          <a:latin typeface="Calibri"/>
-                        </a:rPr>
-                        <a:t>TOP25DET</a:t>
-                      </a:r>
-                    </a:p>
-                  </a:txBody>
-                  <a:tcPr anchor="ctr" marT="4572" marB="4572">
-                    <a:solidFill>
-                      <a:srgbClr val="F3F5F8"/>
-                    </a:solidFill>
-                  </a:tcPr>
-                </a:tc>
-                <a:tc>
-                  <a:txBody>
-                    <a:bodyPr/>
-                    <a:lstStyle/>
-                    <a:p>
-                      <a:pPr algn="l"/>
-                      <a:r>
-                        <a:rPr sz="800">
-                          <a:solidFill>
-                            <a:srgbClr val="1A1A1A"/>
-                          </a:solidFill>
-                          <a:latin typeface="Calibri"/>
-                        </a:rPr>
-                        <a:t>Informe Mensal Estruturado (CVM), mai/2026 + leituras de regulamento (Toma Conta). Subordinação = PL classe subordinada / PL total (Tab X_2). Cedente = TAB_I2A12 (até 9, com %). Cotistas por investidor = Tab X_1_1.</a:t>
-                      </a:r>
-                    </a:p>
-                  </a:txBody>
-                  <a:tcPr anchor="ctr" marT="4572" marB="4572">
-                    <a:solidFill>
-                      <a:srgbClr val="F3F5F8"/>
-                    </a:solidFill>
-                  </a:tcPr>
-                </a:tc>
-              </a:tr>
-            </a:tbl>
-          </a:graphicData>
-        </a:graphic>
-      </p:graphicFrame>
+        </p:nvSpPr>
+        <p:spPr>
+          <a:xfrm>
+            <a:off x="457200" y="1371600"/>
+            <a:ext cx="2651760" cy="658368"/>
+          </a:xfrm>
+          <a:prstGeom prst="rect">
+            <a:avLst/>
+          </a:prstGeom>
+          <a:solidFill>
+            <a:srgbClr val="1F2A44"/>
+          </a:solidFill>
+          <a:ln>
+            <a:noFill/>
+          </a:ln>
+          <a:effectLst/>
+        </p:spPr>
+        <p:style>
+          <a:lnRef idx="1">
+            <a:schemeClr val="accent1"/>
+          </a:lnRef>
+          <a:fillRef idx="3">
+            <a:schemeClr val="accent1"/>
+          </a:fillRef>
+          <a:effectRef idx="2">
+            <a:schemeClr val="accent1"/>
+          </a:effectRef>
+          <a:fontRef idx="minor">
+            <a:schemeClr val="lt1"/>
+          </a:fontRef>
+        </p:style>
+        <p:txBody>
+          <a:bodyPr rtlCol="0" anchor="ctr"/>
+          <a:lstStyle/>
+          <a:p>
+            <a:pPr algn="ctr"/>
+          </a:p>
+        </p:txBody>
+      </p:sp>
+      <p:sp>
+        <p:nvSpPr>
+          <p:cNvPr id="7" name="TextBox 6"/>
+          <p:cNvSpPr txBox="1"/>
+          <p:nvPr/>
+        </p:nvSpPr>
+        <p:spPr>
+          <a:xfrm>
+            <a:off x="548640" y="1389888"/>
+            <a:ext cx="2514600" cy="621792"/>
+          </a:xfrm>
+          <a:prstGeom prst="rect">
+            <a:avLst/>
+          </a:prstGeom>
+          <a:noFill/>
+        </p:spPr>
+        <p:txBody>
+          <a:bodyPr wrap="square" anchor="ctr">
+            <a:spAutoFit/>
+          </a:bodyPr>
+          <a:lstStyle/>
+          <a:p>
+            <a:pPr algn="l"/>
+            <a:r>
+              <a:rPr sz="1100" b="1">
+                <a:solidFill>
+                  <a:srgbClr val="FFFFFF"/>
+                </a:solidFill>
+                <a:latin typeface="Calibri"/>
+              </a:rPr>
+              <a:t>PL da indústria</a:t>
+            </a:r>
+          </a:p>
+        </p:txBody>
+      </p:sp>
+      <p:sp>
+        <p:nvSpPr>
+          <p:cNvPr id="8" name="TextBox 7"/>
+          <p:cNvSpPr txBox="1"/>
+          <p:nvPr/>
+        </p:nvSpPr>
+        <p:spPr>
+          <a:xfrm>
+            <a:off x="3291840" y="1353312"/>
+            <a:ext cx="8595360" cy="694944"/>
+          </a:xfrm>
+          <a:prstGeom prst="rect">
+            <a:avLst/>
+          </a:prstGeom>
+          <a:noFill/>
+        </p:spPr>
+        <p:txBody>
+          <a:bodyPr wrap="square" anchor="ctr">
+            <a:spAutoFit/>
+          </a:bodyPr>
+          <a:lstStyle/>
+          <a:p>
+            <a:pPr algn="l"/>
+            <a:r>
+              <a:rPr sz="1050" b="0">
+                <a:solidFill>
+                  <a:srgbClr val="1A1A1A"/>
+                </a:solidFill>
+                <a:latin typeface="Calibri"/>
+              </a:rPr>
+              <a:t>Σ TAB_IV_A_VL_PL (CVM). Ex-FIC R$ 880 bi (bruto R$ 959 bi, −R$ 79 bi de FIC-FIDC). Bruto bate exato com CVM cru.</a:t>
+            </a:r>
+          </a:p>
+        </p:txBody>
+      </p:sp>
+      <p:sp>
+        <p:nvSpPr>
+          <p:cNvPr id="9" name="Rectangle 8"/>
+          <p:cNvSpPr/>
+          <p:nvPr/>
+        </p:nvSpPr>
+        <p:spPr>
+          <a:xfrm>
+            <a:off x="457200" y="2066543"/>
+            <a:ext cx="2651760" cy="658368"/>
+          </a:xfrm>
+          <a:prstGeom prst="rect">
+            <a:avLst/>
+          </a:prstGeom>
+          <a:solidFill>
+            <a:srgbClr val="1F2A44"/>
+          </a:solidFill>
+          <a:ln>
+            <a:noFill/>
+          </a:ln>
+          <a:effectLst/>
+        </p:spPr>
+        <p:style>
+          <a:lnRef idx="1">
+            <a:schemeClr val="accent1"/>
+          </a:lnRef>
+          <a:fillRef idx="3">
+            <a:schemeClr val="accent1"/>
+          </a:fillRef>
+          <a:effectRef idx="2">
+            <a:schemeClr val="accent1"/>
+          </a:effectRef>
+          <a:fontRef idx="minor">
+            <a:schemeClr val="lt1"/>
+          </a:fontRef>
+        </p:style>
+        <p:txBody>
+          <a:bodyPr rtlCol="0" anchor="ctr"/>
+          <a:lstStyle/>
+          <a:p>
+            <a:pPr algn="ctr"/>
+          </a:p>
+        </p:txBody>
+      </p:sp>
+      <p:sp>
+        <p:nvSpPr>
+          <p:cNvPr id="10" name="TextBox 9"/>
+          <p:cNvSpPr txBox="1"/>
+          <p:nvPr/>
+        </p:nvSpPr>
+        <p:spPr>
+          <a:xfrm>
+            <a:off x="548640" y="2084831"/>
+            <a:ext cx="2514600" cy="621792"/>
+          </a:xfrm>
+          <a:prstGeom prst="rect">
+            <a:avLst/>
+          </a:prstGeom>
+          <a:noFill/>
+        </p:spPr>
+        <p:txBody>
+          <a:bodyPr wrap="square" anchor="ctr">
+            <a:spAutoFit/>
+          </a:bodyPr>
+          <a:lstStyle/>
+          <a:p>
+            <a:pPr algn="l"/>
+            <a:r>
+              <a:rPr sz="1100" b="1">
+                <a:solidFill>
+                  <a:srgbClr val="FFFFFF"/>
+                </a:solidFill>
+                <a:latin typeface="Calibri"/>
+              </a:rPr>
+              <a:t>Rankings/share por papel</a:t>
+            </a:r>
+          </a:p>
+        </p:txBody>
+      </p:sp>
+      <p:sp>
+        <p:nvSpPr>
+          <p:cNvPr id="11" name="TextBox 10"/>
+          <p:cNvSpPr txBox="1"/>
+          <p:nvPr/>
+        </p:nvSpPr>
+        <p:spPr>
+          <a:xfrm>
+            <a:off x="3291840" y="2048255"/>
+            <a:ext cx="8595360" cy="694944"/>
+          </a:xfrm>
+          <a:prstGeom prst="rect">
+            <a:avLst/>
+          </a:prstGeom>
+          <a:noFill/>
+        </p:spPr>
+        <p:txBody>
+          <a:bodyPr wrap="square" anchor="ctr">
+            <a:spAutoFit/>
+          </a:bodyPr>
+          <a:lstStyle/>
+          <a:p>
+            <a:pPr algn="l"/>
+            <a:r>
+              <a:rPr sz="1050" b="0">
+                <a:solidFill>
+                  <a:srgbClr val="1A1A1A"/>
+                </a:solidFill>
+                <a:latin typeface="Calibri"/>
+              </a:rPr>
+              <a:t>PL do grupo / PL total do papel na competência. Gestor = cadastro CVM vigente (ressalva). Adm/custódia = Informe Mensal.</a:t>
+            </a:r>
+          </a:p>
+        </p:txBody>
+      </p:sp>
+      <p:sp>
+        <p:nvSpPr>
+          <p:cNvPr id="12" name="Rectangle 11"/>
+          <p:cNvSpPr/>
+          <p:nvPr/>
+        </p:nvSpPr>
+        <p:spPr>
+          <a:xfrm>
+            <a:off x="457200" y="2761487"/>
+            <a:ext cx="2651760" cy="658368"/>
+          </a:xfrm>
+          <a:prstGeom prst="rect">
+            <a:avLst/>
+          </a:prstGeom>
+          <a:solidFill>
+            <a:srgbClr val="1F2A44"/>
+          </a:solidFill>
+          <a:ln>
+            <a:noFill/>
+          </a:ln>
+          <a:effectLst/>
+        </p:spPr>
+        <p:style>
+          <a:lnRef idx="1">
+            <a:schemeClr val="accent1"/>
+          </a:lnRef>
+          <a:fillRef idx="3">
+            <a:schemeClr val="accent1"/>
+          </a:fillRef>
+          <a:effectRef idx="2">
+            <a:schemeClr val="accent1"/>
+          </a:effectRef>
+          <a:fontRef idx="minor">
+            <a:schemeClr val="lt1"/>
+          </a:fontRef>
+        </p:style>
+        <p:txBody>
+          <a:bodyPr rtlCol="0" anchor="ctr"/>
+          <a:lstStyle/>
+          <a:p>
+            <a:pPr algn="ctr"/>
+          </a:p>
+        </p:txBody>
+      </p:sp>
+      <p:sp>
+        <p:nvSpPr>
+          <p:cNvPr id="13" name="TextBox 12"/>
+          <p:cNvSpPr txBox="1"/>
+          <p:nvPr/>
+        </p:nvSpPr>
+        <p:spPr>
+          <a:xfrm>
+            <a:off x="548640" y="2779775"/>
+            <a:ext cx="2514600" cy="621792"/>
+          </a:xfrm>
+          <a:prstGeom prst="rect">
+            <a:avLst/>
+          </a:prstGeom>
+          <a:noFill/>
+        </p:spPr>
+        <p:txBody>
+          <a:bodyPr wrap="square" anchor="ctr">
+            <a:spAutoFit/>
+          </a:bodyPr>
+          <a:lstStyle/>
+          <a:p>
+            <a:pPr algn="l"/>
+            <a:r>
+              <a:rPr sz="1100" b="1">
+                <a:solidFill>
+                  <a:srgbClr val="FFFFFF"/>
+                </a:solidFill>
+                <a:latin typeface="Calibri"/>
+              </a:rPr>
+              <a:t>Consolidação de grupos</a:t>
+            </a:r>
+          </a:p>
+        </p:txBody>
+      </p:sp>
+      <p:sp>
+        <p:nvSpPr>
+          <p:cNvPr id="14" name="TextBox 13"/>
+          <p:cNvSpPr txBox="1"/>
+          <p:nvPr/>
+        </p:nvSpPr>
+        <p:spPr>
+          <a:xfrm>
+            <a:off x="3291840" y="2743199"/>
+            <a:ext cx="8595360" cy="694944"/>
+          </a:xfrm>
+          <a:prstGeom prst="rect">
+            <a:avLst/>
+          </a:prstGeom>
+          <a:noFill/>
+        </p:spPr>
+        <p:txBody>
+          <a:bodyPr wrap="square" anchor="ctr">
+            <a:spAutoFit/>
+          </a:bodyPr>
+          <a:lstStyle/>
+          <a:p>
+            <a:pPr algn="l"/>
+            <a:r>
+              <a:rPr sz="1050" b="0">
+                <a:solidFill>
+                  <a:srgbClr val="1A1A1A"/>
+                </a:solidFill>
+                <a:latin typeface="Calibri"/>
+              </a:rPr>
+              <a:t>De-para por CNPJ (config/conglomerados_fidc.json). Itaúna ≠ Itaú. Itaú por papel, não somável.</a:t>
+            </a:r>
+          </a:p>
+        </p:txBody>
+      </p:sp>
+      <p:sp>
+        <p:nvSpPr>
+          <p:cNvPr id="15" name="Rectangle 14"/>
+          <p:cNvSpPr/>
+          <p:nvPr/>
+        </p:nvSpPr>
+        <p:spPr>
+          <a:xfrm>
+            <a:off x="457200" y="3456431"/>
+            <a:ext cx="2651760" cy="658368"/>
+          </a:xfrm>
+          <a:prstGeom prst="rect">
+            <a:avLst/>
+          </a:prstGeom>
+          <a:solidFill>
+            <a:srgbClr val="1F2A44"/>
+          </a:solidFill>
+          <a:ln>
+            <a:noFill/>
+          </a:ln>
+          <a:effectLst/>
+        </p:spPr>
+        <p:style>
+          <a:lnRef idx="1">
+            <a:schemeClr val="accent1"/>
+          </a:lnRef>
+          <a:fillRef idx="3">
+            <a:schemeClr val="accent1"/>
+          </a:fillRef>
+          <a:effectRef idx="2">
+            <a:schemeClr val="accent1"/>
+          </a:effectRef>
+          <a:fontRef idx="minor">
+            <a:schemeClr val="lt1"/>
+          </a:fontRef>
+        </p:style>
+        <p:txBody>
+          <a:bodyPr rtlCol="0" anchor="ctr"/>
+          <a:lstStyle/>
+          <a:p>
+            <a:pPr algn="ctr"/>
+          </a:p>
+        </p:txBody>
+      </p:sp>
+      <p:sp>
+        <p:nvSpPr>
+          <p:cNvPr id="16" name="TextBox 15"/>
+          <p:cNvSpPr txBox="1"/>
+          <p:nvPr/>
+        </p:nvSpPr>
+        <p:spPr>
+          <a:xfrm>
+            <a:off x="548640" y="3474719"/>
+            <a:ext cx="2514600" cy="621792"/>
+          </a:xfrm>
+          <a:prstGeom prst="rect">
+            <a:avLst/>
+          </a:prstGeom>
+          <a:noFill/>
+        </p:spPr>
+        <p:txBody>
+          <a:bodyPr wrap="square" anchor="ctr">
+            <a:spAutoFit/>
+          </a:bodyPr>
+          <a:lstStyle/>
+          <a:p>
+            <a:pPr algn="l"/>
+            <a:r>
+              <a:rPr sz="1100" b="1">
+                <a:solidFill>
+                  <a:srgbClr val="FFFFFF"/>
+                </a:solidFill>
+                <a:latin typeface="Calibri"/>
+              </a:rPr>
+              <a:t>Originação</a:t>
+            </a:r>
+          </a:p>
+        </p:txBody>
+      </p:sp>
+      <p:sp>
+        <p:nvSpPr>
+          <p:cNvPr id="17" name="TextBox 16"/>
+          <p:cNvSpPr txBox="1"/>
+          <p:nvPr/>
+        </p:nvSpPr>
+        <p:spPr>
+          <a:xfrm>
+            <a:off x="3291840" y="3438143"/>
+            <a:ext cx="8595360" cy="694944"/>
+          </a:xfrm>
+          <a:prstGeom prst="rect">
+            <a:avLst/>
+          </a:prstGeom>
+          <a:noFill/>
+        </p:spPr>
+        <p:txBody>
+          <a:bodyPr wrap="square" anchor="ctr">
+            <a:spAutoFit/>
+          </a:bodyPr>
+          <a:lstStyle/>
+          <a:p>
+            <a:pPr algn="l"/>
+            <a:r>
+              <a:rPr sz="1050" b="0">
+                <a:solidFill>
+                  <a:srgbClr val="1A1A1A"/>
+                </a:solidFill>
+                <a:latin typeface="Calibri"/>
+              </a:rPr>
+              <a:t>Fundos por ano de 1ª oferta (1.407 de 4.219 datados). Expurga troca de mandato.</a:t>
+            </a:r>
+          </a:p>
+        </p:txBody>
+      </p:sp>
+      <p:sp>
+        <p:nvSpPr>
+          <p:cNvPr id="18" name="Rectangle 17"/>
+          <p:cNvSpPr/>
+          <p:nvPr/>
+        </p:nvSpPr>
+        <p:spPr>
+          <a:xfrm>
+            <a:off x="457200" y="4151375"/>
+            <a:ext cx="2651760" cy="658368"/>
+          </a:xfrm>
+          <a:prstGeom prst="rect">
+            <a:avLst/>
+          </a:prstGeom>
+          <a:solidFill>
+            <a:srgbClr val="1F2A44"/>
+          </a:solidFill>
+          <a:ln>
+            <a:noFill/>
+          </a:ln>
+          <a:effectLst/>
+        </p:spPr>
+        <p:style>
+          <a:lnRef idx="1">
+            <a:schemeClr val="accent1"/>
+          </a:lnRef>
+          <a:fillRef idx="3">
+            <a:schemeClr val="accent1"/>
+          </a:fillRef>
+          <a:effectRef idx="2">
+            <a:schemeClr val="accent1"/>
+          </a:effectRef>
+          <a:fontRef idx="minor">
+            <a:schemeClr val="lt1"/>
+          </a:fontRef>
+        </p:style>
+        <p:txBody>
+          <a:bodyPr rtlCol="0" anchor="ctr"/>
+          <a:lstStyle/>
+          <a:p>
+            <a:pPr algn="ctr"/>
+          </a:p>
+        </p:txBody>
+      </p:sp>
+      <p:sp>
+        <p:nvSpPr>
+          <p:cNvPr id="19" name="TextBox 18"/>
+          <p:cNvSpPr txBox="1"/>
+          <p:nvPr/>
+        </p:nvSpPr>
+        <p:spPr>
+          <a:xfrm>
+            <a:off x="548640" y="4169663"/>
+            <a:ext cx="2514600" cy="621792"/>
+          </a:xfrm>
+          <a:prstGeom prst="rect">
+            <a:avLst/>
+          </a:prstGeom>
+          <a:noFill/>
+        </p:spPr>
+        <p:txBody>
+          <a:bodyPr wrap="square" anchor="ctr">
+            <a:spAutoFit/>
+          </a:bodyPr>
+          <a:lstStyle/>
+          <a:p>
+            <a:pPr algn="l"/>
+            <a:r>
+              <a:rPr sz="1100" b="1">
+                <a:solidFill>
+                  <a:srgbClr val="FFFFFF"/>
+                </a:solidFill>
+                <a:latin typeface="Calibri"/>
+              </a:rPr>
+              <a:t>Cedentes/sacados</a:t>
+            </a:r>
+          </a:p>
+        </p:txBody>
+      </p:sp>
+      <p:sp>
+        <p:nvSpPr>
+          <p:cNvPr id="20" name="TextBox 19"/>
+          <p:cNvSpPr txBox="1"/>
+          <p:nvPr/>
+        </p:nvSpPr>
+        <p:spPr>
+          <a:xfrm>
+            <a:off x="3291840" y="4133087"/>
+            <a:ext cx="8595360" cy="694944"/>
+          </a:xfrm>
+          <a:prstGeom prst="rect">
+            <a:avLst/>
+          </a:prstGeom>
+          <a:noFill/>
+        </p:spPr>
+        <p:txBody>
+          <a:bodyPr wrap="square" anchor="ctr">
+            <a:spAutoFit/>
+          </a:bodyPr>
+          <a:lstStyle/>
+          <a:p>
+            <a:pPr algn="l"/>
+            <a:r>
+              <a:rPr sz="1050" b="0">
+                <a:solidFill>
+                  <a:srgbClr val="1A1A1A"/>
+                </a:solidFill>
+                <a:latin typeface="Calibri"/>
+              </a:rPr>
+              <a:t>Regex sobre 569 regulamentos, safra 2024–26. Amostra enviesada p/ fundos novos — não é a indústria toda.</a:t>
+            </a:r>
+          </a:p>
+        </p:txBody>
+      </p:sp>
+      <p:sp>
+        <p:nvSpPr>
+          <p:cNvPr id="21" name="Rectangle 20"/>
+          <p:cNvSpPr/>
+          <p:nvPr/>
+        </p:nvSpPr>
+        <p:spPr>
+          <a:xfrm>
+            <a:off x="457200" y="4846319"/>
+            <a:ext cx="2651760" cy="658368"/>
+          </a:xfrm>
+          <a:prstGeom prst="rect">
+            <a:avLst/>
+          </a:prstGeom>
+          <a:solidFill>
+            <a:srgbClr val="1F2A44"/>
+          </a:solidFill>
+          <a:ln>
+            <a:noFill/>
+          </a:ln>
+          <a:effectLst/>
+        </p:spPr>
+        <p:style>
+          <a:lnRef idx="1">
+            <a:schemeClr val="accent1"/>
+          </a:lnRef>
+          <a:fillRef idx="3">
+            <a:schemeClr val="accent1"/>
+          </a:fillRef>
+          <a:effectRef idx="2">
+            <a:schemeClr val="accent1"/>
+          </a:effectRef>
+          <a:fontRef idx="minor">
+            <a:schemeClr val="lt1"/>
+          </a:fontRef>
+        </p:style>
+        <p:txBody>
+          <a:bodyPr rtlCol="0" anchor="ctr"/>
+          <a:lstStyle/>
+          <a:p>
+            <a:pPr algn="ctr"/>
+          </a:p>
+        </p:txBody>
+      </p:sp>
+      <p:sp>
+        <p:nvSpPr>
+          <p:cNvPr id="22" name="TextBox 21"/>
+          <p:cNvSpPr txBox="1"/>
+          <p:nvPr/>
+        </p:nvSpPr>
+        <p:spPr>
+          <a:xfrm>
+            <a:off x="548640" y="4864607"/>
+            <a:ext cx="2514600" cy="621792"/>
+          </a:xfrm>
+          <a:prstGeom prst="rect">
+            <a:avLst/>
+          </a:prstGeom>
+          <a:noFill/>
+        </p:spPr>
+        <p:txBody>
+          <a:bodyPr wrap="square" anchor="ctr">
+            <a:spAutoFit/>
+          </a:bodyPr>
+          <a:lstStyle/>
+          <a:p>
+            <a:pPr algn="l"/>
+            <a:r>
+              <a:rPr sz="1100" b="1">
+                <a:solidFill>
+                  <a:srgbClr val="FFFFFF"/>
+                </a:solidFill>
+                <a:latin typeface="Calibri"/>
+              </a:rPr>
+              <a:t>Investidores</a:t>
+            </a:r>
+          </a:p>
+        </p:txBody>
+      </p:sp>
+      <p:sp>
+        <p:nvSpPr>
+          <p:cNvPr id="23" name="TextBox 22"/>
+          <p:cNvSpPr txBox="1"/>
+          <p:nvPr/>
+        </p:nvSpPr>
+        <p:spPr>
+          <a:xfrm>
+            <a:off x="3291840" y="4828031"/>
+            <a:ext cx="8595360" cy="694944"/>
+          </a:xfrm>
+          <a:prstGeom prst="rect">
+            <a:avLst/>
+          </a:prstGeom>
+          <a:noFill/>
+        </p:spPr>
+        <p:txBody>
+          <a:bodyPr wrap="square" anchor="ctr">
+            <a:spAutoFit/>
+          </a:bodyPr>
+          <a:lstStyle/>
+          <a:p>
+            <a:pPr algn="l"/>
+            <a:r>
+              <a:rPr sz="1050" b="0">
+                <a:solidFill>
+                  <a:srgbClr val="1A1A1A"/>
+                </a:solidFill>
+                <a:latin typeface="Calibri"/>
+              </a:rPr>
+              <a:t>Cotistas por categoria (IME Tab X_1_1). Nominal é vedado (sigilo CVM). 24% em 'Outros'.</a:t>
+            </a:r>
+          </a:p>
+        </p:txBody>
+      </p:sp>
+      <p:sp>
+        <p:nvSpPr>
+          <p:cNvPr id="24" name="Rectangle 23"/>
+          <p:cNvSpPr/>
+          <p:nvPr/>
+        </p:nvSpPr>
+        <p:spPr>
+          <a:xfrm>
+            <a:off x="457200" y="5541263"/>
+            <a:ext cx="2651760" cy="658368"/>
+          </a:xfrm>
+          <a:prstGeom prst="rect">
+            <a:avLst/>
+          </a:prstGeom>
+          <a:solidFill>
+            <a:srgbClr val="1F2A44"/>
+          </a:solidFill>
+          <a:ln>
+            <a:noFill/>
+          </a:ln>
+          <a:effectLst/>
+        </p:spPr>
+        <p:style>
+          <a:lnRef idx="1">
+            <a:schemeClr val="accent1"/>
+          </a:lnRef>
+          <a:fillRef idx="3">
+            <a:schemeClr val="accent1"/>
+          </a:fillRef>
+          <a:effectRef idx="2">
+            <a:schemeClr val="accent1"/>
+          </a:effectRef>
+          <a:fontRef idx="minor">
+            <a:schemeClr val="lt1"/>
+          </a:fontRef>
+        </p:style>
+        <p:txBody>
+          <a:bodyPr rtlCol="0" anchor="ctr"/>
+          <a:lstStyle/>
+          <a:p>
+            <a:pPr algn="ctr"/>
+          </a:p>
+        </p:txBody>
+      </p:sp>
+      <p:sp>
+        <p:nvSpPr>
+          <p:cNvPr id="25" name="TextBox 24"/>
+          <p:cNvSpPr txBox="1"/>
+          <p:nvPr/>
+        </p:nvSpPr>
+        <p:spPr>
+          <a:xfrm>
+            <a:off x="548640" y="5559551"/>
+            <a:ext cx="2514600" cy="621792"/>
+          </a:xfrm>
+          <a:prstGeom prst="rect">
+            <a:avLst/>
+          </a:prstGeom>
+          <a:noFill/>
+        </p:spPr>
+        <p:txBody>
+          <a:bodyPr wrap="square" anchor="ctr">
+            <a:spAutoFit/>
+          </a:bodyPr>
+          <a:lstStyle/>
+          <a:p>
+            <a:pPr algn="l"/>
+            <a:r>
+              <a:rPr sz="1100" b="1">
+                <a:solidFill>
+                  <a:srgbClr val="FFFFFF"/>
+                </a:solidFill>
+                <a:latin typeface="Calibri"/>
+              </a:rPr>
+              <a:t>Mercado secundário</a:t>
+            </a:r>
+          </a:p>
+        </p:txBody>
+      </p:sp>
+      <p:sp>
+        <p:nvSpPr>
+          <p:cNvPr id="26" name="TextBox 25"/>
+          <p:cNvSpPr txBox="1"/>
+          <p:nvPr/>
+        </p:nvSpPr>
+        <p:spPr>
+          <a:xfrm>
+            <a:off x="3291840" y="5522975"/>
+            <a:ext cx="8595360" cy="694944"/>
+          </a:xfrm>
+          <a:prstGeom prst="rect">
+            <a:avLst/>
+          </a:prstGeom>
+          <a:noFill/>
+        </p:spPr>
+        <p:txBody>
+          <a:bodyPr wrap="square" anchor="ctr">
+            <a:spAutoFit/>
+          </a:bodyPr>
+          <a:lstStyle/>
+          <a:p>
+            <a:pPr algn="l"/>
+            <a:r>
+              <a:rPr sz="1050" b="0">
+                <a:solidFill>
+                  <a:srgbClr val="1A1A1A"/>
+                </a:solidFill>
+                <a:latin typeface="Calibri"/>
+              </a:rPr>
+              <a:t>Sem base pública granular grátis (ANBIMA Feed/B3 DataWise pagos). Lacuna declarada — não estimada.</a:t>
+            </a:r>
+          </a:p>
+        </p:txBody>
+      </p:sp>
+      <p:sp>
+        <p:nvSpPr>
+          <p:cNvPr id="27" name="TextBox 26"/>
+          <p:cNvSpPr txBox="1"/>
+          <p:nvPr/>
+        </p:nvSpPr>
+        <p:spPr>
+          <a:xfrm>
+            <a:off x="457200" y="6309360"/>
+            <a:ext cx="11338560" cy="365760"/>
+          </a:xfrm>
+          <a:prstGeom prst="rect">
+            <a:avLst/>
+          </a:prstGeom>
+          <a:noFill/>
+        </p:spPr>
+        <p:txBody>
+          <a:bodyPr wrap="square" anchor="t">
+            <a:spAutoFit/>
+          </a:bodyPr>
+          <a:lstStyle/>
+          <a:p>
+            <a:pPr algn="l"/>
+            <a:r>
+              <a:rPr sz="900" b="0">
+                <a:solidFill>
+                  <a:srgbClr val="8A94A6"/>
+                </a:solidFill>
+                <a:latin typeface="Calibri"/>
+              </a:rPr>
+              <a:t>Detalhe completo, divergências entre fontes e checagens adversariais: docs/METODOLOGIA_E_AUDITORIA.md</a:t>
+            </a:r>
+          </a:p>
+        </p:txBody>
+      </p:sp>
     </p:spTree>
   </p:cSld>
   <p:clrMapOvr>
@@ -19163,6 +19178,1072 @@
           </a:p>
         </p:txBody>
       </p:sp>
+    </p:spTree>
+  </p:cSld>
+  <p:clrMapOvr>
+    <a:masterClrMapping/>
+  </p:clrMapOvr>
+</p:sld>
+</file>
+
+<file path=ppt/slides/slide20.xml><?xml version="1.0" encoding="utf-8"?>
+<p:sld xmlns:a="http://schemas.openxmlformats.org/drawingml/2006/main" xmlns:p="http://schemas.openxmlformats.org/presentationml/2006/main" xmlns:r="http://schemas.openxmlformats.org/officeDocument/2006/relationships">
+  <p:cSld>
+    <p:spTree>
+      <p:nvGrpSpPr>
+        <p:cNvPr id="1" name=""/>
+        <p:cNvGrpSpPr/>
+        <p:nvPr/>
+      </p:nvGrpSpPr>
+      <p:grpSpPr/>
+      <p:sp>
+        <p:nvSpPr>
+          <p:cNvPr id="2" name="Rectangle 1"/>
+          <p:cNvSpPr/>
+          <p:nvPr/>
+        </p:nvSpPr>
+        <p:spPr>
+          <a:xfrm>
+            <a:off x="0" y="0"/>
+            <a:ext cx="12191695" cy="1024128"/>
+          </a:xfrm>
+          <a:prstGeom prst="rect">
+            <a:avLst/>
+          </a:prstGeom>
+          <a:solidFill>
+            <a:srgbClr val="1F2A44"/>
+          </a:solidFill>
+          <a:ln>
+            <a:noFill/>
+          </a:ln>
+          <a:effectLst/>
+        </p:spPr>
+        <p:style>
+          <a:lnRef idx="1">
+            <a:schemeClr val="accent1"/>
+          </a:lnRef>
+          <a:fillRef idx="3">
+            <a:schemeClr val="accent1"/>
+          </a:fillRef>
+          <a:effectRef idx="2">
+            <a:schemeClr val="accent1"/>
+          </a:effectRef>
+          <a:fontRef idx="minor">
+            <a:schemeClr val="lt1"/>
+          </a:fontRef>
+        </p:style>
+        <p:txBody>
+          <a:bodyPr rtlCol="0" anchor="ctr"/>
+          <a:lstStyle/>
+          <a:p>
+            <a:pPr algn="ctr"/>
+          </a:p>
+        </p:txBody>
+      </p:sp>
+      <p:sp>
+        <p:nvSpPr>
+          <p:cNvPr id="3" name="Rectangle 2"/>
+          <p:cNvSpPr/>
+          <p:nvPr/>
+        </p:nvSpPr>
+        <p:spPr>
+          <a:xfrm>
+            <a:off x="0" y="1024128"/>
+            <a:ext cx="12191695" cy="45720"/>
+          </a:xfrm>
+          <a:prstGeom prst="rect">
+            <a:avLst/>
+          </a:prstGeom>
+          <a:solidFill>
+            <a:srgbClr val="E8703A"/>
+          </a:solidFill>
+          <a:ln>
+            <a:noFill/>
+          </a:ln>
+          <a:effectLst/>
+        </p:spPr>
+        <p:style>
+          <a:lnRef idx="1">
+            <a:schemeClr val="accent1"/>
+          </a:lnRef>
+          <a:fillRef idx="3">
+            <a:schemeClr val="accent1"/>
+          </a:fillRef>
+          <a:effectRef idx="2">
+            <a:schemeClr val="accent1"/>
+          </a:effectRef>
+          <a:fontRef idx="minor">
+            <a:schemeClr val="lt1"/>
+          </a:fontRef>
+        </p:style>
+        <p:txBody>
+          <a:bodyPr rtlCol="0" anchor="ctr"/>
+          <a:lstStyle/>
+          <a:p>
+            <a:pPr algn="ctr"/>
+          </a:p>
+        </p:txBody>
+      </p:sp>
+      <p:sp>
+        <p:nvSpPr>
+          <p:cNvPr id="4" name="TextBox 3"/>
+          <p:cNvSpPr txBox="1"/>
+          <p:nvPr/>
+        </p:nvSpPr>
+        <p:spPr>
+          <a:xfrm>
+            <a:off x="457200" y="118872"/>
+            <a:ext cx="10972800" cy="274320"/>
+          </a:xfrm>
+          <a:prstGeom prst="rect">
+            <a:avLst/>
+          </a:prstGeom>
+          <a:noFill/>
+        </p:spPr>
+        <p:txBody>
+          <a:bodyPr wrap="square" anchor="t">
+            <a:spAutoFit/>
+          </a:bodyPr>
+          <a:lstStyle/>
+          <a:p>
+            <a:pPr algn="l"/>
+            <a:r>
+              <a:rPr sz="1100" b="1">
+                <a:solidFill>
+                  <a:srgbClr val="F4A97F"/>
+                </a:solidFill>
+                <a:latin typeface="Calibri"/>
+              </a:rPr>
+              <a:t>TRANSPARÊNCIA</a:t>
+            </a:r>
+          </a:p>
+        </p:txBody>
+      </p:sp>
+      <p:sp>
+        <p:nvSpPr>
+          <p:cNvPr id="5" name="TextBox 4"/>
+          <p:cNvSpPr txBox="1"/>
+          <p:nvPr/>
+        </p:nvSpPr>
+        <p:spPr>
+          <a:xfrm>
+            <a:off x="457200" y="365760"/>
+            <a:ext cx="11338560" cy="603504"/>
+          </a:xfrm>
+          <a:prstGeom prst="rect">
+            <a:avLst/>
+          </a:prstGeom>
+          <a:noFill/>
+        </p:spPr>
+        <p:txBody>
+          <a:bodyPr wrap="square" anchor="t">
+            <a:spAutoFit/>
+          </a:bodyPr>
+          <a:lstStyle/>
+          <a:p>
+            <a:pPr algn="l"/>
+            <a:r>
+              <a:rPr sz="2200" b="1">
+                <a:solidFill>
+                  <a:srgbClr val="FFFFFF"/>
+                </a:solidFill>
+                <a:latin typeface="Calibri"/>
+              </a:rPr>
+              <a:t>Fonte exata por gráfico</a:t>
+            </a:r>
+          </a:p>
+        </p:txBody>
+      </p:sp>
+      <p:graphicFrame>
+        <p:nvGraphicFramePr>
+          <p:cNvPr id="6" name="Table 5"/>
+          <p:cNvGraphicFramePr>
+            <a:graphicFrameLocks noGrp="1"/>
+          </p:cNvGraphicFramePr>
+          <p:nvPr/>
+        </p:nvGraphicFramePr>
+        <p:xfrm>
+          <a:off x="365760" y="1280160"/>
+          <a:ext cx="11521439" cy="5029200"/>
+        </p:xfrm>
+        <a:graphic>
+          <a:graphicData uri="http://schemas.openxmlformats.org/drawingml/2006/table">
+            <a:tbl>
+              <a:tblPr firstRow="1" bandRow="1">
+                <a:tableStyleId>{5C22544A-7EE6-4342-B048-85BDC9FD1C3A}</a:tableStyleId>
+              </a:tblPr>
+              <a:tblGrid>
+                <a:gridCol w="1920239"/>
+                <a:gridCol w="9601200"/>
+              </a:tblGrid>
+              <a:tr h="279400">
+                <a:tc>
+                  <a:txBody>
+                    <a:bodyPr/>
+                    <a:lstStyle/>
+                    <a:p>
+                      <a:pPr algn="ctr"/>
+                      <a:r>
+                        <a:rPr sz="800" b="1">
+                          <a:solidFill>
+                            <a:srgbClr val="FFFFFF"/>
+                          </a:solidFill>
+                          <a:latin typeface="Calibri"/>
+                        </a:rPr>
+                        <a:t>Gráfico</a:t>
+                      </a:r>
+                    </a:p>
+                  </a:txBody>
+                  <a:tcPr anchor="ctr" marT="9144" marB="9144">
+                    <a:solidFill>
+                      <a:srgbClr val="1F2A44"/>
+                    </a:solidFill>
+                  </a:tcPr>
+                </a:tc>
+                <a:tc>
+                  <a:txBody>
+                    <a:bodyPr/>
+                    <a:lstStyle/>
+                    <a:p>
+                      <a:pPr algn="ctr"/>
+                      <a:r>
+                        <a:rPr sz="800" b="1">
+                          <a:solidFill>
+                            <a:srgbClr val="FFFFFF"/>
+                          </a:solidFill>
+                          <a:latin typeface="Calibri"/>
+                        </a:rPr>
+                        <a:t>Fonte</a:t>
+                      </a:r>
+                    </a:p>
+                  </a:txBody>
+                  <a:tcPr anchor="ctr" marT="9144" marB="9144">
+                    <a:solidFill>
+                      <a:srgbClr val="1F2A44"/>
+                    </a:solidFill>
+                  </a:tcPr>
+                </a:tc>
+              </a:tr>
+              <a:tr h="279400">
+                <a:tc>
+                  <a:txBody>
+                    <a:bodyPr/>
+                    <a:lstStyle/>
+                    <a:p>
+                      <a:pPr algn="l"/>
+                      <a:r>
+                        <a:rPr sz="800">
+                          <a:solidFill>
+                            <a:srgbClr val="1A1A1A"/>
+                          </a:solidFill>
+                          <a:latin typeface="Calibri"/>
+                        </a:rPr>
+                        <a:t>PL</a:t>
+                      </a:r>
+                    </a:p>
+                  </a:txBody>
+                  <a:tcPr anchor="ctr" marT="4572" marB="4572">
+                    <a:solidFill>
+                      <a:srgbClr val="F3F5F8"/>
+                    </a:solidFill>
+                  </a:tcPr>
+                </a:tc>
+                <a:tc>
+                  <a:txBody>
+                    <a:bodyPr/>
+                    <a:lstStyle/>
+                    <a:p>
+                      <a:pPr algn="l"/>
+                      <a:r>
+                        <a:rPr sz="800">
+                          <a:solidFill>
+                            <a:srgbClr val="1A1A1A"/>
+                          </a:solidFill>
+                          <a:latin typeface="Calibri"/>
+                        </a:rPr>
+                        <a:t>Toma Conta FIDCs — aba Indústria (série mensal, base ex-FIC-FIDC). Origem: Informe Mensal FIDC/CVM. NÃO usa o Power BI/dashboard ANBIMA (dados presos no visual).</a:t>
+                      </a:r>
+                    </a:p>
+                  </a:txBody>
+                  <a:tcPr anchor="ctr" marT="4572" marB="4572">
+                    <a:solidFill>
+                      <a:srgbClr val="F3F5F8"/>
+                    </a:solidFill>
+                  </a:tcPr>
+                </a:tc>
+              </a:tr>
+              <a:tr h="279400">
+                <a:tc>
+                  <a:txBody>
+                    <a:bodyPr/>
+                    <a:lstStyle/>
+                    <a:p>
+                      <a:pPr algn="l"/>
+                      <a:r>
+                        <a:rPr sz="800">
+                          <a:solidFill>
+                            <a:srgbClr val="1A1A1A"/>
+                          </a:solidFill>
+                          <a:latin typeface="Calibri"/>
+                        </a:rPr>
+                        <a:t>COMPOSICAO</a:t>
+                      </a:r>
+                    </a:p>
+                  </a:txBody>
+                  <a:tcPr anchor="ctr" marT="4572" marB="4572">
+                    <a:solidFill>
+                      <a:srgbClr val="FFFFFF"/>
+                    </a:solidFill>
+                  </a:tcPr>
+                </a:tc>
+                <a:tc>
+                  <a:txBody>
+                    <a:bodyPr/>
+                    <a:lstStyle/>
+                    <a:p>
+                      <a:pPr algn="l"/>
+                      <a:r>
+                        <a:rPr sz="800">
+                          <a:solidFill>
+                            <a:srgbClr val="1A1A1A"/>
+                          </a:solidFill>
+                          <a:latin typeface="Calibri"/>
+                        </a:rPr>
+                        <a:t>Toma Conta FIDCs — dimensão 'segmento' (série mensal). Taxonomia interna alinhada às classes ANBIMA. Origem: Informe Mensal FIDC/CVM.</a:t>
+                      </a:r>
+                    </a:p>
+                  </a:txBody>
+                  <a:tcPr anchor="ctr" marT="4572" marB="4572">
+                    <a:solidFill>
+                      <a:srgbClr val="FFFFFF"/>
+                    </a:solidFill>
+                  </a:tcPr>
+                </a:tc>
+              </a:tr>
+              <a:tr h="279400">
+                <a:tc>
+                  <a:txBody>
+                    <a:bodyPr/>
+                    <a:lstStyle/>
+                    <a:p>
+                      <a:pPr algn="l"/>
+                      <a:r>
+                        <a:rPr sz="800">
+                          <a:solidFill>
+                            <a:srgbClr val="1A1A1A"/>
+                          </a:solidFill>
+                          <a:latin typeface="Calibri"/>
+                        </a:rPr>
+                        <a:t>DEFINICOES</a:t>
+                      </a:r>
+                    </a:p>
+                  </a:txBody>
+                  <a:tcPr anchor="ctr" marT="4572" marB="4572">
+                    <a:solidFill>
+                      <a:srgbClr val="F3F5F8"/>
+                    </a:solidFill>
+                  </a:tcPr>
+                </a:tc>
+                <a:tc>
+                  <a:txBody>
+                    <a:bodyPr/>
+                    <a:lstStyle/>
+                    <a:p>
+                      <a:pPr algn="l"/>
+                      <a:r>
+                        <a:rPr sz="800">
+                          <a:solidFill>
+                            <a:srgbClr val="1A1A1A"/>
+                          </a:solidFill>
+                          <a:latin typeface="Calibri"/>
+                        </a:rPr>
+                        <a:t>ANBIMA — Deliberação nº 72 (Diretriz de Classificação de FIDC).</a:t>
+                      </a:r>
+                    </a:p>
+                  </a:txBody>
+                  <a:tcPr anchor="ctr" marT="4572" marB="4572">
+                    <a:solidFill>
+                      <a:srgbClr val="F3F5F8"/>
+                    </a:solidFill>
+                  </a:tcPr>
+                </a:tc>
+              </a:tr>
+              <a:tr h="279400">
+                <a:tc>
+                  <a:txBody>
+                    <a:bodyPr/>
+                    <a:lstStyle/>
+                    <a:p>
+                      <a:pPr algn="l"/>
+                      <a:r>
+                        <a:rPr sz="800">
+                          <a:solidFill>
+                            <a:srgbClr val="1A1A1A"/>
+                          </a:solidFill>
+                          <a:latin typeface="Calibri"/>
+                        </a:rPr>
+                        <a:t>GESTOR</a:t>
+                      </a:r>
+                    </a:p>
+                  </a:txBody>
+                  <a:tcPr anchor="ctr" marT="4572" marB="4572">
+                    <a:solidFill>
+                      <a:srgbClr val="FFFFFF"/>
+                    </a:solidFill>
+                  </a:tcPr>
+                </a:tc>
+                <a:tc>
+                  <a:txBody>
+                    <a:bodyPr/>
+                    <a:lstStyle/>
+                    <a:p>
+                      <a:pPr algn="l"/>
+                      <a:r>
+                        <a:rPr sz="800">
+                          <a:solidFill>
+                            <a:srgbClr val="1A1A1A"/>
+                          </a:solidFill>
+                          <a:latin typeface="Calibri"/>
+                        </a:rPr>
+                        <a:t>Toma Conta FIDCs — dimensão 'gestor', consolidado por conglomerado (de-para por CNPJ). Origem: Cadastro CVM (gestor) + Informe Mensal (PL).</a:t>
+                      </a:r>
+                    </a:p>
+                  </a:txBody>
+                  <a:tcPr anchor="ctr" marT="4572" marB="4572">
+                    <a:solidFill>
+                      <a:srgbClr val="FFFFFF"/>
+                    </a:solidFill>
+                  </a:tcPr>
+                </a:tc>
+              </a:tr>
+              <a:tr h="279400">
+                <a:tc>
+                  <a:txBody>
+                    <a:bodyPr/>
+                    <a:lstStyle/>
+                    <a:p>
+                      <a:pPr algn="l"/>
+                      <a:r>
+                        <a:rPr sz="800">
+                          <a:solidFill>
+                            <a:srgbClr val="1A1A1A"/>
+                          </a:solidFill>
+                          <a:latin typeface="Calibri"/>
+                        </a:rPr>
+                        <a:t>ADMIN</a:t>
+                      </a:r>
+                    </a:p>
+                  </a:txBody>
+                  <a:tcPr anchor="ctr" marT="4572" marB="4572">
+                    <a:solidFill>
+                      <a:srgbClr val="F3F5F8"/>
+                    </a:solidFill>
+                  </a:tcPr>
+                </a:tc>
+                <a:tc>
+                  <a:txBody>
+                    <a:bodyPr/>
+                    <a:lstStyle/>
+                    <a:p>
+                      <a:pPr algn="l"/>
+                      <a:r>
+                        <a:rPr sz="800">
+                          <a:solidFill>
+                            <a:srgbClr val="1A1A1A"/>
+                          </a:solidFill>
+                          <a:latin typeface="Calibri"/>
+                        </a:rPr>
+                        <a:t>Toma Conta FIDCs — dimensão 'administrador', consolidado por conglomerado (de-para por CNPJ). Origem: Informe Mensal FIDC/CVM.</a:t>
+                      </a:r>
+                    </a:p>
+                  </a:txBody>
+                  <a:tcPr anchor="ctr" marT="4572" marB="4572">
+                    <a:solidFill>
+                      <a:srgbClr val="F3F5F8"/>
+                    </a:solidFill>
+                  </a:tcPr>
+                </a:tc>
+              </a:tr>
+              <a:tr h="279400">
+                <a:tc>
+                  <a:txBody>
+                    <a:bodyPr/>
+                    <a:lstStyle/>
+                    <a:p>
+                      <a:pPr algn="l"/>
+                      <a:r>
+                        <a:rPr sz="800">
+                          <a:solidFill>
+                            <a:srgbClr val="1A1A1A"/>
+                          </a:solidFill>
+                          <a:latin typeface="Calibri"/>
+                        </a:rPr>
+                        <a:t>CONTROLE</a:t>
+                      </a:r>
+                    </a:p>
+                  </a:txBody>
+                  <a:tcPr anchor="ctr" marT="4572" marB="4572">
+                    <a:solidFill>
+                      <a:srgbClr val="FFFFFF"/>
+                    </a:solidFill>
+                  </a:tcPr>
+                </a:tc>
+                <a:tc>
+                  <a:txBody>
+                    <a:bodyPr/>
+                    <a:lstStyle/>
+                    <a:p>
+                      <a:pPr algn="l"/>
+                      <a:r>
+                        <a:rPr sz="800">
+                          <a:solidFill>
+                            <a:srgbClr val="1A1A1A"/>
+                          </a:solidFill>
+                          <a:latin typeface="Calibri"/>
+                        </a:rPr>
+                        <a:t>Toma Conta FIDCs — dimensão 'gestor' + taxonomia de controle (Ligada a banco / Independente Grande / Independente; definição do rodapé do deck Itaú BBA).</a:t>
+                      </a:r>
+                    </a:p>
+                  </a:txBody>
+                  <a:tcPr anchor="ctr" marT="4572" marB="4572">
+                    <a:solidFill>
+                      <a:srgbClr val="FFFFFF"/>
+                    </a:solidFill>
+                  </a:tcPr>
+                </a:tc>
+              </a:tr>
+              <a:tr h="279400">
+                <a:tc>
+                  <a:txBody>
+                    <a:bodyPr/>
+                    <a:lstStyle/>
+                    <a:p>
+                      <a:pPr algn="l"/>
+                      <a:r>
+                        <a:rPr sz="800">
+                          <a:solidFill>
+                            <a:srgbClr val="1A1A1A"/>
+                          </a:solidFill>
+                          <a:latin typeface="Calibri"/>
+                        </a:rPr>
+                        <a:t>DEPARA</a:t>
+                      </a:r>
+                    </a:p>
+                  </a:txBody>
+                  <a:tcPr anchor="ctr" marT="4572" marB="4572">
+                    <a:solidFill>
+                      <a:srgbClr val="F3F5F8"/>
+                    </a:solidFill>
+                  </a:tcPr>
+                </a:tc>
+                <a:tc>
+                  <a:txBody>
+                    <a:bodyPr/>
+                    <a:lstStyle/>
+                    <a:p>
+                      <a:pPr algn="l"/>
+                      <a:r>
+                        <a:rPr sz="800">
+                          <a:solidFill>
+                            <a:srgbClr val="1A1A1A"/>
+                          </a:solidFill>
+                          <a:latin typeface="Calibri"/>
+                        </a:rPr>
+                        <a:t>De-para próprio, verificado por CNPJ contra industry_fund_snapshot (mai/2026). Config: config/conglomerados_fidc.json.</a:t>
+                      </a:r>
+                    </a:p>
+                  </a:txBody>
+                  <a:tcPr anchor="ctr" marT="4572" marB="4572">
+                    <a:solidFill>
+                      <a:srgbClr val="F3F5F8"/>
+                    </a:solidFill>
+                  </a:tcPr>
+                </a:tc>
+              </a:tr>
+              <a:tr h="279400">
+                <a:tc>
+                  <a:txBody>
+                    <a:bodyPr/>
+                    <a:lstStyle/>
+                    <a:p>
+                      <a:pPr algn="l"/>
+                      <a:r>
+                        <a:rPr sz="800">
+                          <a:solidFill>
+                            <a:srgbClr val="1A1A1A"/>
+                          </a:solidFill>
+                          <a:latin typeface="Calibri"/>
+                        </a:rPr>
+                        <a:t>TOP25</a:t>
+                      </a:r>
+                    </a:p>
+                  </a:txBody>
+                  <a:tcPr anchor="ctr" marT="4572" marB="4572">
+                    <a:solidFill>
+                      <a:srgbClr val="FFFFFF"/>
+                    </a:solidFill>
+                  </a:tcPr>
+                </a:tc>
+                <a:tc>
+                  <a:txBody>
+                    <a:bodyPr/>
+                    <a:lstStyle/>
+                    <a:p>
+                      <a:pPr algn="l"/>
+                      <a:r>
+                        <a:rPr sz="800">
+                          <a:solidFill>
+                            <a:srgbClr val="1A1A1A"/>
+                          </a:solidFill>
+                          <a:latin typeface="Calibri"/>
+                        </a:rPr>
+                        <a:t>Toma Conta FIDCs — snapshot por fundo (PL, gestor consolidado, leituras de segmento/oferta/subordinação quando há regulamento parseado). Origem: Informe Mensal FIDC/CVM + leituras regulatórias do Toma Conta.</a:t>
+                      </a:r>
+                    </a:p>
+                  </a:txBody>
+                  <a:tcPr anchor="ctr" marT="4572" marB="4572">
+                    <a:solidFill>
+                      <a:srgbClr val="FFFFFF"/>
+                    </a:solidFill>
+                  </a:tcPr>
+                </a:tc>
+              </a:tr>
+              <a:tr h="279400">
+                <a:tc>
+                  <a:txBody>
+                    <a:bodyPr/>
+                    <a:lstStyle/>
+                    <a:p>
+                      <a:pPr algn="l"/>
+                      <a:r>
+                        <a:rPr sz="800">
+                          <a:solidFill>
+                            <a:srgbClr val="1A1A1A"/>
+                          </a:solidFill>
+                          <a:latin typeface="Calibri"/>
+                        </a:rPr>
+                        <a:t>COTISTAS</a:t>
+                      </a:r>
+                    </a:p>
+                  </a:txBody>
+                  <a:tcPr anchor="ctr" marT="4572" marB="4572">
+                    <a:solidFill>
+                      <a:srgbClr val="F3F5F8"/>
+                    </a:solidFill>
+                  </a:tcPr>
+                </a:tc>
+                <a:tc>
+                  <a:txBody>
+                    <a:bodyPr/>
+                    <a:lstStyle/>
+                    <a:p>
+                      <a:pPr algn="l"/>
+                      <a:r>
+                        <a:rPr sz="800">
+                          <a:solidFill>
+                            <a:srgbClr val="1A1A1A"/>
+                          </a:solidFill>
+                          <a:latin typeface="Calibri"/>
+                        </a:rPr>
+                        <a:t>Informe Mensal FIDC/CVM — Tabela X (nº de cotistas) via Toma Conta. Filtro PL &gt; R$ 200 mi.</a:t>
+                      </a:r>
+                    </a:p>
+                  </a:txBody>
+                  <a:tcPr anchor="ctr" marT="4572" marB="4572">
+                    <a:solidFill>
+                      <a:srgbClr val="F3F5F8"/>
+                    </a:solidFill>
+                  </a:tcPr>
+                </a:tc>
+              </a:tr>
+              <a:tr h="279400">
+                <a:tc>
+                  <a:txBody>
+                    <a:bodyPr/>
+                    <a:lstStyle/>
+                    <a:p>
+                      <a:pPr algn="l"/>
+                      <a:r>
+                        <a:rPr sz="800">
+                          <a:solidFill>
+                            <a:srgbClr val="1A1A1A"/>
+                          </a:solidFill>
+                          <a:latin typeface="Calibri"/>
+                        </a:rPr>
+                        <a:t>INVESTIDOR</a:t>
+                      </a:r>
+                    </a:p>
+                  </a:txBody>
+                  <a:tcPr anchor="ctr" marT="4572" marB="4572">
+                    <a:solidFill>
+                      <a:srgbClr val="FFFFFF"/>
+                    </a:solidFill>
+                  </a:tcPr>
+                </a:tc>
+                <a:tc>
+                  <a:txBody>
+                    <a:bodyPr/>
+                    <a:lstStyle/>
+                    <a:p>
+                      <a:pPr algn="l"/>
+                      <a:r>
+                        <a:rPr sz="800">
+                          <a:solidFill>
+                            <a:srgbClr val="1A1A1A"/>
+                          </a:solidFill>
+                          <a:latin typeface="Calibri"/>
+                        </a:rPr>
+                        <a:t>Informe Mensal FIDC/CVM — nº de cotistas por segmento de investidor, via Toma Conta.</a:t>
+                      </a:r>
+                    </a:p>
+                  </a:txBody>
+                  <a:tcPr anchor="ctr" marT="4572" marB="4572">
+                    <a:solidFill>
+                      <a:srgbClr val="FFFFFF"/>
+                    </a:solidFill>
+                  </a:tcPr>
+                </a:tc>
+              </a:tr>
+              <a:tr h="279400">
+                <a:tc>
+                  <a:txBody>
+                    <a:bodyPr/>
+                    <a:lstStyle/>
+                    <a:p>
+                      <a:pPr algn="l"/>
+                      <a:r>
+                        <a:rPr sz="800">
+                          <a:solidFill>
+                            <a:srgbClr val="1A1A1A"/>
+                          </a:solidFill>
+                          <a:latin typeface="Calibri"/>
+                        </a:rPr>
+                        <a:t>EMISSOES</a:t>
+                      </a:r>
+                    </a:p>
+                  </a:txBody>
+                  <a:tcPr anchor="ctr" marT="4572" marB="4572">
+                    <a:solidFill>
+                      <a:srgbClr val="F3F5F8"/>
+                    </a:solidFill>
+                  </a:tcPr>
+                </a:tc>
+                <a:tc>
+                  <a:txBody>
+                    <a:bodyPr/>
+                    <a:lstStyle/>
+                    <a:p>
+                      <a:pPr algn="l"/>
+                      <a:r>
+                        <a:rPr sz="800">
+                          <a:solidFill>
+                            <a:srgbClr val="1A1A1A"/>
+                          </a:solidFill>
+                          <a:latin typeface="Calibri"/>
+                        </a:rPr>
+                        <a:t>Toma Conta FIDCs — variação anual de PL (ex-FIC) e captação líquida (dimensão mensal). Métrica preferida: variação de PL. Validação de magnitude: ANBIMA (imprensa, 2024). NÃO é o campo 'emissões encerradas'.</a:t>
+                      </a:r>
+                    </a:p>
+                  </a:txBody>
+                  <a:tcPr anchor="ctr" marT="4572" marB="4572">
+                    <a:solidFill>
+                      <a:srgbClr val="F3F5F8"/>
+                    </a:solidFill>
+                  </a:tcPr>
+                </a:tc>
+              </a:tr>
+              <a:tr h="279400">
+                <a:tc>
+                  <a:txBody>
+                    <a:bodyPr/>
+                    <a:lstStyle/>
+                    <a:p>
+                      <a:pPr algn="l"/>
+                      <a:r>
+                        <a:rPr sz="800">
+                          <a:solidFill>
+                            <a:srgbClr val="1A1A1A"/>
+                          </a:solidFill>
+                          <a:latin typeface="Calibri"/>
+                        </a:rPr>
+                        <a:t>PARTES</a:t>
+                      </a:r>
+                    </a:p>
+                  </a:txBody>
+                  <a:tcPr anchor="ctr" marT="4572" marB="4572">
+                    <a:solidFill>
+                      <a:srgbClr val="FFFFFF"/>
+                    </a:solidFill>
+                  </a:tcPr>
+                </a:tc>
+                <a:tc>
+                  <a:txBody>
+                    <a:bodyPr/>
+                    <a:lstStyle/>
+                    <a:p>
+                      <a:pPr algn="l"/>
+                      <a:r>
+                        <a:rPr sz="800">
+                          <a:solidFill>
+                            <a:srgbClr val="1A1A1A"/>
+                          </a:solidFill>
+                          <a:latin typeface="Calibri"/>
+                        </a:rPr>
+                        <a:t>Toma Conta FIDCs — leitura de regulamentos (cedentes/sacados nomeados, materialidade por PL de fundo). Base: reports/fidc_clean_named_parties.</a:t>
+                      </a:r>
+                    </a:p>
+                  </a:txBody>
+                  <a:tcPr anchor="ctr" marT="4572" marB="4572">
+                    <a:solidFill>
+                      <a:srgbClr val="FFFFFF"/>
+                    </a:solidFill>
+                  </a:tcPr>
+                </a:tc>
+              </a:tr>
+              <a:tr h="279400">
+                <a:tc>
+                  <a:txBody>
+                    <a:bodyPr/>
+                    <a:lstStyle/>
+                    <a:p>
+                      <a:pPr algn="l"/>
+                      <a:r>
+                        <a:rPr sz="800">
+                          <a:solidFill>
+                            <a:srgbClr val="1A1A1A"/>
+                          </a:solidFill>
+                          <a:latin typeface="Calibri"/>
+                        </a:rPr>
+                        <a:t>SUMARIO</a:t>
+                      </a:r>
+                    </a:p>
+                  </a:txBody>
+                  <a:tcPr anchor="ctr" marT="4572" marB="4572">
+                    <a:solidFill>
+                      <a:srgbClr val="F3F5F8"/>
+                    </a:solidFill>
+                  </a:tcPr>
+                </a:tc>
+                <a:tc>
+                  <a:txBody>
+                    <a:bodyPr/>
+                    <a:lstStyle/>
+                    <a:p>
+                      <a:pPr algn="l"/>
+                      <a:r>
+                        <a:rPr sz="800">
+                          <a:solidFill>
+                            <a:srgbClr val="1A1A1A"/>
+                          </a:solidFill>
+                          <a:latin typeface="Calibri"/>
+                        </a:rPr>
+                        <a:t>Síntese das dimensões do Toma Conta (gestor/admin/custodiante/segmento) consolidadas por conglomerado.</a:t>
+                      </a:r>
+                    </a:p>
+                  </a:txBody>
+                  <a:tcPr anchor="ctr" marT="4572" marB="4572">
+                    <a:solidFill>
+                      <a:srgbClr val="F3F5F8"/>
+                    </a:solidFill>
+                  </a:tcPr>
+                </a:tc>
+              </a:tr>
+              <a:tr h="279400">
+                <a:tc>
+                  <a:txBody>
+                    <a:bodyPr/>
+                    <a:lstStyle/>
+                    <a:p>
+                      <a:pPr algn="l"/>
+                      <a:r>
+                        <a:rPr sz="800">
+                          <a:solidFill>
+                            <a:srgbClr val="1A1A1A"/>
+                          </a:solidFill>
+                          <a:latin typeface="Calibri"/>
+                        </a:rPr>
+                        <a:t>DELTA_PAPEL</a:t>
+                      </a:r>
+                    </a:p>
+                  </a:txBody>
+                  <a:tcPr anchor="ctr" marT="4572" marB="4572">
+                    <a:solidFill>
+                      <a:srgbClr val="FFFFFF"/>
+                    </a:solidFill>
+                  </a:tcPr>
+                </a:tc>
+                <a:tc>
+                  <a:txBody>
+                    <a:bodyPr/>
+                    <a:lstStyle/>
+                    <a:p>
+                      <a:pPr algn="l"/>
+                      <a:r>
+                        <a:rPr sz="800">
+                          <a:solidFill>
+                            <a:srgbClr val="1A1A1A"/>
+                          </a:solidFill>
+                          <a:latin typeface="Calibri"/>
+                        </a:rPr>
+                        <a:t>Toma Conta FIDCs — dimensão mensal por papel, consolidada por CNPJ. Share = PL do grupo / PL total do papel na competência. Δrank = posição em dez/2023 menos posição em mai/2026. PL de estoque (inclui troca de mandato).</a:t>
+                      </a:r>
+                    </a:p>
+                  </a:txBody>
+                  <a:tcPr anchor="ctr" marT="4572" marB="4572">
+                    <a:solidFill>
+                      <a:srgbClr val="FFFFFF"/>
+                    </a:solidFill>
+                  </a:tcPr>
+                </a:tc>
+              </a:tr>
+              <a:tr h="279400">
+                <a:tc>
+                  <a:txBody>
+                    <a:bodyPr/>
+                    <a:lstStyle/>
+                    <a:p>
+                      <a:pPr algn="l"/>
+                      <a:r>
+                        <a:rPr sz="800">
+                          <a:solidFill>
+                            <a:srgbClr val="1A1A1A"/>
+                          </a:solidFill>
+                          <a:latin typeface="Calibri"/>
+                        </a:rPr>
+                        <a:t>ORIGINACAO</a:t>
+                      </a:r>
+                    </a:p>
+                  </a:txBody>
+                  <a:tcPr anchor="ctr" marT="4572" marB="4572">
+                    <a:solidFill>
+                      <a:srgbClr val="F3F5F8"/>
+                    </a:solidFill>
+                  </a:tcPr>
+                </a:tc>
+                <a:tc>
+                  <a:txBody>
+                    <a:bodyPr/>
+                    <a:lstStyle/>
+                    <a:p>
+                      <a:pPr algn="l"/>
+                      <a:r>
+                        <a:rPr sz="800">
+                          <a:solidFill>
+                            <a:srgbClr val="1A1A1A"/>
+                          </a:solidFill>
+                          <a:latin typeface="Calibri"/>
+                        </a:rPr>
+                        <a:t>Toma Conta FIDCs — fundos por ANO DE 1ª OFERTA (snapshot: first_offer_year). Mede ORIGINAÇÃO (fundo novo), expurgando troca de gestor/adm de fundos já existentes. Cobertura de 1ª oferta: 1.407 de 4.219 fundos.</a:t>
+                      </a:r>
+                    </a:p>
+                  </a:txBody>
+                  <a:tcPr anchor="ctr" marT="4572" marB="4572">
+                    <a:solidFill>
+                      <a:srgbClr val="F3F5F8"/>
+                    </a:solidFill>
+                  </a:tcPr>
+                </a:tc>
+              </a:tr>
+              <a:tr h="279400">
+                <a:tc>
+                  <a:txBody>
+                    <a:bodyPr/>
+                    <a:lstStyle/>
+                    <a:p>
+                      <a:pPr algn="l"/>
+                      <a:r>
+                        <a:rPr sz="800">
+                          <a:solidFill>
+                            <a:srgbClr val="1A1A1A"/>
+                          </a:solidFill>
+                          <a:latin typeface="Calibri"/>
+                        </a:rPr>
+                        <a:t>CAPTACAO</a:t>
+                      </a:r>
+                    </a:p>
+                  </a:txBody>
+                  <a:tcPr anchor="ctr" marT="4572" marB="4572">
+                    <a:solidFill>
+                      <a:srgbClr val="FFFFFF"/>
+                    </a:solidFill>
+                  </a:tcPr>
+                </a:tc>
+                <a:tc>
+                  <a:txBody>
+                    <a:bodyPr/>
+                    <a:lstStyle/>
+                    <a:p>
+                      <a:pPr algn="l"/>
+                      <a:r>
+                        <a:rPr sz="800">
+                          <a:solidFill>
+                            <a:srgbClr val="1A1A1A"/>
+                          </a:solidFill>
+                          <a:latin typeface="Calibri"/>
+                        </a:rPr>
+                        <a:t>Toma Conta FIDCs — captação líquida = captações − resgates no mês (Informe Mensal FIDC/CVM), somada por ano. Complementa a variação de PL.</a:t>
+                      </a:r>
+                    </a:p>
+                  </a:txBody>
+                  <a:tcPr anchor="ctr" marT="4572" marB="4572">
+                    <a:solidFill>
+                      <a:srgbClr val="FFFFFF"/>
+                    </a:solidFill>
+                  </a:tcPr>
+                </a:tc>
+              </a:tr>
+              <a:tr h="279400">
+                <a:tc>
+                  <a:txBody>
+                    <a:bodyPr/>
+                    <a:lstStyle/>
+                    <a:p>
+                      <a:pPr algn="l"/>
+                      <a:r>
+                        <a:rPr sz="800">
+                          <a:solidFill>
+                            <a:srgbClr val="1A1A1A"/>
+                          </a:solidFill>
+                          <a:latin typeface="Calibri"/>
+                        </a:rPr>
+                        <a:t>TOP25DET</a:t>
+                      </a:r>
+                    </a:p>
+                  </a:txBody>
+                  <a:tcPr anchor="ctr" marT="4572" marB="4572">
+                    <a:solidFill>
+                      <a:srgbClr val="F3F5F8"/>
+                    </a:solidFill>
+                  </a:tcPr>
+                </a:tc>
+                <a:tc>
+                  <a:txBody>
+                    <a:bodyPr/>
+                    <a:lstStyle/>
+                    <a:p>
+                      <a:pPr algn="l"/>
+                      <a:r>
+                        <a:rPr sz="800">
+                          <a:solidFill>
+                            <a:srgbClr val="1A1A1A"/>
+                          </a:solidFill>
+                          <a:latin typeface="Calibri"/>
+                        </a:rPr>
+                        <a:t>Informe Mensal Estruturado (CVM), mai/2026 + leituras de regulamento (Toma Conta). Subordinação = PL classe subordinada / PL total (Tab X_2). Cedente = TAB_I2A12 (até 9, com %). Cotistas por investidor = Tab X_1_1.</a:t>
+                      </a:r>
+                    </a:p>
+                  </a:txBody>
+                  <a:tcPr anchor="ctr" marT="4572" marB="4572">
+                    <a:solidFill>
+                      <a:srgbClr val="F3F5F8"/>
+                    </a:solidFill>
+                  </a:tcPr>
+                </a:tc>
+              </a:tr>
+            </a:tbl>
+          </a:graphicData>
+        </a:graphic>
+      </p:graphicFrame>
     </p:spTree>
   </p:cSld>
   <p:clrMapOvr>
@@ -22938,8 +24019,8 @@
         </p:nvSpPr>
         <p:spPr>
           <a:xfrm>
-            <a:off x="457200" y="5943600"/>
-            <a:ext cx="11338560" cy="457200"/>
+            <a:off x="457200" y="5897880"/>
+            <a:ext cx="11338560" cy="502920"/>
           </a:xfrm>
           <a:prstGeom prst="rect">
             <a:avLst/>
@@ -22960,7 +24041,7 @@
                 </a:solidFill>
                 <a:latin typeface="Calibri"/>
               </a:rPr>
-              <a:t>▲ Ganhou share: Itau (+1.9 pp)    ▼ Perdeu: Banco do Brasil (-3.1 pp)</a:t>
+              <a:t>▲ Ganhou share: Itau (+1.9 pp · +26 fundos)    ▼ Perdeu: Banco do Brasil (-3.1 pp)</a:t>
             </a:r>
           </a:p>
         </p:txBody>
@@ -25076,8 +26157,8 @@
         </p:nvSpPr>
         <p:spPr>
           <a:xfrm>
-            <a:off x="457200" y="5943600"/>
-            <a:ext cx="11338560" cy="457200"/>
+            <a:off x="457200" y="5897880"/>
+            <a:ext cx="11338560" cy="502920"/>
           </a:xfrm>
           <a:prstGeom prst="rect">
             <a:avLst/>
@@ -25098,7 +26179,7 @@
                 </a:solidFill>
                 <a:latin typeface="Calibri"/>
               </a:rPr>
-              <a:t>▲ Ganhou share: BTG Pactual (+3.1 pp)    ▼ Perdeu: Banco do Brasil (-3.1 pp)</a:t>
+              <a:t>▲ Ganhou share: BTG Pactual (+3.1 pp · +307 fundos)    ▼ Perdeu: Banco do Brasil (-3.1 pp)</a:t>
             </a:r>
           </a:p>
         </p:txBody>
@@ -27214,8 +28295,8 @@
         </p:nvSpPr>
         <p:spPr>
           <a:xfrm>
-            <a:off x="457200" y="5943600"/>
-            <a:ext cx="11338560" cy="457200"/>
+            <a:off x="457200" y="5897880"/>
+            <a:ext cx="11338560" cy="502920"/>
           </a:xfrm>
           <a:prstGeom prst="rect">
             <a:avLst/>
@@ -27236,7 +28317,7 @@
                 </a:solidFill>
                 <a:latin typeface="Calibri"/>
               </a:rPr>
-              <a:t>▲ Ganhou share: BTG Pactual (+3.0 pp)    ▼ Perdeu: BANCO DO BRASIL S.A. (-3.1 pp)</a:t>
+              <a:t>▲ Ganhou share: BTG Pactual (+3.0 pp · +307 fundos)    ▼ Perdeu: BANCO DO BRASIL S.A. (-3.1 pp)</a:t>
             </a:r>
           </a:p>
         </p:txBody>

</xml_diff>